<commit_message>
Polish October 19 circle lesson exports
</commit_message>
<xml_diff>
--- a/slides/math130-quiz8-readiness-2026-10-19.pptx
+++ b/slides/math130-quiz8-readiness-2026-10-19.pptx
@@ -2,43 +2,43 @@
 <file path=ppt/presentation.xml><?xml version="1.0" encoding="utf-8"?>
 <p:presentation xmlns:p="http://schemas.openxmlformats.org/presentationml/2006/main">
   <p:sldMasterIdLst>
-    <p:sldMasterId xmlns:r="http://schemas.openxmlformats.org/officeDocument/2006/relationships" id="2147483648" r:id="R7d5b927660804b6b"/>
+    <p:sldMasterId xmlns:r="http://schemas.openxmlformats.org/officeDocument/2006/relationships" id="2147483648" r:id="R1df9f034349d47c2"/>
   </p:sldMasterIdLst>
   <p:notesMasterIdLst>
-    <p:notesMasterId xmlns:r="http://schemas.openxmlformats.org/officeDocument/2006/relationships" r:id="R772cb91b19554314"/>
+    <p:notesMasterId xmlns:r="http://schemas.openxmlformats.org/officeDocument/2006/relationships" r:id="Rf0e62f3c91d94903"/>
   </p:notesMasterIdLst>
   <p:sldIdLst>
-    <p:sldId xmlns:r="http://schemas.openxmlformats.org/officeDocument/2006/relationships" id="256" r:id="R0000183b2dae4c4a"/>
-    <p:sldId xmlns:r="http://schemas.openxmlformats.org/officeDocument/2006/relationships" id="257" r:id="R29282e22e55a491d"/>
-    <p:sldId xmlns:r="http://schemas.openxmlformats.org/officeDocument/2006/relationships" id="258" r:id="R30fb1f0f132c43e4"/>
-    <p:sldId xmlns:r="http://schemas.openxmlformats.org/officeDocument/2006/relationships" id="259" r:id="Rc240e55e667e47d5"/>
-    <p:sldId xmlns:r="http://schemas.openxmlformats.org/officeDocument/2006/relationships" id="260" r:id="Re95a92c542e54a08"/>
-    <p:sldId xmlns:r="http://schemas.openxmlformats.org/officeDocument/2006/relationships" id="261" r:id="R935c7fce993d4366"/>
-    <p:sldId xmlns:r="http://schemas.openxmlformats.org/officeDocument/2006/relationships" id="262" r:id="R0aaa87425a144fdd"/>
-    <p:sldId xmlns:r="http://schemas.openxmlformats.org/officeDocument/2006/relationships" id="263" r:id="R372c65666ab448bb"/>
-    <p:sldId xmlns:r="http://schemas.openxmlformats.org/officeDocument/2006/relationships" id="264" r:id="R1bd04c8f5f26425b"/>
-    <p:sldId xmlns:r="http://schemas.openxmlformats.org/officeDocument/2006/relationships" id="265" r:id="R9224b2248d2744b1"/>
-    <p:sldId xmlns:r="http://schemas.openxmlformats.org/officeDocument/2006/relationships" id="266" r:id="R2d49751648c54143"/>
-    <p:sldId xmlns:r="http://schemas.openxmlformats.org/officeDocument/2006/relationships" id="267" r:id="R468dc6b0bec04796"/>
-    <p:sldId xmlns:r="http://schemas.openxmlformats.org/officeDocument/2006/relationships" id="268" r:id="R21d8ef8588a04f70"/>
-    <p:sldId xmlns:r="http://schemas.openxmlformats.org/officeDocument/2006/relationships" id="269" r:id="Rc6bc728fbd114b5b"/>
-    <p:sldId xmlns:r="http://schemas.openxmlformats.org/officeDocument/2006/relationships" id="270" r:id="R92839c6eb1e542b0"/>
-    <p:sldId xmlns:r="http://schemas.openxmlformats.org/officeDocument/2006/relationships" id="271" r:id="Rbdc9d3462137465b"/>
-    <p:sldId xmlns:r="http://schemas.openxmlformats.org/officeDocument/2006/relationships" id="272" r:id="Rf566f4e54c2f494e"/>
-    <p:sldId xmlns:r="http://schemas.openxmlformats.org/officeDocument/2006/relationships" id="273" r:id="Ra99a9387f07c486b"/>
-    <p:sldId xmlns:r="http://schemas.openxmlformats.org/officeDocument/2006/relationships" id="274" r:id="Rbb193534ea964a56"/>
-    <p:sldId xmlns:r="http://schemas.openxmlformats.org/officeDocument/2006/relationships" id="275" r:id="R3bb6c76eab2a423b"/>
-    <p:sldId xmlns:r="http://schemas.openxmlformats.org/officeDocument/2006/relationships" id="276" r:id="Ref15933bce0f4e2e"/>
-    <p:sldId xmlns:r="http://schemas.openxmlformats.org/officeDocument/2006/relationships" id="277" r:id="Rc8395b12a36e41cb"/>
-    <p:sldId xmlns:r="http://schemas.openxmlformats.org/officeDocument/2006/relationships" id="278" r:id="R5a914df80c574a83"/>
-    <p:sldId xmlns:r="http://schemas.openxmlformats.org/officeDocument/2006/relationships" id="279" r:id="R3da0c01ed64d4844"/>
-    <p:sldId xmlns:r="http://schemas.openxmlformats.org/officeDocument/2006/relationships" id="280" r:id="R56cb0ab4a70145c2"/>
-    <p:sldId xmlns:r="http://schemas.openxmlformats.org/officeDocument/2006/relationships" id="281" r:id="R470930d941ea49f1"/>
-    <p:sldId xmlns:r="http://schemas.openxmlformats.org/officeDocument/2006/relationships" id="282" r:id="Rd2b02df8a9b945db"/>
-    <p:sldId xmlns:r="http://schemas.openxmlformats.org/officeDocument/2006/relationships" id="283" r:id="Rfb3df201fb17421c"/>
-    <p:sldId xmlns:r="http://schemas.openxmlformats.org/officeDocument/2006/relationships" id="284" r:id="R162bfb05b0b24584"/>
-    <p:sldId xmlns:r="http://schemas.openxmlformats.org/officeDocument/2006/relationships" id="285" r:id="R4e00149fd9274c0a"/>
-    <p:sldId xmlns:r="http://schemas.openxmlformats.org/officeDocument/2006/relationships" id="286" r:id="Ra2c12947f42741dc"/>
+    <p:sldId xmlns:r="http://schemas.openxmlformats.org/officeDocument/2006/relationships" id="256" r:id="Raa1fc00300d4418a"/>
+    <p:sldId xmlns:r="http://schemas.openxmlformats.org/officeDocument/2006/relationships" id="257" r:id="Reac9609fb14d461f"/>
+    <p:sldId xmlns:r="http://schemas.openxmlformats.org/officeDocument/2006/relationships" id="258" r:id="R488cd9e64cd74fca"/>
+    <p:sldId xmlns:r="http://schemas.openxmlformats.org/officeDocument/2006/relationships" id="259" r:id="R071e031a5bb24e1f"/>
+    <p:sldId xmlns:r="http://schemas.openxmlformats.org/officeDocument/2006/relationships" id="260" r:id="R34f39ada016844d8"/>
+    <p:sldId xmlns:r="http://schemas.openxmlformats.org/officeDocument/2006/relationships" id="261" r:id="R5981bfab1ebd42a2"/>
+    <p:sldId xmlns:r="http://schemas.openxmlformats.org/officeDocument/2006/relationships" id="262" r:id="Rc50e84527f0f459c"/>
+    <p:sldId xmlns:r="http://schemas.openxmlformats.org/officeDocument/2006/relationships" id="263" r:id="Rb32fed3896bb4f4f"/>
+    <p:sldId xmlns:r="http://schemas.openxmlformats.org/officeDocument/2006/relationships" id="264" r:id="R7de10806ab984df9"/>
+    <p:sldId xmlns:r="http://schemas.openxmlformats.org/officeDocument/2006/relationships" id="265" r:id="R69d796dd98e14d9d"/>
+    <p:sldId xmlns:r="http://schemas.openxmlformats.org/officeDocument/2006/relationships" id="266" r:id="Rfdc72e3a84164c4d"/>
+    <p:sldId xmlns:r="http://schemas.openxmlformats.org/officeDocument/2006/relationships" id="267" r:id="R2390f7548caa4ef8"/>
+    <p:sldId xmlns:r="http://schemas.openxmlformats.org/officeDocument/2006/relationships" id="268" r:id="R6cfe2f28867943ce"/>
+    <p:sldId xmlns:r="http://schemas.openxmlformats.org/officeDocument/2006/relationships" id="269" r:id="R4e26d6f97f904642"/>
+    <p:sldId xmlns:r="http://schemas.openxmlformats.org/officeDocument/2006/relationships" id="270" r:id="Ra54c927fa1674427"/>
+    <p:sldId xmlns:r="http://schemas.openxmlformats.org/officeDocument/2006/relationships" id="271" r:id="R61466d65b22e464c"/>
+    <p:sldId xmlns:r="http://schemas.openxmlformats.org/officeDocument/2006/relationships" id="272" r:id="Ra3b933bd1f3f4439"/>
+    <p:sldId xmlns:r="http://schemas.openxmlformats.org/officeDocument/2006/relationships" id="273" r:id="R27c0cc899ae34fa5"/>
+    <p:sldId xmlns:r="http://schemas.openxmlformats.org/officeDocument/2006/relationships" id="274" r:id="R61c5be96d1c3423b"/>
+    <p:sldId xmlns:r="http://schemas.openxmlformats.org/officeDocument/2006/relationships" id="275" r:id="Re0103bd5f23a4f2f"/>
+    <p:sldId xmlns:r="http://schemas.openxmlformats.org/officeDocument/2006/relationships" id="276" r:id="R037d74fe58774bd8"/>
+    <p:sldId xmlns:r="http://schemas.openxmlformats.org/officeDocument/2006/relationships" id="277" r:id="R9d5c516d38af4d20"/>
+    <p:sldId xmlns:r="http://schemas.openxmlformats.org/officeDocument/2006/relationships" id="278" r:id="R3847fa6203b84a8e"/>
+    <p:sldId xmlns:r="http://schemas.openxmlformats.org/officeDocument/2006/relationships" id="279" r:id="Ra2b14aa16ea8435b"/>
+    <p:sldId xmlns:r="http://schemas.openxmlformats.org/officeDocument/2006/relationships" id="280" r:id="Rbdcd4f70ab2e4df2"/>
+    <p:sldId xmlns:r="http://schemas.openxmlformats.org/officeDocument/2006/relationships" id="281" r:id="Rf8b75fc37d3548ed"/>
+    <p:sldId xmlns:r="http://schemas.openxmlformats.org/officeDocument/2006/relationships" id="282" r:id="R70043fe00b51441d"/>
+    <p:sldId xmlns:r="http://schemas.openxmlformats.org/officeDocument/2006/relationships" id="283" r:id="Rf9220c4216a44759"/>
+    <p:sldId xmlns:r="http://schemas.openxmlformats.org/officeDocument/2006/relationships" id="284" r:id="R6a272eecaf8b4c90"/>
+    <p:sldId xmlns:r="http://schemas.openxmlformats.org/officeDocument/2006/relationships" id="285" r:id="R1fe50b059871453a"/>
+    <p:sldId xmlns:r="http://schemas.openxmlformats.org/officeDocument/2006/relationships" id="286" r:id="R89c792fda63c48a5"/>
   </p:sldIdLst>
   <p:sldSz cx="12192000" cy="6858000"/>
   <p:notesSz cx="6858000" cy="9144000"/>
@@ -2919,7 +2919,7 @@
           <p:cNvPr id="3" name="Title">
             <a:extLst xmlns:a="http://schemas.openxmlformats.org/drawingml/2006/main">
               <a:ext uri="{FF2B5EF4-FFF2-40B4-BE49-F238E27FC236}">
-                <a16:creationId xmlns:a16="http://schemas.microsoft.com/office/drawing/2014/main" id="{9BD4C84B-F952-4040-A0BB-CEE4E33BD36A}"/>
+                <a16:creationId xmlns:a16="http://schemas.microsoft.com/office/drawing/2014/main" id="{3906F23B-1F4A-4AA0-A672-33F5C534753D}"/>
               </a:ext>
             </a:extLst>
           </p:cNvPr>
@@ -3148,7 +3148,7 @@
           <p:cNvPr id="2" name="Subtitle">
             <a:extLst xmlns:a="http://schemas.openxmlformats.org/drawingml/2006/main">
               <a:ext uri="{FF2B5EF4-FFF2-40B4-BE49-F238E27FC236}">
-                <a16:creationId xmlns:a16="http://schemas.microsoft.com/office/drawing/2014/main" id="{90577D5B-5934-47ED-ACAD-D2BBF73E1F34}"/>
+                <a16:creationId xmlns:a16="http://schemas.microsoft.com/office/drawing/2014/main" id="{0417B783-0DAD-4B38-8601-0B1F3E27253D}"/>
               </a:ext>
             </a:extLst>
           </p:cNvPr>
@@ -3394,7 +3394,7 @@
           <p:cNvPr id="2" name="Section title">
             <a:extLst xmlns:a="http://schemas.openxmlformats.org/drawingml/2006/main">
               <a:ext uri="{FF2B5EF4-FFF2-40B4-BE49-F238E27FC236}">
-                <a16:creationId xmlns:a16="http://schemas.microsoft.com/office/drawing/2014/main" id="{C313930D-E1B3-4E6B-ADCE-FBEE9E833D02}"/>
+                <a16:creationId xmlns:a16="http://schemas.microsoft.com/office/drawing/2014/main" id="{73396A12-9C6B-4F11-9626-9952CFDD32BF}"/>
               </a:ext>
             </a:extLst>
           </p:cNvPr>
@@ -3640,7 +3640,7 @@
           <p:cNvPr id="3" name="Title">
             <a:extLst xmlns:a="http://schemas.openxmlformats.org/drawingml/2006/main">
               <a:ext uri="{FF2B5EF4-FFF2-40B4-BE49-F238E27FC236}">
-                <a16:creationId xmlns:a16="http://schemas.microsoft.com/office/drawing/2014/main" id="{144A9706-4F4E-4C23-87DC-1EE4BB549E76}"/>
+                <a16:creationId xmlns:a16="http://schemas.microsoft.com/office/drawing/2014/main" id="{9FF16173-0EF6-465B-95EA-FF9320265530}"/>
               </a:ext>
             </a:extLst>
           </p:cNvPr>
@@ -3869,7 +3869,7 @@
           <p:cNvPr id="2" name="Body">
             <a:extLst xmlns:a="http://schemas.openxmlformats.org/drawingml/2006/main">
               <a:ext uri="{FF2B5EF4-FFF2-40B4-BE49-F238E27FC236}">
-                <a16:creationId xmlns:a16="http://schemas.microsoft.com/office/drawing/2014/main" id="{6FAD7C63-63DC-429A-8254-9DC52D314189}"/>
+                <a16:creationId xmlns:a16="http://schemas.microsoft.com/office/drawing/2014/main" id="{6EF4CE35-6B33-408A-8717-F036A77757D4}"/>
               </a:ext>
             </a:extLst>
           </p:cNvPr>
@@ -4115,7 +4115,7 @@
           <p:cNvPr id="4" name="Title">
             <a:extLst xmlns:a="http://schemas.openxmlformats.org/drawingml/2006/main">
               <a:ext uri="{FF2B5EF4-FFF2-40B4-BE49-F238E27FC236}">
-                <a16:creationId xmlns:a16="http://schemas.microsoft.com/office/drawing/2014/main" id="{79752948-CF12-4995-99D7-2DC55F6F3186}"/>
+                <a16:creationId xmlns:a16="http://schemas.microsoft.com/office/drawing/2014/main" id="{98D90DEA-0B66-4060-ACA9-585098FF7078}"/>
               </a:ext>
             </a:extLst>
           </p:cNvPr>
@@ -4344,7 +4344,7 @@
           <p:cNvPr id="2" name="Left column">
             <a:extLst xmlns:a="http://schemas.openxmlformats.org/drawingml/2006/main">
               <a:ext uri="{FF2B5EF4-FFF2-40B4-BE49-F238E27FC236}">
-                <a16:creationId xmlns:a16="http://schemas.microsoft.com/office/drawing/2014/main" id="{5202F258-9D4E-44DC-9E2B-340FFC20A451}"/>
+                <a16:creationId xmlns:a16="http://schemas.microsoft.com/office/drawing/2014/main" id="{76D9B7A8-8F18-4657-91BA-0DCE20FDD608}"/>
               </a:ext>
             </a:extLst>
           </p:cNvPr>
@@ -4573,7 +4573,7 @@
           <p:cNvPr id="3" name="Right column">
             <a:extLst xmlns:a="http://schemas.openxmlformats.org/drawingml/2006/main">
               <a:ext uri="{FF2B5EF4-FFF2-40B4-BE49-F238E27FC236}">
-                <a16:creationId xmlns:a16="http://schemas.microsoft.com/office/drawing/2014/main" id="{57222174-0855-4682-98E2-E247A5AC520D}"/>
+                <a16:creationId xmlns:a16="http://schemas.microsoft.com/office/drawing/2014/main" id="{FD0E5BA2-95CA-4E26-A3AF-95912795D9A5}"/>
               </a:ext>
             </a:extLst>
           </p:cNvPr>
@@ -4819,7 +4819,7 @@
           <p:cNvPr id="3" name="Title">
             <a:extLst xmlns:a="http://schemas.openxmlformats.org/drawingml/2006/main">
               <a:ext uri="{FF2B5EF4-FFF2-40B4-BE49-F238E27FC236}">
-                <a16:creationId xmlns:a16="http://schemas.microsoft.com/office/drawing/2014/main" id="{BA0D1E2C-FA8B-46C4-A1DB-8EAD0291AC7E}"/>
+                <a16:creationId xmlns:a16="http://schemas.microsoft.com/office/drawing/2014/main" id="{6E3A863C-31E8-4F93-8A44-B0DA6C562096}"/>
               </a:ext>
             </a:extLst>
           </p:cNvPr>
@@ -5048,7 +5048,7 @@
           <p:cNvPr id="2" name="Left column">
             <a:extLst xmlns:a="http://schemas.openxmlformats.org/drawingml/2006/main">
               <a:ext uri="{FF2B5EF4-FFF2-40B4-BE49-F238E27FC236}">
-                <a16:creationId xmlns:a16="http://schemas.microsoft.com/office/drawing/2014/main" id="{2E64463F-6282-4AD8-9FFB-623F1C404F44}"/>
+                <a16:creationId xmlns:a16="http://schemas.microsoft.com/office/drawing/2014/main" id="{C2866101-8CC3-4ECA-A057-B8D46E6E9336}"/>
               </a:ext>
             </a:extLst>
           </p:cNvPr>
@@ -5315,12 +5315,12 @@
   </p:cSld>
   <p:clrMap bg1="lt1" tx1="dk1" bg2="lt2" tx2="dk2" accent1="accent1" accent2="accent2" accent3="accent3" accent4="accent4" accent5="accent5" accent6="accent6" hlink="hlink" folHlink="folHlink"/>
   <p:sldLayoutIdLst>
-    <p:sldLayoutId xmlns:r="http://schemas.openxmlformats.org/officeDocument/2006/relationships" id="2147483649" r:id="R45f59769560540a2"/>
-    <p:sldLayoutId xmlns:r="http://schemas.openxmlformats.org/officeDocument/2006/relationships" id="2147483650" r:id="R5e82a2a566c645d8"/>
-    <p:sldLayoutId xmlns:r="http://schemas.openxmlformats.org/officeDocument/2006/relationships" id="2147483651" r:id="R68e0af92747f45ab"/>
-    <p:sldLayoutId xmlns:r="http://schemas.openxmlformats.org/officeDocument/2006/relationships" id="2147483652" r:id="R4118810e1a9a4b84"/>
-    <p:sldLayoutId xmlns:r="http://schemas.openxmlformats.org/officeDocument/2006/relationships" id="2147483653" r:id="R9c773a79dfcf4fcf"/>
-    <p:sldLayoutId xmlns:r="http://schemas.openxmlformats.org/officeDocument/2006/relationships" id="2147483654" r:id="R99d795ff319f4567"/>
+    <p:sldLayoutId xmlns:r="http://schemas.openxmlformats.org/officeDocument/2006/relationships" id="2147483649" r:id="R59e211e772a44394"/>
+    <p:sldLayoutId xmlns:r="http://schemas.openxmlformats.org/officeDocument/2006/relationships" id="2147483650" r:id="Re1c13ae3de9346ac"/>
+    <p:sldLayoutId xmlns:r="http://schemas.openxmlformats.org/officeDocument/2006/relationships" id="2147483651" r:id="R547f338fcbcb4800"/>
+    <p:sldLayoutId xmlns:r="http://schemas.openxmlformats.org/officeDocument/2006/relationships" id="2147483652" r:id="R282b3627fa624729"/>
+    <p:sldLayoutId xmlns:r="http://schemas.openxmlformats.org/officeDocument/2006/relationships" id="2147483653" r:id="R76494df9496d411d"/>
+    <p:sldLayoutId xmlns:r="http://schemas.openxmlformats.org/officeDocument/2006/relationships" id="2147483654" r:id="R19d36887876d4c74"/>
   </p:sldLayoutIdLst>
   <p:txStyles>
     <p:titleStyle>
@@ -5871,7 +5871,7 @@
           <p:cNvPr id="6" name="">
             <a:extLst xmlns:a="http://schemas.openxmlformats.org/drawingml/2006/main">
               <a:ext uri="{FF2B5EF4-FFF2-40B4-BE49-F238E27FC236}">
-                <a16:creationId xmlns:a16="http://schemas.microsoft.com/office/drawing/2014/main" id="{D66309A5-4735-4072-99C4-46C49C229456}"/>
+                <a16:creationId xmlns:a16="http://schemas.microsoft.com/office/drawing/2014/main" id="{7C77F97B-BFE2-4C8B-B8FA-1A856DA16C0E}"/>
               </a:ext>
             </a:extLst>
           </p:cNvPr>
@@ -6027,7 +6027,7 @@
           <p:cNvPr id="2" name="">
             <a:extLst xmlns:a="http://schemas.openxmlformats.org/drawingml/2006/main">
               <a:ext uri="{FF2B5EF4-FFF2-40B4-BE49-F238E27FC236}">
-                <a16:creationId xmlns:a16="http://schemas.microsoft.com/office/drawing/2014/main" id="{FAB3B608-5ABC-4995-9444-2DB184068C32}"/>
+                <a16:creationId xmlns:a16="http://schemas.microsoft.com/office/drawing/2014/main" id="{D195D3F3-26C7-41F8-B5A6-1A7FC8816C9A}"/>
               </a:ext>
             </a:extLst>
           </p:cNvPr>
@@ -6183,7 +6183,7 @@
           <p:cNvPr id="3" name="">
             <a:extLst xmlns:a="http://schemas.openxmlformats.org/drawingml/2006/main">
               <a:ext uri="{FF2B5EF4-FFF2-40B4-BE49-F238E27FC236}">
-                <a16:creationId xmlns:a16="http://schemas.microsoft.com/office/drawing/2014/main" id="{A122F198-9C75-4E06-9EAC-2400ABB7179D}"/>
+                <a16:creationId xmlns:a16="http://schemas.microsoft.com/office/drawing/2014/main" id="{D663ABF5-067D-4CE9-BBB2-BCDA28A13C87}"/>
               </a:ext>
             </a:extLst>
           </p:cNvPr>
@@ -6339,7 +6339,7 @@
           <p:cNvPr id="4" name="">
             <a:extLst xmlns:a="http://schemas.openxmlformats.org/drawingml/2006/main">
               <a:ext uri="{FF2B5EF4-FFF2-40B4-BE49-F238E27FC236}">
-                <a16:creationId xmlns:a16="http://schemas.microsoft.com/office/drawing/2014/main" id="{1C347C95-C99B-4A6B-B622-E26264B57BC3}"/>
+                <a16:creationId xmlns:a16="http://schemas.microsoft.com/office/drawing/2014/main" id="{CEBBD79E-0842-4D9A-ADFF-00C2A82123DF}"/>
               </a:ext>
             </a:extLst>
           </p:cNvPr>
@@ -6495,7 +6495,7 @@
           <p:cNvPr id="5" name="">
             <a:extLst xmlns:a="http://schemas.openxmlformats.org/drawingml/2006/main">
               <a:ext uri="{FF2B5EF4-FFF2-40B4-BE49-F238E27FC236}">
-                <a16:creationId xmlns:a16="http://schemas.microsoft.com/office/drawing/2014/main" id="{D65A9483-87F3-4644-8750-994ADB8D21BC}"/>
+                <a16:creationId xmlns:a16="http://schemas.microsoft.com/office/drawing/2014/main" id="{7E0D3C5A-7C57-49A9-BC95-61E6C56AF944}"/>
               </a:ext>
             </a:extLst>
           </p:cNvPr>
@@ -6649,7 +6649,7 @@
     </p:spTree>
     <p:extLst>
       <p:ext uri="{BB962C8B-B14F-4D97-AF65-F5344CB8AC3E}">
-        <p14:creationId xmlns:p14="http://schemas.microsoft.com/office/powerpoint/2010/main" val="2027173642"/>
+        <p14:creationId xmlns:p14="http://schemas.microsoft.com/office/powerpoint/2010/main" val="1655091736"/>
       </p:ext>
     </p:extLst>
   </p:cSld>
@@ -6680,7 +6680,7 @@
           <p:cNvPr id="8" name="">
             <a:extLst xmlns:a="http://schemas.openxmlformats.org/drawingml/2006/main">
               <a:ext uri="{FF2B5EF4-FFF2-40B4-BE49-F238E27FC236}">
-                <a16:creationId xmlns:a16="http://schemas.microsoft.com/office/drawing/2014/main" id="{334E9A13-20CF-492B-93A8-0918319E7A32}"/>
+                <a16:creationId xmlns:a16="http://schemas.microsoft.com/office/drawing/2014/main" id="{108FDB88-BEDD-4CCC-866D-8221A268D1A8}"/>
               </a:ext>
             </a:extLst>
           </p:cNvPr>
@@ -6836,7 +6836,7 @@
           <p:cNvPr id="2" name="">
             <a:extLst xmlns:a="http://schemas.openxmlformats.org/drawingml/2006/main">
               <a:ext uri="{FF2B5EF4-FFF2-40B4-BE49-F238E27FC236}">
-                <a16:creationId xmlns:a16="http://schemas.microsoft.com/office/drawing/2014/main" id="{02993E22-825B-4970-B8F9-BACF1CCD6B2C}"/>
+                <a16:creationId xmlns:a16="http://schemas.microsoft.com/office/drawing/2014/main" id="{91A92B64-6B50-4FD2-9907-663437EE0302}"/>
               </a:ext>
             </a:extLst>
           </p:cNvPr>
@@ -6992,7 +6992,7 @@
           <p:cNvPr id="3" name="">
             <a:extLst xmlns:a="http://schemas.openxmlformats.org/drawingml/2006/main">
               <a:ext uri="{FF2B5EF4-FFF2-40B4-BE49-F238E27FC236}">
-                <a16:creationId xmlns:a16="http://schemas.microsoft.com/office/drawing/2014/main" id="{BE404651-5520-4BC4-A7D1-35F9A9CE53BC}"/>
+                <a16:creationId xmlns:a16="http://schemas.microsoft.com/office/drawing/2014/main" id="{4B37B1A6-387F-43FF-90A8-77DBFE8AC4FA}"/>
               </a:ext>
             </a:extLst>
           </p:cNvPr>
@@ -7148,7 +7148,7 @@
           <p:cNvPr id="4" name="">
             <a:extLst xmlns:a="http://schemas.openxmlformats.org/drawingml/2006/main">
               <a:ext uri="{FF2B5EF4-FFF2-40B4-BE49-F238E27FC236}">
-                <a16:creationId xmlns:a16="http://schemas.microsoft.com/office/drawing/2014/main" id="{9107F8FD-876D-4510-8C35-DD8F16367912}"/>
+                <a16:creationId xmlns:a16="http://schemas.microsoft.com/office/drawing/2014/main" id="{737CD05A-E890-43C7-95BA-7496FB7337C5}"/>
               </a:ext>
             </a:extLst>
           </p:cNvPr>
@@ -7304,7 +7304,7 @@
           <p:cNvPr id="5" name="">
             <a:extLst xmlns:a="http://schemas.openxmlformats.org/drawingml/2006/main">
               <a:ext uri="{FF2B5EF4-FFF2-40B4-BE49-F238E27FC236}">
-                <a16:creationId xmlns:a16="http://schemas.microsoft.com/office/drawing/2014/main" id="{4E46A282-C5D9-41ED-8CE0-BD2A354C9F38}"/>
+                <a16:creationId xmlns:a16="http://schemas.microsoft.com/office/drawing/2014/main" id="{4F9DF091-DA26-4CFF-8F98-F0DEA1213510}"/>
               </a:ext>
             </a:extLst>
           </p:cNvPr>
@@ -7460,7 +7460,7 @@
           <p:cNvPr id="6" name="">
             <a:extLst xmlns:a="http://schemas.openxmlformats.org/drawingml/2006/main">
               <a:ext uri="{FF2B5EF4-FFF2-40B4-BE49-F238E27FC236}">
-                <a16:creationId xmlns:a16="http://schemas.microsoft.com/office/drawing/2014/main" id="{7C61E717-7DF2-4BB2-97B9-A24189516F0D}"/>
+                <a16:creationId xmlns:a16="http://schemas.microsoft.com/office/drawing/2014/main" id="{9E72690F-92F9-4631-9A96-0D679E1D3CF7}"/>
               </a:ext>
             </a:extLst>
           </p:cNvPr>
@@ -7616,7 +7616,7 @@
           <p:cNvPr id="7" name="">
             <a:extLst xmlns:a="http://schemas.openxmlformats.org/drawingml/2006/main">
               <a:ext uri="{FF2B5EF4-FFF2-40B4-BE49-F238E27FC236}">
-                <a16:creationId xmlns:a16="http://schemas.microsoft.com/office/drawing/2014/main" id="{C035C4A2-EF8B-4925-A7E4-9D5659176544}"/>
+                <a16:creationId xmlns:a16="http://schemas.microsoft.com/office/drawing/2014/main" id="{2D7F4749-00DC-4961-8FD2-FE297FA9CC8A}"/>
               </a:ext>
             </a:extLst>
           </p:cNvPr>
@@ -7770,7 +7770,7 @@
     </p:spTree>
     <p:extLst>
       <p:ext uri="{BB962C8B-B14F-4D97-AF65-F5344CB8AC3E}">
-        <p14:creationId xmlns:p14="http://schemas.microsoft.com/office/powerpoint/2010/main" val="752199807"/>
+        <p14:creationId xmlns:p14="http://schemas.microsoft.com/office/powerpoint/2010/main" val="110400074"/>
       </p:ext>
     </p:extLst>
   </p:cSld>
@@ -7801,7 +7801,7 @@
           <p:cNvPr id="8" name="">
             <a:extLst xmlns:a="http://schemas.openxmlformats.org/drawingml/2006/main">
               <a:ext uri="{FF2B5EF4-FFF2-40B4-BE49-F238E27FC236}">
-                <a16:creationId xmlns:a16="http://schemas.microsoft.com/office/drawing/2014/main" id="{1056DE26-39DC-4633-92C6-1430C2EBA088}"/>
+                <a16:creationId xmlns:a16="http://schemas.microsoft.com/office/drawing/2014/main" id="{B87AA3E8-DA81-4EF8-A8E5-12FEB6B130BF}"/>
               </a:ext>
             </a:extLst>
           </p:cNvPr>
@@ -7957,7 +7957,7 @@
           <p:cNvPr id="2" name="">
             <a:extLst xmlns:a="http://schemas.openxmlformats.org/drawingml/2006/main">
               <a:ext uri="{FF2B5EF4-FFF2-40B4-BE49-F238E27FC236}">
-                <a16:creationId xmlns:a16="http://schemas.microsoft.com/office/drawing/2014/main" id="{BF338C7C-B8E3-4B6E-BEF7-29A3EA186118}"/>
+                <a16:creationId xmlns:a16="http://schemas.microsoft.com/office/drawing/2014/main" id="{DF9BD27B-DFBA-4438-A7AB-53C2E6F020CD}"/>
               </a:ext>
             </a:extLst>
           </p:cNvPr>
@@ -8113,7 +8113,7 @@
           <p:cNvPr id="3" name="">
             <a:extLst xmlns:a="http://schemas.openxmlformats.org/drawingml/2006/main">
               <a:ext uri="{FF2B5EF4-FFF2-40B4-BE49-F238E27FC236}">
-                <a16:creationId xmlns:a16="http://schemas.microsoft.com/office/drawing/2014/main" id="{76B3A5F4-7CA2-4A0D-AB28-35CFC7A79514}"/>
+                <a16:creationId xmlns:a16="http://schemas.microsoft.com/office/drawing/2014/main" id="{9065A19D-D867-4DFC-9C49-BE5AA70D9D65}"/>
               </a:ext>
             </a:extLst>
           </p:cNvPr>
@@ -8269,7 +8269,7 @@
           <p:cNvPr id="4" name="">
             <a:extLst xmlns:a="http://schemas.openxmlformats.org/drawingml/2006/main">
               <a:ext uri="{FF2B5EF4-FFF2-40B4-BE49-F238E27FC236}">
-                <a16:creationId xmlns:a16="http://schemas.microsoft.com/office/drawing/2014/main" id="{6CDB3F91-3D21-45AD-9D7F-31480F3932FF}"/>
+                <a16:creationId xmlns:a16="http://schemas.microsoft.com/office/drawing/2014/main" id="{D40E56FC-66C4-485E-A29D-587A28CC5C15}"/>
               </a:ext>
             </a:extLst>
           </p:cNvPr>
@@ -8425,7 +8425,7 @@
           <p:cNvPr id="5" name="">
             <a:extLst xmlns:a="http://schemas.openxmlformats.org/drawingml/2006/main">
               <a:ext uri="{FF2B5EF4-FFF2-40B4-BE49-F238E27FC236}">
-                <a16:creationId xmlns:a16="http://schemas.microsoft.com/office/drawing/2014/main" id="{A8F0BFF3-8555-4FAE-9645-D7EF369AEEE0}"/>
+                <a16:creationId xmlns:a16="http://schemas.microsoft.com/office/drawing/2014/main" id="{10C7111D-B70D-4B48-A038-DADE70A374C9}"/>
               </a:ext>
             </a:extLst>
           </p:cNvPr>
@@ -8581,7 +8581,7 @@
           <p:cNvPr id="6" name="">
             <a:extLst xmlns:a="http://schemas.openxmlformats.org/drawingml/2006/main">
               <a:ext uri="{FF2B5EF4-FFF2-40B4-BE49-F238E27FC236}">
-                <a16:creationId xmlns:a16="http://schemas.microsoft.com/office/drawing/2014/main" id="{7B21B560-0903-4018-8E59-BD93CD454992}"/>
+                <a16:creationId xmlns:a16="http://schemas.microsoft.com/office/drawing/2014/main" id="{0D5D2A5F-D6F3-426D-82FE-B101B122F7E2}"/>
               </a:ext>
             </a:extLst>
           </p:cNvPr>
@@ -8737,7 +8737,7 @@
           <p:cNvPr id="7" name="">
             <a:extLst xmlns:a="http://schemas.openxmlformats.org/drawingml/2006/main">
               <a:ext uri="{FF2B5EF4-FFF2-40B4-BE49-F238E27FC236}">
-                <a16:creationId xmlns:a16="http://schemas.microsoft.com/office/drawing/2014/main" id="{A54C9D74-A6CA-45F5-A09D-176B12329A03}"/>
+                <a16:creationId xmlns:a16="http://schemas.microsoft.com/office/drawing/2014/main" id="{F241ABE9-9E90-438A-AE1C-0A4FC460CC27}"/>
               </a:ext>
             </a:extLst>
           </p:cNvPr>
@@ -8891,7 +8891,7 @@
     </p:spTree>
     <p:extLst>
       <p:ext uri="{BB962C8B-B14F-4D97-AF65-F5344CB8AC3E}">
-        <p14:creationId xmlns:p14="http://schemas.microsoft.com/office/powerpoint/2010/main" val="877386252"/>
+        <p14:creationId xmlns:p14="http://schemas.microsoft.com/office/powerpoint/2010/main" val="234123633"/>
       </p:ext>
     </p:extLst>
   </p:cSld>
@@ -8922,7 +8922,7 @@
           <p:cNvPr id="7" name="">
             <a:extLst xmlns:a="http://schemas.openxmlformats.org/drawingml/2006/main">
               <a:ext uri="{FF2B5EF4-FFF2-40B4-BE49-F238E27FC236}">
-                <a16:creationId xmlns:a16="http://schemas.microsoft.com/office/drawing/2014/main" id="{11BF581C-9B2F-4CE7-B7B1-56B8875A55E1}"/>
+                <a16:creationId xmlns:a16="http://schemas.microsoft.com/office/drawing/2014/main" id="{78021948-AEF9-440A-A292-A2E413D1C440}"/>
               </a:ext>
             </a:extLst>
           </p:cNvPr>
@@ -9078,7 +9078,7 @@
           <p:cNvPr id="2" name="">
             <a:extLst xmlns:a="http://schemas.openxmlformats.org/drawingml/2006/main">
               <a:ext uri="{FF2B5EF4-FFF2-40B4-BE49-F238E27FC236}">
-                <a16:creationId xmlns:a16="http://schemas.microsoft.com/office/drawing/2014/main" id="{B349B810-04D3-409A-830C-E692B1009363}"/>
+                <a16:creationId xmlns:a16="http://schemas.microsoft.com/office/drawing/2014/main" id="{01313A95-9BFA-4F89-B34D-78ACEB1153EA}"/>
               </a:ext>
             </a:extLst>
           </p:cNvPr>
@@ -9234,7 +9234,7 @@
           <p:cNvPr id="3" name="">
             <a:extLst xmlns:a="http://schemas.openxmlformats.org/drawingml/2006/main">
               <a:ext uri="{FF2B5EF4-FFF2-40B4-BE49-F238E27FC236}">
-                <a16:creationId xmlns:a16="http://schemas.microsoft.com/office/drawing/2014/main" id="{BBBF48C0-B66E-4EBB-B6F2-ED339680353F}"/>
+                <a16:creationId xmlns:a16="http://schemas.microsoft.com/office/drawing/2014/main" id="{52BB3D85-6461-45CA-A2E6-F7EB111AA459}"/>
               </a:ext>
             </a:extLst>
           </p:cNvPr>
@@ -9390,7 +9390,7 @@
           <p:cNvPr id="4" name="">
             <a:extLst xmlns:a="http://schemas.openxmlformats.org/drawingml/2006/main">
               <a:ext uri="{FF2B5EF4-FFF2-40B4-BE49-F238E27FC236}">
-                <a16:creationId xmlns:a16="http://schemas.microsoft.com/office/drawing/2014/main" id="{89AC21BD-C77D-4D5A-990D-C2DE1A0654BC}"/>
+                <a16:creationId xmlns:a16="http://schemas.microsoft.com/office/drawing/2014/main" id="{FA8C5E68-A8F2-4883-9B35-7B0D6CA3D3CB}"/>
               </a:ext>
             </a:extLst>
           </p:cNvPr>
@@ -9546,7 +9546,7 @@
           <p:cNvPr id="5" name="">
             <a:extLst xmlns:a="http://schemas.openxmlformats.org/drawingml/2006/main">
               <a:ext uri="{FF2B5EF4-FFF2-40B4-BE49-F238E27FC236}">
-                <a16:creationId xmlns:a16="http://schemas.microsoft.com/office/drawing/2014/main" id="{52693305-1077-4D83-8B7E-E772C1875979}"/>
+                <a16:creationId xmlns:a16="http://schemas.microsoft.com/office/drawing/2014/main" id="{A179BD5F-2C36-4A32-8268-5F3E03119FD1}"/>
               </a:ext>
             </a:extLst>
           </p:cNvPr>
@@ -9702,7 +9702,7 @@
           <p:cNvPr id="6" name="">
             <a:extLst xmlns:a="http://schemas.openxmlformats.org/drawingml/2006/main">
               <a:ext uri="{FF2B5EF4-FFF2-40B4-BE49-F238E27FC236}">
-                <a16:creationId xmlns:a16="http://schemas.microsoft.com/office/drawing/2014/main" id="{E1C4FCCC-50D0-42A9-86E5-50341A0B60A6}"/>
+                <a16:creationId xmlns:a16="http://schemas.microsoft.com/office/drawing/2014/main" id="{B22984BC-708C-4163-8C0F-B10B9EF4470D}"/>
               </a:ext>
             </a:extLst>
           </p:cNvPr>
@@ -9856,7 +9856,7 @@
     </p:spTree>
     <p:extLst>
       <p:ext uri="{BB962C8B-B14F-4D97-AF65-F5344CB8AC3E}">
-        <p14:creationId xmlns:p14="http://schemas.microsoft.com/office/powerpoint/2010/main" val="1520174723"/>
+        <p14:creationId xmlns:p14="http://schemas.microsoft.com/office/powerpoint/2010/main" val="2089844462"/>
       </p:ext>
     </p:extLst>
   </p:cSld>
@@ -9887,7 +9887,7 @@
           <p:cNvPr id="7" name="">
             <a:extLst xmlns:a="http://schemas.openxmlformats.org/drawingml/2006/main">
               <a:ext uri="{FF2B5EF4-FFF2-40B4-BE49-F238E27FC236}">
-                <a16:creationId xmlns:a16="http://schemas.microsoft.com/office/drawing/2014/main" id="{0E2BD8C6-31FE-4C63-877B-77B3AF402D2E}"/>
+                <a16:creationId xmlns:a16="http://schemas.microsoft.com/office/drawing/2014/main" id="{41736E7C-F5FC-453F-8D63-BC95EAED0AF3}"/>
               </a:ext>
             </a:extLst>
           </p:cNvPr>
@@ -10043,7 +10043,7 @@
           <p:cNvPr id="2" name="">
             <a:extLst xmlns:a="http://schemas.openxmlformats.org/drawingml/2006/main">
               <a:ext uri="{FF2B5EF4-FFF2-40B4-BE49-F238E27FC236}">
-                <a16:creationId xmlns:a16="http://schemas.microsoft.com/office/drawing/2014/main" id="{04DCD6BC-BDE5-4E8D-80C4-79B8E8A25DC4}"/>
+                <a16:creationId xmlns:a16="http://schemas.microsoft.com/office/drawing/2014/main" id="{FBA2620D-598A-4AC5-8CB8-2B4173912316}"/>
               </a:ext>
             </a:extLst>
           </p:cNvPr>
@@ -10199,7 +10199,7 @@
           <p:cNvPr id="3" name="">
             <a:extLst xmlns:a="http://schemas.openxmlformats.org/drawingml/2006/main">
               <a:ext uri="{FF2B5EF4-FFF2-40B4-BE49-F238E27FC236}">
-                <a16:creationId xmlns:a16="http://schemas.microsoft.com/office/drawing/2014/main" id="{2E93099D-4506-42F8-BD27-BC45DDB9E3BA}"/>
+                <a16:creationId xmlns:a16="http://schemas.microsoft.com/office/drawing/2014/main" id="{A524C47F-680B-4844-9604-D102628B969A}"/>
               </a:ext>
             </a:extLst>
           </p:cNvPr>
@@ -10355,7 +10355,7 @@
           <p:cNvPr id="4" name="">
             <a:extLst xmlns:a="http://schemas.openxmlformats.org/drawingml/2006/main">
               <a:ext uri="{FF2B5EF4-FFF2-40B4-BE49-F238E27FC236}">
-                <a16:creationId xmlns:a16="http://schemas.microsoft.com/office/drawing/2014/main" id="{BC29AB54-60F2-4285-95A7-791493423912}"/>
+                <a16:creationId xmlns:a16="http://schemas.microsoft.com/office/drawing/2014/main" id="{DE6BC859-8AC4-44ED-87C6-F4BBA32167A2}"/>
               </a:ext>
             </a:extLst>
           </p:cNvPr>
@@ -10511,7 +10511,7 @@
           <p:cNvPr id="5" name="">
             <a:extLst xmlns:a="http://schemas.openxmlformats.org/drawingml/2006/main">
               <a:ext uri="{FF2B5EF4-FFF2-40B4-BE49-F238E27FC236}">
-                <a16:creationId xmlns:a16="http://schemas.microsoft.com/office/drawing/2014/main" id="{A3CC0DA9-822F-46D1-B679-8FA7BCBBA192}"/>
+                <a16:creationId xmlns:a16="http://schemas.microsoft.com/office/drawing/2014/main" id="{0AE1E5D5-C79B-4C89-960A-D2FB157F5522}"/>
               </a:ext>
             </a:extLst>
           </p:cNvPr>
@@ -10667,7 +10667,7 @@
           <p:cNvPr id="6" name="">
             <a:extLst xmlns:a="http://schemas.openxmlformats.org/drawingml/2006/main">
               <a:ext uri="{FF2B5EF4-FFF2-40B4-BE49-F238E27FC236}">
-                <a16:creationId xmlns:a16="http://schemas.microsoft.com/office/drawing/2014/main" id="{C348F2AC-F9C0-4A10-8730-E9A47DED1CAD}"/>
+                <a16:creationId xmlns:a16="http://schemas.microsoft.com/office/drawing/2014/main" id="{73C85406-EBC1-4F82-986A-441A4AC29875}"/>
               </a:ext>
             </a:extLst>
           </p:cNvPr>
@@ -10821,7 +10821,7 @@
     </p:spTree>
     <p:extLst>
       <p:ext uri="{BB962C8B-B14F-4D97-AF65-F5344CB8AC3E}">
-        <p14:creationId xmlns:p14="http://schemas.microsoft.com/office/powerpoint/2010/main" val="2065795882"/>
+        <p14:creationId xmlns:p14="http://schemas.microsoft.com/office/powerpoint/2010/main" val="1372346944"/>
       </p:ext>
     </p:extLst>
   </p:cSld>
@@ -10852,7 +10852,7 @@
           <p:cNvPr id="6" name="">
             <a:extLst xmlns:a="http://schemas.openxmlformats.org/drawingml/2006/main">
               <a:ext uri="{FF2B5EF4-FFF2-40B4-BE49-F238E27FC236}">
-                <a16:creationId xmlns:a16="http://schemas.microsoft.com/office/drawing/2014/main" id="{A3CB0BE8-5A4D-4F80-805B-5DFD9FEB665B}"/>
+                <a16:creationId xmlns:a16="http://schemas.microsoft.com/office/drawing/2014/main" id="{ED417FEE-1261-46D3-A8F5-1F196F48FBBF}"/>
               </a:ext>
             </a:extLst>
           </p:cNvPr>
@@ -11008,7 +11008,7 @@
           <p:cNvPr id="2" name="">
             <a:extLst xmlns:a="http://schemas.openxmlformats.org/drawingml/2006/main">
               <a:ext uri="{FF2B5EF4-FFF2-40B4-BE49-F238E27FC236}">
-                <a16:creationId xmlns:a16="http://schemas.microsoft.com/office/drawing/2014/main" id="{12C8B080-CEFB-4A34-BE79-75481A04E136}"/>
+                <a16:creationId xmlns:a16="http://schemas.microsoft.com/office/drawing/2014/main" id="{7EE9964F-B188-43F3-B1C3-FE7F1B8A78D8}"/>
               </a:ext>
             </a:extLst>
           </p:cNvPr>
@@ -11164,7 +11164,7 @@
           <p:cNvPr id="3" name="">
             <a:extLst xmlns:a="http://schemas.openxmlformats.org/drawingml/2006/main">
               <a:ext uri="{FF2B5EF4-FFF2-40B4-BE49-F238E27FC236}">
-                <a16:creationId xmlns:a16="http://schemas.microsoft.com/office/drawing/2014/main" id="{B12AB2FB-7FB8-421B-9B41-EDDC8456F6F9}"/>
+                <a16:creationId xmlns:a16="http://schemas.microsoft.com/office/drawing/2014/main" id="{6BFD96F6-1B61-43A6-939D-4012BA5BFA05}"/>
               </a:ext>
             </a:extLst>
           </p:cNvPr>
@@ -11320,7 +11320,7 @@
           <p:cNvPr id="4" name="">
             <a:extLst xmlns:a="http://schemas.openxmlformats.org/drawingml/2006/main">
               <a:ext uri="{FF2B5EF4-FFF2-40B4-BE49-F238E27FC236}">
-                <a16:creationId xmlns:a16="http://schemas.microsoft.com/office/drawing/2014/main" id="{445995BA-ACBE-4A4A-9633-06C024D86807}"/>
+                <a16:creationId xmlns:a16="http://schemas.microsoft.com/office/drawing/2014/main" id="{53DBF7CB-3EA6-4609-B73B-0004D6051ECA}"/>
               </a:ext>
             </a:extLst>
           </p:cNvPr>
@@ -11476,7 +11476,7 @@
           <p:cNvPr id="5" name="">
             <a:extLst xmlns:a="http://schemas.openxmlformats.org/drawingml/2006/main">
               <a:ext uri="{FF2B5EF4-FFF2-40B4-BE49-F238E27FC236}">
-                <a16:creationId xmlns:a16="http://schemas.microsoft.com/office/drawing/2014/main" id="{F5B3B836-5FC5-4CC6-8695-C03C1BD9D34E}"/>
+                <a16:creationId xmlns:a16="http://schemas.microsoft.com/office/drawing/2014/main" id="{B716D368-6B05-4D39-B5E5-D7EECB0D21F6}"/>
               </a:ext>
             </a:extLst>
           </p:cNvPr>
@@ -11630,7 +11630,7 @@
     </p:spTree>
     <p:extLst>
       <p:ext uri="{BB962C8B-B14F-4D97-AF65-F5344CB8AC3E}">
-        <p14:creationId xmlns:p14="http://schemas.microsoft.com/office/powerpoint/2010/main" val="326537061"/>
+        <p14:creationId xmlns:p14="http://schemas.microsoft.com/office/powerpoint/2010/main" val="315271551"/>
       </p:ext>
     </p:extLst>
   </p:cSld>
@@ -11661,7 +11661,7 @@
           <p:cNvPr id="6" name="">
             <a:extLst xmlns:a="http://schemas.openxmlformats.org/drawingml/2006/main">
               <a:ext uri="{FF2B5EF4-FFF2-40B4-BE49-F238E27FC236}">
-                <a16:creationId xmlns:a16="http://schemas.microsoft.com/office/drawing/2014/main" id="{4FBFE736-FE75-4118-B3E0-8CBDE69A9D78}"/>
+                <a16:creationId xmlns:a16="http://schemas.microsoft.com/office/drawing/2014/main" id="{150A809F-CE03-4A6B-9A56-AD4DB06566BD}"/>
               </a:ext>
             </a:extLst>
           </p:cNvPr>
@@ -11817,7 +11817,7 @@
           <p:cNvPr id="2" name="">
             <a:extLst xmlns:a="http://schemas.openxmlformats.org/drawingml/2006/main">
               <a:ext uri="{FF2B5EF4-FFF2-40B4-BE49-F238E27FC236}">
-                <a16:creationId xmlns:a16="http://schemas.microsoft.com/office/drawing/2014/main" id="{FE5BD2B9-6AE7-4C99-A75F-F6C98AE68818}"/>
+                <a16:creationId xmlns:a16="http://schemas.microsoft.com/office/drawing/2014/main" id="{FF465852-5AB3-47C0-90FE-B78B0523A4ED}"/>
               </a:ext>
             </a:extLst>
           </p:cNvPr>
@@ -11973,7 +11973,7 @@
           <p:cNvPr id="3" name="">
             <a:extLst xmlns:a="http://schemas.openxmlformats.org/drawingml/2006/main">
               <a:ext uri="{FF2B5EF4-FFF2-40B4-BE49-F238E27FC236}">
-                <a16:creationId xmlns:a16="http://schemas.microsoft.com/office/drawing/2014/main" id="{38BA2DBB-D030-4827-A5C7-B2108862A30D}"/>
+                <a16:creationId xmlns:a16="http://schemas.microsoft.com/office/drawing/2014/main" id="{79467178-4A5E-4C50-92EE-547F3B1F663A}"/>
               </a:ext>
             </a:extLst>
           </p:cNvPr>
@@ -12129,7 +12129,7 @@
           <p:cNvPr id="4" name="">
             <a:extLst xmlns:a="http://schemas.openxmlformats.org/drawingml/2006/main">
               <a:ext uri="{FF2B5EF4-FFF2-40B4-BE49-F238E27FC236}">
-                <a16:creationId xmlns:a16="http://schemas.microsoft.com/office/drawing/2014/main" id="{1A0F965D-7657-48E7-9D4B-5B801C782E49}"/>
+                <a16:creationId xmlns:a16="http://schemas.microsoft.com/office/drawing/2014/main" id="{63205B3C-B411-4F8C-B9C2-102DE3CBFF4B}"/>
               </a:ext>
             </a:extLst>
           </p:cNvPr>
@@ -12285,7 +12285,7 @@
           <p:cNvPr id="5" name="">
             <a:extLst xmlns:a="http://schemas.openxmlformats.org/drawingml/2006/main">
               <a:ext uri="{FF2B5EF4-FFF2-40B4-BE49-F238E27FC236}">
-                <a16:creationId xmlns:a16="http://schemas.microsoft.com/office/drawing/2014/main" id="{53A463E0-EC0E-48F7-9BB8-78E697BA0951}"/>
+                <a16:creationId xmlns:a16="http://schemas.microsoft.com/office/drawing/2014/main" id="{393DAD7A-5EA2-4568-AE24-071D6C75B03F}"/>
               </a:ext>
             </a:extLst>
           </p:cNvPr>
@@ -12439,7 +12439,7 @@
     </p:spTree>
     <p:extLst>
       <p:ext uri="{BB962C8B-B14F-4D97-AF65-F5344CB8AC3E}">
-        <p14:creationId xmlns:p14="http://schemas.microsoft.com/office/powerpoint/2010/main" val="1669901078"/>
+        <p14:creationId xmlns:p14="http://schemas.microsoft.com/office/powerpoint/2010/main" val="813662182"/>
       </p:ext>
     </p:extLst>
   </p:cSld>
@@ -12470,7 +12470,7 @@
           <p:cNvPr id="6" name="">
             <a:extLst xmlns:a="http://schemas.openxmlformats.org/drawingml/2006/main">
               <a:ext uri="{FF2B5EF4-FFF2-40B4-BE49-F238E27FC236}">
-                <a16:creationId xmlns:a16="http://schemas.microsoft.com/office/drawing/2014/main" id="{B974535E-BE67-4223-BDAC-F83D0E368330}"/>
+                <a16:creationId xmlns:a16="http://schemas.microsoft.com/office/drawing/2014/main" id="{B5FB7DBC-2BD4-4BDB-9F5D-9A4567DD037D}"/>
               </a:ext>
             </a:extLst>
           </p:cNvPr>
@@ -12626,7 +12626,7 @@
           <p:cNvPr id="2" name="">
             <a:extLst xmlns:a="http://schemas.openxmlformats.org/drawingml/2006/main">
               <a:ext uri="{FF2B5EF4-FFF2-40B4-BE49-F238E27FC236}">
-                <a16:creationId xmlns:a16="http://schemas.microsoft.com/office/drawing/2014/main" id="{38C5D028-25A2-4157-BE1E-ABE6E81BEDA9}"/>
+                <a16:creationId xmlns:a16="http://schemas.microsoft.com/office/drawing/2014/main" id="{E6406161-9479-4CFF-A2A4-2C18FB36B619}"/>
               </a:ext>
             </a:extLst>
           </p:cNvPr>
@@ -12782,7 +12782,7 @@
           <p:cNvPr id="3" name="">
             <a:extLst xmlns:a="http://schemas.openxmlformats.org/drawingml/2006/main">
               <a:ext uri="{FF2B5EF4-FFF2-40B4-BE49-F238E27FC236}">
-                <a16:creationId xmlns:a16="http://schemas.microsoft.com/office/drawing/2014/main" id="{32CCF224-3E1E-4BF2-BFC3-B0CB8E42DB3E}"/>
+                <a16:creationId xmlns:a16="http://schemas.microsoft.com/office/drawing/2014/main" id="{38BDDEAF-7B78-4BFF-AB7F-9B6ED20B8633}"/>
               </a:ext>
             </a:extLst>
           </p:cNvPr>
@@ -12938,7 +12938,7 @@
           <p:cNvPr id="4" name="">
             <a:extLst xmlns:a="http://schemas.openxmlformats.org/drawingml/2006/main">
               <a:ext uri="{FF2B5EF4-FFF2-40B4-BE49-F238E27FC236}">
-                <a16:creationId xmlns:a16="http://schemas.microsoft.com/office/drawing/2014/main" id="{B3EB5623-4162-483D-8940-495602708F40}"/>
+                <a16:creationId xmlns:a16="http://schemas.microsoft.com/office/drawing/2014/main" id="{3EE433C9-79B0-4E8B-A9F6-42D960BE66D7}"/>
               </a:ext>
             </a:extLst>
           </p:cNvPr>
@@ -13094,7 +13094,7 @@
           <p:cNvPr id="5" name="">
             <a:extLst xmlns:a="http://schemas.openxmlformats.org/drawingml/2006/main">
               <a:ext uri="{FF2B5EF4-FFF2-40B4-BE49-F238E27FC236}">
-                <a16:creationId xmlns:a16="http://schemas.microsoft.com/office/drawing/2014/main" id="{566202FA-BC5F-4231-8A69-1E71D860D01B}"/>
+                <a16:creationId xmlns:a16="http://schemas.microsoft.com/office/drawing/2014/main" id="{7D25FE3F-BC84-4977-9C58-70712735A4DD}"/>
               </a:ext>
             </a:extLst>
           </p:cNvPr>
@@ -13248,7 +13248,7 @@
     </p:spTree>
     <p:extLst>
       <p:ext uri="{BB962C8B-B14F-4D97-AF65-F5344CB8AC3E}">
-        <p14:creationId xmlns:p14="http://schemas.microsoft.com/office/powerpoint/2010/main" val="236201132"/>
+        <p14:creationId xmlns:p14="http://schemas.microsoft.com/office/powerpoint/2010/main" val="292794274"/>
       </p:ext>
     </p:extLst>
   </p:cSld>
@@ -13279,7 +13279,7 @@
           <p:cNvPr id="11" name="">
             <a:extLst xmlns:a="http://schemas.openxmlformats.org/drawingml/2006/main">
               <a:ext uri="{FF2B5EF4-FFF2-40B4-BE49-F238E27FC236}">
-                <a16:creationId xmlns:a16="http://schemas.microsoft.com/office/drawing/2014/main" id="{A51BCFBD-4056-49B6-9708-424D86339939}"/>
+                <a16:creationId xmlns:a16="http://schemas.microsoft.com/office/drawing/2014/main" id="{D5E4D123-A5C1-4D83-BBC8-ECE0B9E524F0}"/>
               </a:ext>
             </a:extLst>
           </p:cNvPr>
@@ -13435,7 +13435,7 @@
           <p:cNvPr id="2" name="">
             <a:extLst xmlns:a="http://schemas.openxmlformats.org/drawingml/2006/main">
               <a:ext uri="{FF2B5EF4-FFF2-40B4-BE49-F238E27FC236}">
-                <a16:creationId xmlns:a16="http://schemas.microsoft.com/office/drawing/2014/main" id="{C323C495-A9C2-42B0-8B9D-D6785F0A9CD0}"/>
+                <a16:creationId xmlns:a16="http://schemas.microsoft.com/office/drawing/2014/main" id="{60D32D0D-A1B7-415D-96FA-6CAB8A85D0B7}"/>
               </a:ext>
             </a:extLst>
           </p:cNvPr>
@@ -13591,7 +13591,7 @@
           <p:cNvPr id="3" name="">
             <a:extLst xmlns:a="http://schemas.openxmlformats.org/drawingml/2006/main">
               <a:ext uri="{FF2B5EF4-FFF2-40B4-BE49-F238E27FC236}">
-                <a16:creationId xmlns:a16="http://schemas.microsoft.com/office/drawing/2014/main" id="{28A14348-AC49-4714-80C4-83D5BE5532F2}"/>
+                <a16:creationId xmlns:a16="http://schemas.microsoft.com/office/drawing/2014/main" id="{1DD152C8-B537-4D63-B9B6-C47051257F11}"/>
               </a:ext>
             </a:extLst>
           </p:cNvPr>
@@ -13747,7 +13747,7 @@
           <p:cNvPr id="4" name="">
             <a:extLst xmlns:a="http://schemas.openxmlformats.org/drawingml/2006/main">
               <a:ext uri="{FF2B5EF4-FFF2-40B4-BE49-F238E27FC236}">
-                <a16:creationId xmlns:a16="http://schemas.microsoft.com/office/drawing/2014/main" id="{3262AD9E-FA83-4DCD-BB02-66CE484F28AF}"/>
+                <a16:creationId xmlns:a16="http://schemas.microsoft.com/office/drawing/2014/main" id="{406E1464-903A-4E00-9F22-C7EC23C43922}"/>
               </a:ext>
             </a:extLst>
           </p:cNvPr>
@@ -13777,7 +13777,7 @@
           <p:cNvPr id="5" name="">
             <a:extLst xmlns:a="http://schemas.openxmlformats.org/drawingml/2006/main">
               <a:ext uri="{FF2B5EF4-FFF2-40B4-BE49-F238E27FC236}">
-                <a16:creationId xmlns:a16="http://schemas.microsoft.com/office/drawing/2014/main" id="{1FFEC10F-F50C-4625-ADD3-476BE0E5BDEA}"/>
+                <a16:creationId xmlns:a16="http://schemas.microsoft.com/office/drawing/2014/main" id="{3931D34A-260E-4C64-8AF0-7F985B4ACA35}"/>
               </a:ext>
             </a:extLst>
           </p:cNvPr>
@@ -14031,7 +14031,7 @@
           <p:cNvPr id="6" name="">
             <a:extLst xmlns:a="http://schemas.openxmlformats.org/drawingml/2006/main">
               <a:ext uri="{FF2B5EF4-FFF2-40B4-BE49-F238E27FC236}">
-                <a16:creationId xmlns:a16="http://schemas.microsoft.com/office/drawing/2014/main" id="{0A8E6189-03DB-40A4-A68B-A1B32CE28F23}"/>
+                <a16:creationId xmlns:a16="http://schemas.microsoft.com/office/drawing/2014/main" id="{43B80DFD-2907-4CD1-B32F-1C8795BD99D3}"/>
               </a:ext>
             </a:extLst>
           </p:cNvPr>
@@ -14187,7 +14187,7 @@
           <p:cNvPr id="7" name="">
             <a:extLst xmlns:a="http://schemas.openxmlformats.org/drawingml/2006/main">
               <a:ext uri="{FF2B5EF4-FFF2-40B4-BE49-F238E27FC236}">
-                <a16:creationId xmlns:a16="http://schemas.microsoft.com/office/drawing/2014/main" id="{20948C46-DEE8-41DD-B762-070B4780C669}"/>
+                <a16:creationId xmlns:a16="http://schemas.microsoft.com/office/drawing/2014/main" id="{5C82B612-16E3-47F3-8B51-C88FCF54400F}"/>
               </a:ext>
             </a:extLst>
           </p:cNvPr>
@@ -14343,7 +14343,7 @@
           <p:cNvPr id="8" name="">
             <a:extLst xmlns:a="http://schemas.openxmlformats.org/drawingml/2006/main">
               <a:ext uri="{FF2B5EF4-FFF2-40B4-BE49-F238E27FC236}">
-                <a16:creationId xmlns:a16="http://schemas.microsoft.com/office/drawing/2014/main" id="{28471CDB-E5D3-4C4B-BBB7-068CBDBB3A4A}"/>
+                <a16:creationId xmlns:a16="http://schemas.microsoft.com/office/drawing/2014/main" id="{15C8DCE0-4929-48E0-83C4-1373F8A6EFEE}"/>
               </a:ext>
             </a:extLst>
           </p:cNvPr>
@@ -14354,7 +14354,7 @@
         </p:nvSpPr>
         <p:spPr>
           <a:xfrm xmlns:a="http://schemas.openxmlformats.org/drawingml/2006/main">
-            <a:off x="9572625" y="2628900"/>
+            <a:off x="10191750" y="2905125"/>
             <a:ext cx="1714500" cy="400050"/>
           </a:xfrm>
           <a:prstGeom xmlns:a="http://schemas.openxmlformats.org/drawingml/2006/main" prst="rect">
@@ -14499,7 +14499,7 @@
           <p:cNvPr id="9" name="">
             <a:extLst xmlns:a="http://schemas.openxmlformats.org/drawingml/2006/main">
               <a:ext uri="{FF2B5EF4-FFF2-40B4-BE49-F238E27FC236}">
-                <a16:creationId xmlns:a16="http://schemas.microsoft.com/office/drawing/2014/main" id="{83B0F499-D6E0-4C86-A7C4-8633DA431EDD}"/>
+                <a16:creationId xmlns:a16="http://schemas.microsoft.com/office/drawing/2014/main" id="{4D4F1C0D-8A98-4DA3-BB1E-77E5CF97DE38}"/>
               </a:ext>
             </a:extLst>
           </p:cNvPr>
@@ -14655,7 +14655,7 @@
           <p:cNvPr id="10" name="">
             <a:extLst xmlns:a="http://schemas.openxmlformats.org/drawingml/2006/main">
               <a:ext uri="{FF2B5EF4-FFF2-40B4-BE49-F238E27FC236}">
-                <a16:creationId xmlns:a16="http://schemas.microsoft.com/office/drawing/2014/main" id="{98DD7BFC-DD03-4D3B-A893-8ECF819D6279}"/>
+                <a16:creationId xmlns:a16="http://schemas.microsoft.com/office/drawing/2014/main" id="{5EDDFF09-2D81-4956-A40A-3ECF40906D97}"/>
               </a:ext>
             </a:extLst>
           </p:cNvPr>
@@ -14809,7 +14809,7 @@
     </p:spTree>
     <p:extLst>
       <p:ext uri="{BB962C8B-B14F-4D97-AF65-F5344CB8AC3E}">
-        <p14:creationId xmlns:p14="http://schemas.microsoft.com/office/powerpoint/2010/main" val="557625583"/>
+        <p14:creationId xmlns:p14="http://schemas.microsoft.com/office/powerpoint/2010/main" val="520825701"/>
       </p:ext>
     </p:extLst>
   </p:cSld>
@@ -14840,7 +14840,7 @@
           <p:cNvPr id="8" name="">
             <a:extLst xmlns:a="http://schemas.openxmlformats.org/drawingml/2006/main">
               <a:ext uri="{FF2B5EF4-FFF2-40B4-BE49-F238E27FC236}">
-                <a16:creationId xmlns:a16="http://schemas.microsoft.com/office/drawing/2014/main" id="{7689A0F2-85B5-42E8-B7CB-CD5B23DC6EF4}"/>
+                <a16:creationId xmlns:a16="http://schemas.microsoft.com/office/drawing/2014/main" id="{CA8A24EE-8985-4818-B539-65AF871DA9A6}"/>
               </a:ext>
             </a:extLst>
           </p:cNvPr>
@@ -14996,7 +14996,7 @@
           <p:cNvPr id="2" name="">
             <a:extLst xmlns:a="http://schemas.openxmlformats.org/drawingml/2006/main">
               <a:ext uri="{FF2B5EF4-FFF2-40B4-BE49-F238E27FC236}">
-                <a16:creationId xmlns:a16="http://schemas.microsoft.com/office/drawing/2014/main" id="{379706AF-7557-47B4-B97D-DDD7E5B980C3}"/>
+                <a16:creationId xmlns:a16="http://schemas.microsoft.com/office/drawing/2014/main" id="{EBC2686E-1C0D-4D91-A1B1-E7283576A76E}"/>
               </a:ext>
             </a:extLst>
           </p:cNvPr>
@@ -15152,7 +15152,7 @@
           <p:cNvPr id="3" name="">
             <a:extLst xmlns:a="http://schemas.openxmlformats.org/drawingml/2006/main">
               <a:ext uri="{FF2B5EF4-FFF2-40B4-BE49-F238E27FC236}">
-                <a16:creationId xmlns:a16="http://schemas.microsoft.com/office/drawing/2014/main" id="{B6475353-2F63-40BD-BAC9-F17052DDB409}"/>
+                <a16:creationId xmlns:a16="http://schemas.microsoft.com/office/drawing/2014/main" id="{39513461-439F-405F-A045-5702CC1DB2E4}"/>
               </a:ext>
             </a:extLst>
           </p:cNvPr>
@@ -15308,7 +15308,7 @@
           <p:cNvPr id="4" name="">
             <a:extLst xmlns:a="http://schemas.openxmlformats.org/drawingml/2006/main">
               <a:ext uri="{FF2B5EF4-FFF2-40B4-BE49-F238E27FC236}">
-                <a16:creationId xmlns:a16="http://schemas.microsoft.com/office/drawing/2014/main" id="{D10D5E0F-BFA1-4039-A310-BFBF48008241}"/>
+                <a16:creationId xmlns:a16="http://schemas.microsoft.com/office/drawing/2014/main" id="{FB6DC46A-0ADA-4950-BB59-31CF51188483}"/>
               </a:ext>
             </a:extLst>
           </p:cNvPr>
@@ -15464,7 +15464,7 @@
           <p:cNvPr id="5" name="">
             <a:extLst xmlns:a="http://schemas.openxmlformats.org/drawingml/2006/main">
               <a:ext uri="{FF2B5EF4-FFF2-40B4-BE49-F238E27FC236}">
-                <a16:creationId xmlns:a16="http://schemas.microsoft.com/office/drawing/2014/main" id="{92E97FA1-7CB9-4D4A-8F5C-EE38B0D9EE07}"/>
+                <a16:creationId xmlns:a16="http://schemas.microsoft.com/office/drawing/2014/main" id="{201B2DED-0961-4507-9B08-604CCEE94A10}"/>
               </a:ext>
             </a:extLst>
           </p:cNvPr>
@@ -15620,7 +15620,7 @@
           <p:cNvPr id="6" name="">
             <a:extLst xmlns:a="http://schemas.openxmlformats.org/drawingml/2006/main">
               <a:ext uri="{FF2B5EF4-FFF2-40B4-BE49-F238E27FC236}">
-                <a16:creationId xmlns:a16="http://schemas.microsoft.com/office/drawing/2014/main" id="{82EA4CA7-EDC2-477B-8136-470D04DEB8C4}"/>
+                <a16:creationId xmlns:a16="http://schemas.microsoft.com/office/drawing/2014/main" id="{FADE6C02-0CA0-4060-9661-D20576FB330B}"/>
               </a:ext>
             </a:extLst>
           </p:cNvPr>
@@ -15776,7 +15776,7 @@
           <p:cNvPr id="7" name="">
             <a:extLst xmlns:a="http://schemas.openxmlformats.org/drawingml/2006/main">
               <a:ext uri="{FF2B5EF4-FFF2-40B4-BE49-F238E27FC236}">
-                <a16:creationId xmlns:a16="http://schemas.microsoft.com/office/drawing/2014/main" id="{B1B3CD53-14FE-44B9-A9FF-F8CC0DF54BFD}"/>
+                <a16:creationId xmlns:a16="http://schemas.microsoft.com/office/drawing/2014/main" id="{68A489C3-4971-4F66-9264-551C7E4B5D94}"/>
               </a:ext>
             </a:extLst>
           </p:cNvPr>
@@ -15930,7 +15930,7 @@
     </p:spTree>
     <p:extLst>
       <p:ext uri="{BB962C8B-B14F-4D97-AF65-F5344CB8AC3E}">
-        <p14:creationId xmlns:p14="http://schemas.microsoft.com/office/powerpoint/2010/main" val="690293515"/>
+        <p14:creationId xmlns:p14="http://schemas.microsoft.com/office/powerpoint/2010/main" val="1973437686"/>
       </p:ext>
     </p:extLst>
   </p:cSld>
@@ -15961,7 +15961,7 @@
           <p:cNvPr id="13" name="">
             <a:extLst xmlns:a="http://schemas.openxmlformats.org/drawingml/2006/main">
               <a:ext uri="{FF2B5EF4-FFF2-40B4-BE49-F238E27FC236}">
-                <a16:creationId xmlns:a16="http://schemas.microsoft.com/office/drawing/2014/main" id="{305FF00B-EB40-4510-9A87-1AECB6049E7E}"/>
+                <a16:creationId xmlns:a16="http://schemas.microsoft.com/office/drawing/2014/main" id="{D5E4CF24-5D77-4DD1-906D-B79FCD2769EC}"/>
               </a:ext>
             </a:extLst>
           </p:cNvPr>
@@ -16117,7 +16117,7 @@
           <p:cNvPr id="2" name="">
             <a:extLst xmlns:a="http://schemas.openxmlformats.org/drawingml/2006/main">
               <a:ext uri="{FF2B5EF4-FFF2-40B4-BE49-F238E27FC236}">
-                <a16:creationId xmlns:a16="http://schemas.microsoft.com/office/drawing/2014/main" id="{19CCA025-C062-4CF2-B1D8-F5E750C9D665}"/>
+                <a16:creationId xmlns:a16="http://schemas.microsoft.com/office/drawing/2014/main" id="{A621FF7E-9CDE-4AEF-86FF-FC0F77C128C9}"/>
               </a:ext>
             </a:extLst>
           </p:cNvPr>
@@ -16273,7 +16273,7 @@
           <p:cNvPr id="3" name="">
             <a:extLst xmlns:a="http://schemas.openxmlformats.org/drawingml/2006/main">
               <a:ext uri="{FF2B5EF4-FFF2-40B4-BE49-F238E27FC236}">
-                <a16:creationId xmlns:a16="http://schemas.microsoft.com/office/drawing/2014/main" id="{3F6C8828-F024-4C9E-B532-1E7C2EACFDA9}"/>
+                <a16:creationId xmlns:a16="http://schemas.microsoft.com/office/drawing/2014/main" id="{007D2EDD-66C0-4FD6-8849-0A626EF40A61}"/>
               </a:ext>
             </a:extLst>
           </p:cNvPr>
@@ -16429,7 +16429,7 @@
           <p:cNvPr id="4" name="">
             <a:extLst xmlns:a="http://schemas.openxmlformats.org/drawingml/2006/main">
               <a:ext uri="{FF2B5EF4-FFF2-40B4-BE49-F238E27FC236}">
-                <a16:creationId xmlns:a16="http://schemas.microsoft.com/office/drawing/2014/main" id="{F684306D-E368-44FA-BC0A-DAD6D3B96509}"/>
+                <a16:creationId xmlns:a16="http://schemas.microsoft.com/office/drawing/2014/main" id="{A2D68A39-54F8-4D07-B09D-6D153075A752}"/>
               </a:ext>
             </a:extLst>
           </p:cNvPr>
@@ -16585,7 +16585,7 @@
           <p:cNvPr id="5" name="">
             <a:extLst xmlns:a="http://schemas.openxmlformats.org/drawingml/2006/main">
               <a:ext uri="{FF2B5EF4-FFF2-40B4-BE49-F238E27FC236}">
-                <a16:creationId xmlns:a16="http://schemas.microsoft.com/office/drawing/2014/main" id="{CFC5072F-78A8-4900-877E-3FE2C76FC297}"/>
+                <a16:creationId xmlns:a16="http://schemas.microsoft.com/office/drawing/2014/main" id="{4BC4FC38-ABCF-4F2B-A1BF-A2236C62F98D}"/>
               </a:ext>
             </a:extLst>
           </p:cNvPr>
@@ -16741,7 +16741,7 @@
           <p:cNvPr id="6" name="">
             <a:extLst xmlns:a="http://schemas.openxmlformats.org/drawingml/2006/main">
               <a:ext uri="{FF2B5EF4-FFF2-40B4-BE49-F238E27FC236}">
-                <a16:creationId xmlns:a16="http://schemas.microsoft.com/office/drawing/2014/main" id="{5FA41D19-BD42-4CDC-8DF7-1C7C7231C118}"/>
+                <a16:creationId xmlns:a16="http://schemas.microsoft.com/office/drawing/2014/main" id="{3E413DBD-EC65-4D5A-875D-FEF587E51B97}"/>
               </a:ext>
             </a:extLst>
           </p:cNvPr>
@@ -16771,7 +16771,7 @@
           <p:cNvPr id="7" name="">
             <a:extLst xmlns:a="http://schemas.openxmlformats.org/drawingml/2006/main">
               <a:ext uri="{FF2B5EF4-FFF2-40B4-BE49-F238E27FC236}">
-                <a16:creationId xmlns:a16="http://schemas.microsoft.com/office/drawing/2014/main" id="{C8A8C962-08E3-49ED-912D-202B6F8FD27F}"/>
+                <a16:creationId xmlns:a16="http://schemas.microsoft.com/office/drawing/2014/main" id="{F23B6179-37AD-42FD-B75D-134A027B64FA}"/>
               </a:ext>
             </a:extLst>
           </p:cNvPr>
@@ -17025,7 +17025,7 @@
           <p:cNvPr id="8" name="">
             <a:extLst xmlns:a="http://schemas.openxmlformats.org/drawingml/2006/main">
               <a:ext uri="{FF2B5EF4-FFF2-40B4-BE49-F238E27FC236}">
-                <a16:creationId xmlns:a16="http://schemas.microsoft.com/office/drawing/2014/main" id="{55BA52C1-57B8-4482-9730-6D600C8ED4D2}"/>
+                <a16:creationId xmlns:a16="http://schemas.microsoft.com/office/drawing/2014/main" id="{7CC9A27B-25BA-4E22-951A-0EEA3383BD8A}"/>
               </a:ext>
             </a:extLst>
           </p:cNvPr>
@@ -17181,7 +17181,7 @@
           <p:cNvPr id="9" name="">
             <a:extLst xmlns:a="http://schemas.openxmlformats.org/drawingml/2006/main">
               <a:ext uri="{FF2B5EF4-FFF2-40B4-BE49-F238E27FC236}">
-                <a16:creationId xmlns:a16="http://schemas.microsoft.com/office/drawing/2014/main" id="{E124B3E4-D347-4227-A8F0-F1181A7DAC47}"/>
+                <a16:creationId xmlns:a16="http://schemas.microsoft.com/office/drawing/2014/main" id="{CC4BA97F-486C-48B5-A726-75175F09F17A}"/>
               </a:ext>
             </a:extLst>
           </p:cNvPr>
@@ -17337,7 +17337,7 @@
           <p:cNvPr id="10" name="">
             <a:extLst xmlns:a="http://schemas.openxmlformats.org/drawingml/2006/main">
               <a:ext uri="{FF2B5EF4-FFF2-40B4-BE49-F238E27FC236}">
-                <a16:creationId xmlns:a16="http://schemas.microsoft.com/office/drawing/2014/main" id="{D016E073-0208-4582-A725-82D370C733F5}"/>
+                <a16:creationId xmlns:a16="http://schemas.microsoft.com/office/drawing/2014/main" id="{C75A70D3-FBD4-4567-8449-D128EF8BB955}"/>
               </a:ext>
             </a:extLst>
           </p:cNvPr>
@@ -17348,7 +17348,7 @@
         </p:nvSpPr>
         <p:spPr>
           <a:xfrm xmlns:a="http://schemas.openxmlformats.org/drawingml/2006/main">
-            <a:off x="9572625" y="2628900"/>
+            <a:off x="10191750" y="2905125"/>
             <a:ext cx="1714500" cy="400050"/>
           </a:xfrm>
           <a:prstGeom xmlns:a="http://schemas.openxmlformats.org/drawingml/2006/main" prst="rect">
@@ -17493,7 +17493,7 @@
           <p:cNvPr id="11" name="">
             <a:extLst xmlns:a="http://schemas.openxmlformats.org/drawingml/2006/main">
               <a:ext uri="{FF2B5EF4-FFF2-40B4-BE49-F238E27FC236}">
-                <a16:creationId xmlns:a16="http://schemas.microsoft.com/office/drawing/2014/main" id="{DAFCB178-5FEE-48DA-81BA-876EB9BE938C}"/>
+                <a16:creationId xmlns:a16="http://schemas.microsoft.com/office/drawing/2014/main" id="{D837590E-3119-41DE-A3A9-37571CDF4D7A}"/>
               </a:ext>
             </a:extLst>
           </p:cNvPr>
@@ -17649,7 +17649,7 @@
           <p:cNvPr id="12" name="">
             <a:extLst xmlns:a="http://schemas.openxmlformats.org/drawingml/2006/main">
               <a:ext uri="{FF2B5EF4-FFF2-40B4-BE49-F238E27FC236}">
-                <a16:creationId xmlns:a16="http://schemas.microsoft.com/office/drawing/2014/main" id="{29AEE0E3-29BE-432B-BD6F-BF2550B918DC}"/>
+                <a16:creationId xmlns:a16="http://schemas.microsoft.com/office/drawing/2014/main" id="{2B8649EB-0E78-4D2C-BDAD-D7E3FEB54807}"/>
               </a:ext>
             </a:extLst>
           </p:cNvPr>
@@ -17803,7 +17803,7 @@
     </p:spTree>
     <p:extLst>
       <p:ext uri="{BB962C8B-B14F-4D97-AF65-F5344CB8AC3E}">
-        <p14:creationId xmlns:p14="http://schemas.microsoft.com/office/powerpoint/2010/main" val="585474389"/>
+        <p14:creationId xmlns:p14="http://schemas.microsoft.com/office/powerpoint/2010/main" val="304751344"/>
       </p:ext>
     </p:extLst>
   </p:cSld>
@@ -17834,7 +17834,7 @@
           <p:cNvPr id="8" name="">
             <a:extLst xmlns:a="http://schemas.openxmlformats.org/drawingml/2006/main">
               <a:ext uri="{FF2B5EF4-FFF2-40B4-BE49-F238E27FC236}">
-                <a16:creationId xmlns:a16="http://schemas.microsoft.com/office/drawing/2014/main" id="{FE89DBDE-CF96-4498-9BE1-2818490E7529}"/>
+                <a16:creationId xmlns:a16="http://schemas.microsoft.com/office/drawing/2014/main" id="{F7A74E3C-5B8B-42E5-8501-3288E7ED9675}"/>
               </a:ext>
             </a:extLst>
           </p:cNvPr>
@@ -17990,7 +17990,7 @@
           <p:cNvPr id="2" name="">
             <a:extLst xmlns:a="http://schemas.openxmlformats.org/drawingml/2006/main">
               <a:ext uri="{FF2B5EF4-FFF2-40B4-BE49-F238E27FC236}">
-                <a16:creationId xmlns:a16="http://schemas.microsoft.com/office/drawing/2014/main" id="{67058937-5DF8-40F6-8D5F-86C610ECE01A}"/>
+                <a16:creationId xmlns:a16="http://schemas.microsoft.com/office/drawing/2014/main" id="{C47D7E5B-EFB9-4384-BCF3-13935C4F3578}"/>
               </a:ext>
             </a:extLst>
           </p:cNvPr>
@@ -18146,7 +18146,7 @@
           <p:cNvPr id="3" name="">
             <a:extLst xmlns:a="http://schemas.openxmlformats.org/drawingml/2006/main">
               <a:ext uri="{FF2B5EF4-FFF2-40B4-BE49-F238E27FC236}">
-                <a16:creationId xmlns:a16="http://schemas.microsoft.com/office/drawing/2014/main" id="{FAB76236-4C32-4EE3-AEFC-1786BD9F95DA}"/>
+                <a16:creationId xmlns:a16="http://schemas.microsoft.com/office/drawing/2014/main" id="{FF7B0F6C-E638-4E07-B1EF-103AA4E6855F}"/>
               </a:ext>
             </a:extLst>
           </p:cNvPr>
@@ -18302,7 +18302,7 @@
           <p:cNvPr id="4" name="">
             <a:extLst xmlns:a="http://schemas.openxmlformats.org/drawingml/2006/main">
               <a:ext uri="{FF2B5EF4-FFF2-40B4-BE49-F238E27FC236}">
-                <a16:creationId xmlns:a16="http://schemas.microsoft.com/office/drawing/2014/main" id="{C7A5415D-0245-4834-91EF-EA123F720317}"/>
+                <a16:creationId xmlns:a16="http://schemas.microsoft.com/office/drawing/2014/main" id="{5A046953-1F12-4A17-A05B-3465876E7E65}"/>
               </a:ext>
             </a:extLst>
           </p:cNvPr>
@@ -18458,7 +18458,7 @@
           <p:cNvPr id="5" name="">
             <a:extLst xmlns:a="http://schemas.openxmlformats.org/drawingml/2006/main">
               <a:ext uri="{FF2B5EF4-FFF2-40B4-BE49-F238E27FC236}">
-                <a16:creationId xmlns:a16="http://schemas.microsoft.com/office/drawing/2014/main" id="{1F7771BF-B1E0-4710-A375-ACB322794F52}"/>
+                <a16:creationId xmlns:a16="http://schemas.microsoft.com/office/drawing/2014/main" id="{05CABEA1-A82B-4575-AB49-1D6FE3464BD3}"/>
               </a:ext>
             </a:extLst>
           </p:cNvPr>
@@ -18614,7 +18614,7 @@
           <p:cNvPr id="6" name="">
             <a:extLst xmlns:a="http://schemas.openxmlformats.org/drawingml/2006/main">
               <a:ext uri="{FF2B5EF4-FFF2-40B4-BE49-F238E27FC236}">
-                <a16:creationId xmlns:a16="http://schemas.microsoft.com/office/drawing/2014/main" id="{6AE7D4E7-2F97-4587-891A-AD2EE70D89F5}"/>
+                <a16:creationId xmlns:a16="http://schemas.microsoft.com/office/drawing/2014/main" id="{D72826E7-AFE3-4533-B6B6-F24E8ADB1E62}"/>
               </a:ext>
             </a:extLst>
           </p:cNvPr>
@@ -18770,7 +18770,7 @@
           <p:cNvPr id="7" name="">
             <a:extLst xmlns:a="http://schemas.openxmlformats.org/drawingml/2006/main">
               <a:ext uri="{FF2B5EF4-FFF2-40B4-BE49-F238E27FC236}">
-                <a16:creationId xmlns:a16="http://schemas.microsoft.com/office/drawing/2014/main" id="{4D8FE114-E5E6-4B3E-B4DE-EADA922D865C}"/>
+                <a16:creationId xmlns:a16="http://schemas.microsoft.com/office/drawing/2014/main" id="{E919ACEC-1386-445E-B990-C250E1ED7E98}"/>
               </a:ext>
             </a:extLst>
           </p:cNvPr>
@@ -18924,7 +18924,7 @@
     </p:spTree>
     <p:extLst>
       <p:ext uri="{BB962C8B-B14F-4D97-AF65-F5344CB8AC3E}">
-        <p14:creationId xmlns:p14="http://schemas.microsoft.com/office/powerpoint/2010/main" val="408120777"/>
+        <p14:creationId xmlns:p14="http://schemas.microsoft.com/office/powerpoint/2010/main" val="1956649856"/>
       </p:ext>
     </p:extLst>
   </p:cSld>
@@ -18955,7 +18955,7 @@
           <p:cNvPr id="6" name="">
             <a:extLst xmlns:a="http://schemas.openxmlformats.org/drawingml/2006/main">
               <a:ext uri="{FF2B5EF4-FFF2-40B4-BE49-F238E27FC236}">
-                <a16:creationId xmlns:a16="http://schemas.microsoft.com/office/drawing/2014/main" id="{DD37BEE4-9F8F-4821-A3B5-4FE9A3DC20A8}"/>
+                <a16:creationId xmlns:a16="http://schemas.microsoft.com/office/drawing/2014/main" id="{A5FB394A-F0BA-4D95-875C-3BBC1BC3C6D4}"/>
               </a:ext>
             </a:extLst>
           </p:cNvPr>
@@ -19111,7 +19111,7 @@
           <p:cNvPr id="2" name="">
             <a:extLst xmlns:a="http://schemas.openxmlformats.org/drawingml/2006/main">
               <a:ext uri="{FF2B5EF4-FFF2-40B4-BE49-F238E27FC236}">
-                <a16:creationId xmlns:a16="http://schemas.microsoft.com/office/drawing/2014/main" id="{8BC03AFB-454F-4944-B584-86027E9E618D}"/>
+                <a16:creationId xmlns:a16="http://schemas.microsoft.com/office/drawing/2014/main" id="{41B0A252-E19D-448E-B291-030308439F82}"/>
               </a:ext>
             </a:extLst>
           </p:cNvPr>
@@ -19267,7 +19267,7 @@
           <p:cNvPr id="3" name="">
             <a:extLst xmlns:a="http://schemas.openxmlformats.org/drawingml/2006/main">
               <a:ext uri="{FF2B5EF4-FFF2-40B4-BE49-F238E27FC236}">
-                <a16:creationId xmlns:a16="http://schemas.microsoft.com/office/drawing/2014/main" id="{43E2EDF4-0F2D-4163-82C9-1DAC449C3107}"/>
+                <a16:creationId xmlns:a16="http://schemas.microsoft.com/office/drawing/2014/main" id="{5E61778A-6827-4DA1-9651-5B47301DCDAC}"/>
               </a:ext>
             </a:extLst>
           </p:cNvPr>
@@ -19423,7 +19423,7 @@
           <p:cNvPr id="4" name="">
             <a:extLst xmlns:a="http://schemas.openxmlformats.org/drawingml/2006/main">
               <a:ext uri="{FF2B5EF4-FFF2-40B4-BE49-F238E27FC236}">
-                <a16:creationId xmlns:a16="http://schemas.microsoft.com/office/drawing/2014/main" id="{CE84B1F4-9700-4FBC-8FB0-EE318E621FFE}"/>
+                <a16:creationId xmlns:a16="http://schemas.microsoft.com/office/drawing/2014/main" id="{60C7EEAC-0131-4FF6-994E-FED8E49815D5}"/>
               </a:ext>
             </a:extLst>
           </p:cNvPr>
@@ -19579,7 +19579,7 @@
           <p:cNvPr id="5" name="">
             <a:extLst xmlns:a="http://schemas.openxmlformats.org/drawingml/2006/main">
               <a:ext uri="{FF2B5EF4-FFF2-40B4-BE49-F238E27FC236}">
-                <a16:creationId xmlns:a16="http://schemas.microsoft.com/office/drawing/2014/main" id="{95C94B2E-71B7-4281-AE86-4BC13569C660}"/>
+                <a16:creationId xmlns:a16="http://schemas.microsoft.com/office/drawing/2014/main" id="{ACF711DD-39F8-456B-B4A1-6210198A7847}"/>
               </a:ext>
             </a:extLst>
           </p:cNvPr>
@@ -19733,7 +19733,7 @@
     </p:spTree>
     <p:extLst>
       <p:ext uri="{BB962C8B-B14F-4D97-AF65-F5344CB8AC3E}">
-        <p14:creationId xmlns:p14="http://schemas.microsoft.com/office/powerpoint/2010/main" val="1446994363"/>
+        <p14:creationId xmlns:p14="http://schemas.microsoft.com/office/powerpoint/2010/main" val="1497563004"/>
       </p:ext>
     </p:extLst>
   </p:cSld>
@@ -19764,7 +19764,7 @@
           <p:cNvPr id="13" name="">
             <a:extLst xmlns:a="http://schemas.openxmlformats.org/drawingml/2006/main">
               <a:ext uri="{FF2B5EF4-FFF2-40B4-BE49-F238E27FC236}">
-                <a16:creationId xmlns:a16="http://schemas.microsoft.com/office/drawing/2014/main" id="{E0F52966-5463-4DE0-A35B-41A899E4FB61}"/>
+                <a16:creationId xmlns:a16="http://schemas.microsoft.com/office/drawing/2014/main" id="{28672247-567D-410B-85E9-0E81B75A2503}"/>
               </a:ext>
             </a:extLst>
           </p:cNvPr>
@@ -19920,7 +19920,7 @@
           <p:cNvPr id="2" name="">
             <a:extLst xmlns:a="http://schemas.openxmlformats.org/drawingml/2006/main">
               <a:ext uri="{FF2B5EF4-FFF2-40B4-BE49-F238E27FC236}">
-                <a16:creationId xmlns:a16="http://schemas.microsoft.com/office/drawing/2014/main" id="{BD52B19A-A22F-4205-BA75-5DA675D4BFCA}"/>
+                <a16:creationId xmlns:a16="http://schemas.microsoft.com/office/drawing/2014/main" id="{4B9A9884-0D6A-44A2-8982-0089279D696E}"/>
               </a:ext>
             </a:extLst>
           </p:cNvPr>
@@ -20076,7 +20076,7 @@
           <p:cNvPr id="3" name="">
             <a:extLst xmlns:a="http://schemas.openxmlformats.org/drawingml/2006/main">
               <a:ext uri="{FF2B5EF4-FFF2-40B4-BE49-F238E27FC236}">
-                <a16:creationId xmlns:a16="http://schemas.microsoft.com/office/drawing/2014/main" id="{86D5AE6F-C89B-4524-822E-2E0DB6BC938F}"/>
+                <a16:creationId xmlns:a16="http://schemas.microsoft.com/office/drawing/2014/main" id="{5543C129-E269-4936-8FB4-895DEB460F74}"/>
               </a:ext>
             </a:extLst>
           </p:cNvPr>
@@ -20232,7 +20232,7 @@
           <p:cNvPr id="4" name="">
             <a:extLst xmlns:a="http://schemas.openxmlformats.org/drawingml/2006/main">
               <a:ext uri="{FF2B5EF4-FFF2-40B4-BE49-F238E27FC236}">
-                <a16:creationId xmlns:a16="http://schemas.microsoft.com/office/drawing/2014/main" id="{5C7BCEDB-18B0-4573-803D-4BAC378E6AAE}"/>
+                <a16:creationId xmlns:a16="http://schemas.microsoft.com/office/drawing/2014/main" id="{8F164AE6-F178-48DE-8F7A-240CBF7F7D87}"/>
               </a:ext>
             </a:extLst>
           </p:cNvPr>
@@ -20388,7 +20388,7 @@
           <p:cNvPr id="5" name="">
             <a:extLst xmlns:a="http://schemas.openxmlformats.org/drawingml/2006/main">
               <a:ext uri="{FF2B5EF4-FFF2-40B4-BE49-F238E27FC236}">
-                <a16:creationId xmlns:a16="http://schemas.microsoft.com/office/drawing/2014/main" id="{88CF886B-B3B3-45D0-ACF6-E00255A36F5E}"/>
+                <a16:creationId xmlns:a16="http://schemas.microsoft.com/office/drawing/2014/main" id="{2AACDAA7-31B6-49E9-B031-6F0750176758}"/>
               </a:ext>
             </a:extLst>
           </p:cNvPr>
@@ -20544,7 +20544,7 @@
           <p:cNvPr id="6" name="">
             <a:extLst xmlns:a="http://schemas.openxmlformats.org/drawingml/2006/main">
               <a:ext uri="{FF2B5EF4-FFF2-40B4-BE49-F238E27FC236}">
-                <a16:creationId xmlns:a16="http://schemas.microsoft.com/office/drawing/2014/main" id="{0154B047-9EE8-4101-9E37-64A8E3574A6D}"/>
+                <a16:creationId xmlns:a16="http://schemas.microsoft.com/office/drawing/2014/main" id="{BDB5F477-3FDD-4D23-943D-C5D24F1EBD19}"/>
               </a:ext>
             </a:extLst>
           </p:cNvPr>
@@ -20574,7 +20574,7 @@
           <p:cNvPr id="7" name="">
             <a:extLst xmlns:a="http://schemas.openxmlformats.org/drawingml/2006/main">
               <a:ext uri="{FF2B5EF4-FFF2-40B4-BE49-F238E27FC236}">
-                <a16:creationId xmlns:a16="http://schemas.microsoft.com/office/drawing/2014/main" id="{48C20ABB-BF28-45BA-9F05-0C64B55C5746}"/>
+                <a16:creationId xmlns:a16="http://schemas.microsoft.com/office/drawing/2014/main" id="{75260319-6097-4EEB-9D31-BE3F0067D29C}"/>
               </a:ext>
             </a:extLst>
           </p:cNvPr>
@@ -20828,7 +20828,7 @@
           <p:cNvPr id="8" name="">
             <a:extLst xmlns:a="http://schemas.openxmlformats.org/drawingml/2006/main">
               <a:ext uri="{FF2B5EF4-FFF2-40B4-BE49-F238E27FC236}">
-                <a16:creationId xmlns:a16="http://schemas.microsoft.com/office/drawing/2014/main" id="{32B293B9-8665-4952-80AF-46AB3E1B5E7C}"/>
+                <a16:creationId xmlns:a16="http://schemas.microsoft.com/office/drawing/2014/main" id="{086F1CF3-0C4B-44D1-A476-D03093BC366E}"/>
               </a:ext>
             </a:extLst>
           </p:cNvPr>
@@ -20984,7 +20984,7 @@
           <p:cNvPr id="9" name="">
             <a:extLst xmlns:a="http://schemas.openxmlformats.org/drawingml/2006/main">
               <a:ext uri="{FF2B5EF4-FFF2-40B4-BE49-F238E27FC236}">
-                <a16:creationId xmlns:a16="http://schemas.microsoft.com/office/drawing/2014/main" id="{4413FA7B-F5CF-4150-8234-901A19CCBEE1}"/>
+                <a16:creationId xmlns:a16="http://schemas.microsoft.com/office/drawing/2014/main" id="{8A5E0808-AC85-49C4-A42A-A8D45E4DC78E}"/>
               </a:ext>
             </a:extLst>
           </p:cNvPr>
@@ -21140,7 +21140,7 @@
           <p:cNvPr id="10" name="">
             <a:extLst xmlns:a="http://schemas.openxmlformats.org/drawingml/2006/main">
               <a:ext uri="{FF2B5EF4-FFF2-40B4-BE49-F238E27FC236}">
-                <a16:creationId xmlns:a16="http://schemas.microsoft.com/office/drawing/2014/main" id="{AC011CBC-EC69-41EF-86A6-C21EB2C7CEEC}"/>
+                <a16:creationId xmlns:a16="http://schemas.microsoft.com/office/drawing/2014/main" id="{FDE27BF8-D54B-43D8-82B0-5709EC376640}"/>
               </a:ext>
             </a:extLst>
           </p:cNvPr>
@@ -21296,7 +21296,7 @@
           <p:cNvPr id="11" name="">
             <a:extLst xmlns:a="http://schemas.openxmlformats.org/drawingml/2006/main">
               <a:ext uri="{FF2B5EF4-FFF2-40B4-BE49-F238E27FC236}">
-                <a16:creationId xmlns:a16="http://schemas.microsoft.com/office/drawing/2014/main" id="{E6B4F452-521E-43F6-97EB-7160C3B90B9E}"/>
+                <a16:creationId xmlns:a16="http://schemas.microsoft.com/office/drawing/2014/main" id="{A2EEE696-C163-495A-AC1E-60DA44870DCF}"/>
               </a:ext>
             </a:extLst>
           </p:cNvPr>
@@ -21452,7 +21452,7 @@
           <p:cNvPr id="12" name="">
             <a:extLst xmlns:a="http://schemas.openxmlformats.org/drawingml/2006/main">
               <a:ext uri="{FF2B5EF4-FFF2-40B4-BE49-F238E27FC236}">
-                <a16:creationId xmlns:a16="http://schemas.microsoft.com/office/drawing/2014/main" id="{1E8F8C58-0E89-4EDD-B3F0-4C9F1B53E4D0}"/>
+                <a16:creationId xmlns:a16="http://schemas.microsoft.com/office/drawing/2014/main" id="{B6656C0E-112D-49AE-ACE2-C0CEC64551F3}"/>
               </a:ext>
             </a:extLst>
           </p:cNvPr>
@@ -21606,7 +21606,7 @@
     </p:spTree>
     <p:extLst>
       <p:ext uri="{BB962C8B-B14F-4D97-AF65-F5344CB8AC3E}">
-        <p14:creationId xmlns:p14="http://schemas.microsoft.com/office/powerpoint/2010/main" val="664437670"/>
+        <p14:creationId xmlns:p14="http://schemas.microsoft.com/office/powerpoint/2010/main" val="881016575"/>
       </p:ext>
     </p:extLst>
   </p:cSld>
@@ -21637,7 +21637,7 @@
           <p:cNvPr id="12" name="">
             <a:extLst xmlns:a="http://schemas.openxmlformats.org/drawingml/2006/main">
               <a:ext uri="{FF2B5EF4-FFF2-40B4-BE49-F238E27FC236}">
-                <a16:creationId xmlns:a16="http://schemas.microsoft.com/office/drawing/2014/main" id="{0E66FA2B-2AC6-4820-A932-F420FA94FF7C}"/>
+                <a16:creationId xmlns:a16="http://schemas.microsoft.com/office/drawing/2014/main" id="{91E4773B-CA81-4E91-9280-372250032901}"/>
               </a:ext>
             </a:extLst>
           </p:cNvPr>
@@ -21793,7 +21793,7 @@
           <p:cNvPr id="2" name="">
             <a:extLst xmlns:a="http://schemas.openxmlformats.org/drawingml/2006/main">
               <a:ext uri="{FF2B5EF4-FFF2-40B4-BE49-F238E27FC236}">
-                <a16:creationId xmlns:a16="http://schemas.microsoft.com/office/drawing/2014/main" id="{461EB442-840E-4C0E-92E6-125126D9D931}"/>
+                <a16:creationId xmlns:a16="http://schemas.microsoft.com/office/drawing/2014/main" id="{528A82C6-1CA2-40F2-8A28-0BFD6EE4E593}"/>
               </a:ext>
             </a:extLst>
           </p:cNvPr>
@@ -21949,7 +21949,7 @@
           <p:cNvPr id="3" name="">
             <a:extLst xmlns:a="http://schemas.openxmlformats.org/drawingml/2006/main">
               <a:ext uri="{FF2B5EF4-FFF2-40B4-BE49-F238E27FC236}">
-                <a16:creationId xmlns:a16="http://schemas.microsoft.com/office/drawing/2014/main" id="{1888ECAA-233C-4600-A1F6-5195F2FC6F9C}"/>
+                <a16:creationId xmlns:a16="http://schemas.microsoft.com/office/drawing/2014/main" id="{79D1026A-22B0-4B5C-8780-9AC3B8699F66}"/>
               </a:ext>
             </a:extLst>
           </p:cNvPr>
@@ -22105,7 +22105,7 @@
           <p:cNvPr id="4" name="">
             <a:extLst xmlns:a="http://schemas.openxmlformats.org/drawingml/2006/main">
               <a:ext uri="{FF2B5EF4-FFF2-40B4-BE49-F238E27FC236}">
-                <a16:creationId xmlns:a16="http://schemas.microsoft.com/office/drawing/2014/main" id="{83A9DD95-2041-4FBE-A97B-CE86E1263A84}"/>
+                <a16:creationId xmlns:a16="http://schemas.microsoft.com/office/drawing/2014/main" id="{3BE93FDC-875D-4DA7-A5E4-F0757E989EDF}"/>
               </a:ext>
             </a:extLst>
           </p:cNvPr>
@@ -22261,7 +22261,7 @@
           <p:cNvPr id="5" name="">
             <a:extLst xmlns:a="http://schemas.openxmlformats.org/drawingml/2006/main">
               <a:ext uri="{FF2B5EF4-FFF2-40B4-BE49-F238E27FC236}">
-                <a16:creationId xmlns:a16="http://schemas.microsoft.com/office/drawing/2014/main" id="{63E49109-CC70-42AE-9B84-6DA5CCCA83FE}"/>
+                <a16:creationId xmlns:a16="http://schemas.microsoft.com/office/drawing/2014/main" id="{01EBEFE5-4904-40BD-9B44-92C22FE8ED4C}"/>
               </a:ext>
             </a:extLst>
           </p:cNvPr>
@@ -22291,7 +22291,7 @@
           <p:cNvPr id="6" name="">
             <a:extLst xmlns:a="http://schemas.openxmlformats.org/drawingml/2006/main">
               <a:ext uri="{FF2B5EF4-FFF2-40B4-BE49-F238E27FC236}">
-                <a16:creationId xmlns:a16="http://schemas.microsoft.com/office/drawing/2014/main" id="{FE588A85-7037-4FAC-B83B-87766A0434F9}"/>
+                <a16:creationId xmlns:a16="http://schemas.microsoft.com/office/drawing/2014/main" id="{1171C6AC-51DC-4480-A3D6-2584AD80E308}"/>
               </a:ext>
             </a:extLst>
           </p:cNvPr>
@@ -22545,7 +22545,7 @@
           <p:cNvPr id="7" name="">
             <a:extLst xmlns:a="http://schemas.openxmlformats.org/drawingml/2006/main">
               <a:ext uri="{FF2B5EF4-FFF2-40B4-BE49-F238E27FC236}">
-                <a16:creationId xmlns:a16="http://schemas.microsoft.com/office/drawing/2014/main" id="{E94ACB52-D1B6-4940-9A99-B1498A6F498F}"/>
+                <a16:creationId xmlns:a16="http://schemas.microsoft.com/office/drawing/2014/main" id="{F46B3BBE-0B51-46BE-885B-0A9B1F2A2501}"/>
               </a:ext>
             </a:extLst>
           </p:cNvPr>
@@ -22701,7 +22701,7 @@
           <p:cNvPr id="8" name="">
             <a:extLst xmlns:a="http://schemas.openxmlformats.org/drawingml/2006/main">
               <a:ext uri="{FF2B5EF4-FFF2-40B4-BE49-F238E27FC236}">
-                <a16:creationId xmlns:a16="http://schemas.microsoft.com/office/drawing/2014/main" id="{B3035F16-0FD8-48F9-9193-A5161E04CD60}"/>
+                <a16:creationId xmlns:a16="http://schemas.microsoft.com/office/drawing/2014/main" id="{393A9EF4-1073-40FF-9F64-E2A506F9B956}"/>
               </a:ext>
             </a:extLst>
           </p:cNvPr>
@@ -22857,7 +22857,7 @@
           <p:cNvPr id="9" name="">
             <a:extLst xmlns:a="http://schemas.openxmlformats.org/drawingml/2006/main">
               <a:ext uri="{FF2B5EF4-FFF2-40B4-BE49-F238E27FC236}">
-                <a16:creationId xmlns:a16="http://schemas.microsoft.com/office/drawing/2014/main" id="{B9AD25B2-5CAB-4A78-92F6-44A0FDA66E69}"/>
+                <a16:creationId xmlns:a16="http://schemas.microsoft.com/office/drawing/2014/main" id="{3FE5EC64-3FB2-43C5-98CB-10F08CED5CC0}"/>
               </a:ext>
             </a:extLst>
           </p:cNvPr>
@@ -23013,7 +23013,7 @@
           <p:cNvPr id="10" name="">
             <a:extLst xmlns:a="http://schemas.openxmlformats.org/drawingml/2006/main">
               <a:ext uri="{FF2B5EF4-FFF2-40B4-BE49-F238E27FC236}">
-                <a16:creationId xmlns:a16="http://schemas.microsoft.com/office/drawing/2014/main" id="{A2FF6822-198A-474D-AFCC-AB30AB8431F8}"/>
+                <a16:creationId xmlns:a16="http://schemas.microsoft.com/office/drawing/2014/main" id="{246A9F88-33BB-4476-956D-89BB44ABC9A0}"/>
               </a:ext>
             </a:extLst>
           </p:cNvPr>
@@ -23169,7 +23169,7 @@
           <p:cNvPr id="11" name="">
             <a:extLst xmlns:a="http://schemas.openxmlformats.org/drawingml/2006/main">
               <a:ext uri="{FF2B5EF4-FFF2-40B4-BE49-F238E27FC236}">
-                <a16:creationId xmlns:a16="http://schemas.microsoft.com/office/drawing/2014/main" id="{14C39B06-C8E8-48FF-BF8A-E61920417C6C}"/>
+                <a16:creationId xmlns:a16="http://schemas.microsoft.com/office/drawing/2014/main" id="{0327E496-B4B3-4D74-8DBA-A123766D977D}"/>
               </a:ext>
             </a:extLst>
           </p:cNvPr>
@@ -23323,7 +23323,7 @@
     </p:spTree>
     <p:extLst>
       <p:ext uri="{BB962C8B-B14F-4D97-AF65-F5344CB8AC3E}">
-        <p14:creationId xmlns:p14="http://schemas.microsoft.com/office/powerpoint/2010/main" val="2065812500"/>
+        <p14:creationId xmlns:p14="http://schemas.microsoft.com/office/powerpoint/2010/main" val="1941120827"/>
       </p:ext>
     </p:extLst>
   </p:cSld>
@@ -23354,7 +23354,7 @@
           <p:cNvPr id="7" name="">
             <a:extLst xmlns:a="http://schemas.openxmlformats.org/drawingml/2006/main">
               <a:ext uri="{FF2B5EF4-FFF2-40B4-BE49-F238E27FC236}">
-                <a16:creationId xmlns:a16="http://schemas.microsoft.com/office/drawing/2014/main" id="{04CADD09-9A8C-42BB-86D7-7DEECAC873DA}"/>
+                <a16:creationId xmlns:a16="http://schemas.microsoft.com/office/drawing/2014/main" id="{302A44E9-2F0E-4587-82C1-5CC614A3E594}"/>
               </a:ext>
             </a:extLst>
           </p:cNvPr>
@@ -23510,7 +23510,7 @@
           <p:cNvPr id="2" name="">
             <a:extLst xmlns:a="http://schemas.openxmlformats.org/drawingml/2006/main">
               <a:ext uri="{FF2B5EF4-FFF2-40B4-BE49-F238E27FC236}">
-                <a16:creationId xmlns:a16="http://schemas.microsoft.com/office/drawing/2014/main" id="{EF1A297F-3BA8-4EDF-82F8-468195E2D9A0}"/>
+                <a16:creationId xmlns:a16="http://schemas.microsoft.com/office/drawing/2014/main" id="{245071AC-96D7-41F8-8D29-457C1C47EBD9}"/>
               </a:ext>
             </a:extLst>
           </p:cNvPr>
@@ -23666,7 +23666,7 @@
           <p:cNvPr id="3" name="">
             <a:extLst xmlns:a="http://schemas.openxmlformats.org/drawingml/2006/main">
               <a:ext uri="{FF2B5EF4-FFF2-40B4-BE49-F238E27FC236}">
-                <a16:creationId xmlns:a16="http://schemas.microsoft.com/office/drawing/2014/main" id="{4A6F4483-1D0D-4C0C-A8CC-BE6757C7508E}"/>
+                <a16:creationId xmlns:a16="http://schemas.microsoft.com/office/drawing/2014/main" id="{4F8DC2BD-00E3-44BF-9009-14508A049450}"/>
               </a:ext>
             </a:extLst>
           </p:cNvPr>
@@ -23822,7 +23822,7 @@
           <p:cNvPr id="4" name="">
             <a:extLst xmlns:a="http://schemas.openxmlformats.org/drawingml/2006/main">
               <a:ext uri="{FF2B5EF4-FFF2-40B4-BE49-F238E27FC236}">
-                <a16:creationId xmlns:a16="http://schemas.microsoft.com/office/drawing/2014/main" id="{2A8C374F-D4F1-4403-8193-CA45A1031A1D}"/>
+                <a16:creationId xmlns:a16="http://schemas.microsoft.com/office/drawing/2014/main" id="{51442176-FFC5-4047-B6F9-11EBFC45B48B}"/>
               </a:ext>
             </a:extLst>
           </p:cNvPr>
@@ -23978,7 +23978,7 @@
           <p:cNvPr id="5" name="">
             <a:extLst xmlns:a="http://schemas.openxmlformats.org/drawingml/2006/main">
               <a:ext uri="{FF2B5EF4-FFF2-40B4-BE49-F238E27FC236}">
-                <a16:creationId xmlns:a16="http://schemas.microsoft.com/office/drawing/2014/main" id="{CEA7C16C-FD3A-40C6-AB1F-5C3CE749B710}"/>
+                <a16:creationId xmlns:a16="http://schemas.microsoft.com/office/drawing/2014/main" id="{05168705-7D8A-4A0D-9177-D0B93B7B5AAA}"/>
               </a:ext>
             </a:extLst>
           </p:cNvPr>
@@ -24134,7 +24134,7 @@
           <p:cNvPr id="6" name="">
             <a:extLst xmlns:a="http://schemas.openxmlformats.org/drawingml/2006/main">
               <a:ext uri="{FF2B5EF4-FFF2-40B4-BE49-F238E27FC236}">
-                <a16:creationId xmlns:a16="http://schemas.microsoft.com/office/drawing/2014/main" id="{4DB19ED7-282D-4AA1-BA2D-E83587993011}"/>
+                <a16:creationId xmlns:a16="http://schemas.microsoft.com/office/drawing/2014/main" id="{838C0C43-CFEB-4D46-8D0C-707639FAAA17}"/>
               </a:ext>
             </a:extLst>
           </p:cNvPr>
@@ -24288,7 +24288,7 @@
     </p:spTree>
     <p:extLst>
       <p:ext uri="{BB962C8B-B14F-4D97-AF65-F5344CB8AC3E}">
-        <p14:creationId xmlns:p14="http://schemas.microsoft.com/office/powerpoint/2010/main" val="169733037"/>
+        <p14:creationId xmlns:p14="http://schemas.microsoft.com/office/powerpoint/2010/main" val="779041234"/>
       </p:ext>
     </p:extLst>
   </p:cSld>
@@ -24319,7 +24319,7 @@
           <p:cNvPr id="7" name="">
             <a:extLst xmlns:a="http://schemas.openxmlformats.org/drawingml/2006/main">
               <a:ext uri="{FF2B5EF4-FFF2-40B4-BE49-F238E27FC236}">
-                <a16:creationId xmlns:a16="http://schemas.microsoft.com/office/drawing/2014/main" id="{FFF075E4-60CB-4D5D-B2A4-82BC2DEF26FC}"/>
+                <a16:creationId xmlns:a16="http://schemas.microsoft.com/office/drawing/2014/main" id="{A645A158-3987-4561-A880-6735EC23D1B9}"/>
               </a:ext>
             </a:extLst>
           </p:cNvPr>
@@ -24475,7 +24475,7 @@
           <p:cNvPr id="2" name="">
             <a:extLst xmlns:a="http://schemas.openxmlformats.org/drawingml/2006/main">
               <a:ext uri="{FF2B5EF4-FFF2-40B4-BE49-F238E27FC236}">
-                <a16:creationId xmlns:a16="http://schemas.microsoft.com/office/drawing/2014/main" id="{A89469DB-5F3D-4C45-AF79-2BCA7F8D4421}"/>
+                <a16:creationId xmlns:a16="http://schemas.microsoft.com/office/drawing/2014/main" id="{C1CB2208-29A2-4B57-817D-65DD1E025DE0}"/>
               </a:ext>
             </a:extLst>
           </p:cNvPr>
@@ -24631,7 +24631,7 @@
           <p:cNvPr id="3" name="">
             <a:extLst xmlns:a="http://schemas.openxmlformats.org/drawingml/2006/main">
               <a:ext uri="{FF2B5EF4-FFF2-40B4-BE49-F238E27FC236}">
-                <a16:creationId xmlns:a16="http://schemas.microsoft.com/office/drawing/2014/main" id="{7C5F38FD-2F10-40A1-BC81-9AD1966C3959}"/>
+                <a16:creationId xmlns:a16="http://schemas.microsoft.com/office/drawing/2014/main" id="{0B641128-CE44-45F7-8EBB-E632AB0EB592}"/>
               </a:ext>
             </a:extLst>
           </p:cNvPr>
@@ -24787,7 +24787,7 @@
           <p:cNvPr id="4" name="">
             <a:extLst xmlns:a="http://schemas.openxmlformats.org/drawingml/2006/main">
               <a:ext uri="{FF2B5EF4-FFF2-40B4-BE49-F238E27FC236}">
-                <a16:creationId xmlns:a16="http://schemas.microsoft.com/office/drawing/2014/main" id="{7AE8EBF6-D2F5-4A9F-A1B7-9602E1B9896F}"/>
+                <a16:creationId xmlns:a16="http://schemas.microsoft.com/office/drawing/2014/main" id="{E785FC5B-03B3-43C0-843D-C2DE41ECD1FD}"/>
               </a:ext>
             </a:extLst>
           </p:cNvPr>
@@ -24943,7 +24943,7 @@
           <p:cNvPr id="5" name="">
             <a:extLst xmlns:a="http://schemas.openxmlformats.org/drawingml/2006/main">
               <a:ext uri="{FF2B5EF4-FFF2-40B4-BE49-F238E27FC236}">
-                <a16:creationId xmlns:a16="http://schemas.microsoft.com/office/drawing/2014/main" id="{9D89E450-A94C-43D6-9ABD-6CD4982828FE}"/>
+                <a16:creationId xmlns:a16="http://schemas.microsoft.com/office/drawing/2014/main" id="{347140EE-FF5B-4C81-92C0-17F026DF3827}"/>
               </a:ext>
             </a:extLst>
           </p:cNvPr>
@@ -25099,7 +25099,7 @@
           <p:cNvPr id="6" name="">
             <a:extLst xmlns:a="http://schemas.openxmlformats.org/drawingml/2006/main">
               <a:ext uri="{FF2B5EF4-FFF2-40B4-BE49-F238E27FC236}">
-                <a16:creationId xmlns:a16="http://schemas.microsoft.com/office/drawing/2014/main" id="{C4345A04-45DD-44CD-90B4-D5C8020B8262}"/>
+                <a16:creationId xmlns:a16="http://schemas.microsoft.com/office/drawing/2014/main" id="{C4FF37F5-9B94-40EC-A02E-8AB3AC2EC7B9}"/>
               </a:ext>
             </a:extLst>
           </p:cNvPr>
@@ -25253,7 +25253,7 @@
     </p:spTree>
     <p:extLst>
       <p:ext uri="{BB962C8B-B14F-4D97-AF65-F5344CB8AC3E}">
-        <p14:creationId xmlns:p14="http://schemas.microsoft.com/office/powerpoint/2010/main" val="123009004"/>
+        <p14:creationId xmlns:p14="http://schemas.microsoft.com/office/powerpoint/2010/main" val="1561626112"/>
       </p:ext>
     </p:extLst>
   </p:cSld>
@@ -25284,7 +25284,7 @@
           <p:cNvPr id="6" name="">
             <a:extLst xmlns:a="http://schemas.openxmlformats.org/drawingml/2006/main">
               <a:ext uri="{FF2B5EF4-FFF2-40B4-BE49-F238E27FC236}">
-                <a16:creationId xmlns:a16="http://schemas.microsoft.com/office/drawing/2014/main" id="{6BD002A9-ACB8-4BF2-AFDA-03F36B1C57E0}"/>
+                <a16:creationId xmlns:a16="http://schemas.microsoft.com/office/drawing/2014/main" id="{C5C4F12C-9640-424F-8F0F-982AC071BA8A}"/>
               </a:ext>
             </a:extLst>
           </p:cNvPr>
@@ -25440,7 +25440,7 @@
           <p:cNvPr id="2" name="">
             <a:extLst xmlns:a="http://schemas.openxmlformats.org/drawingml/2006/main">
               <a:ext uri="{FF2B5EF4-FFF2-40B4-BE49-F238E27FC236}">
-                <a16:creationId xmlns:a16="http://schemas.microsoft.com/office/drawing/2014/main" id="{9CA527BE-2468-41E7-8E48-7BFD0A5ED7DE}"/>
+                <a16:creationId xmlns:a16="http://schemas.microsoft.com/office/drawing/2014/main" id="{BC2F0A04-A3D3-4108-9EE6-6DA8F64A0F47}"/>
               </a:ext>
             </a:extLst>
           </p:cNvPr>
@@ -25596,7 +25596,7 @@
           <p:cNvPr id="3" name="">
             <a:extLst xmlns:a="http://schemas.openxmlformats.org/drawingml/2006/main">
               <a:ext uri="{FF2B5EF4-FFF2-40B4-BE49-F238E27FC236}">
-                <a16:creationId xmlns:a16="http://schemas.microsoft.com/office/drawing/2014/main" id="{F2C5FD36-4E32-43C3-8FF0-C8AAE4F94064}"/>
+                <a16:creationId xmlns:a16="http://schemas.microsoft.com/office/drawing/2014/main" id="{FBA3F2A9-2045-42E5-88CC-C85D53343054}"/>
               </a:ext>
             </a:extLst>
           </p:cNvPr>
@@ -25752,7 +25752,7 @@
           <p:cNvPr id="4" name="">
             <a:extLst xmlns:a="http://schemas.openxmlformats.org/drawingml/2006/main">
               <a:ext uri="{FF2B5EF4-FFF2-40B4-BE49-F238E27FC236}">
-                <a16:creationId xmlns:a16="http://schemas.microsoft.com/office/drawing/2014/main" id="{EA7199D9-0585-480E-8180-72D945FEE0B7}"/>
+                <a16:creationId xmlns:a16="http://schemas.microsoft.com/office/drawing/2014/main" id="{A29B9DB6-737B-4A33-BE43-1CDAEF1820EE}"/>
               </a:ext>
             </a:extLst>
           </p:cNvPr>
@@ -25908,7 +25908,7 @@
           <p:cNvPr id="5" name="">
             <a:extLst xmlns:a="http://schemas.openxmlformats.org/drawingml/2006/main">
               <a:ext uri="{FF2B5EF4-FFF2-40B4-BE49-F238E27FC236}">
-                <a16:creationId xmlns:a16="http://schemas.microsoft.com/office/drawing/2014/main" id="{47AA864D-13EF-4DAE-9377-4CCECB6BB53E}"/>
+                <a16:creationId xmlns:a16="http://schemas.microsoft.com/office/drawing/2014/main" id="{72494B76-0ACD-4162-A499-8B44E94F1D6E}"/>
               </a:ext>
             </a:extLst>
           </p:cNvPr>
@@ -26062,7 +26062,7 @@
     </p:spTree>
     <p:extLst>
       <p:ext uri="{BB962C8B-B14F-4D97-AF65-F5344CB8AC3E}">
-        <p14:creationId xmlns:p14="http://schemas.microsoft.com/office/powerpoint/2010/main" val="1403502525"/>
+        <p14:creationId xmlns:p14="http://schemas.microsoft.com/office/powerpoint/2010/main" val="1426234700"/>
       </p:ext>
     </p:extLst>
   </p:cSld>
@@ -26093,7 +26093,7 @@
           <p:cNvPr id="8" name="">
             <a:extLst xmlns:a="http://schemas.openxmlformats.org/drawingml/2006/main">
               <a:ext uri="{FF2B5EF4-FFF2-40B4-BE49-F238E27FC236}">
-                <a16:creationId xmlns:a16="http://schemas.microsoft.com/office/drawing/2014/main" id="{6CDDD47C-DB9E-4082-B3C8-17ECAE38C1BA}"/>
+                <a16:creationId xmlns:a16="http://schemas.microsoft.com/office/drawing/2014/main" id="{19CA5295-D73D-44C4-A40D-FF225FB16A5C}"/>
               </a:ext>
             </a:extLst>
           </p:cNvPr>
@@ -26249,7 +26249,7 @@
           <p:cNvPr id="2" name="">
             <a:extLst xmlns:a="http://schemas.openxmlformats.org/drawingml/2006/main">
               <a:ext uri="{FF2B5EF4-FFF2-40B4-BE49-F238E27FC236}">
-                <a16:creationId xmlns:a16="http://schemas.microsoft.com/office/drawing/2014/main" id="{99CAAC3C-1AB6-47A9-BB68-6AE0EC995E1B}"/>
+                <a16:creationId xmlns:a16="http://schemas.microsoft.com/office/drawing/2014/main" id="{ABA88F5D-17A2-46C7-89AC-932F40BAE694}"/>
               </a:ext>
             </a:extLst>
           </p:cNvPr>
@@ -26405,7 +26405,7 @@
           <p:cNvPr id="3" name="">
             <a:extLst xmlns:a="http://schemas.openxmlformats.org/drawingml/2006/main">
               <a:ext uri="{FF2B5EF4-FFF2-40B4-BE49-F238E27FC236}">
-                <a16:creationId xmlns:a16="http://schemas.microsoft.com/office/drawing/2014/main" id="{807CBD3E-892A-42EA-8C02-D628D068217D}"/>
+                <a16:creationId xmlns:a16="http://schemas.microsoft.com/office/drawing/2014/main" id="{06EF75D4-4889-4C52-944B-F921DAD74ECD}"/>
               </a:ext>
             </a:extLst>
           </p:cNvPr>
@@ -26561,7 +26561,7 @@
           <p:cNvPr id="4" name="">
             <a:extLst xmlns:a="http://schemas.openxmlformats.org/drawingml/2006/main">
               <a:ext uri="{FF2B5EF4-FFF2-40B4-BE49-F238E27FC236}">
-                <a16:creationId xmlns:a16="http://schemas.microsoft.com/office/drawing/2014/main" id="{A049E290-389B-4277-BC4F-7307A7260DB5}"/>
+                <a16:creationId xmlns:a16="http://schemas.microsoft.com/office/drawing/2014/main" id="{77886BCA-224A-4594-A160-DC18A30A0D37}"/>
               </a:ext>
             </a:extLst>
           </p:cNvPr>
@@ -26717,7 +26717,7 @@
           <p:cNvPr id="5" name="">
             <a:extLst xmlns:a="http://schemas.openxmlformats.org/drawingml/2006/main">
               <a:ext uri="{FF2B5EF4-FFF2-40B4-BE49-F238E27FC236}">
-                <a16:creationId xmlns:a16="http://schemas.microsoft.com/office/drawing/2014/main" id="{D0654AB2-380E-45A1-A701-86E48A5C2DF2}"/>
+                <a16:creationId xmlns:a16="http://schemas.microsoft.com/office/drawing/2014/main" id="{1469A837-1ED7-4D03-9F8F-DCF648E9C4C1}"/>
               </a:ext>
             </a:extLst>
           </p:cNvPr>
@@ -26873,7 +26873,7 @@
           <p:cNvPr id="6" name="">
             <a:extLst xmlns:a="http://schemas.openxmlformats.org/drawingml/2006/main">
               <a:ext uri="{FF2B5EF4-FFF2-40B4-BE49-F238E27FC236}">
-                <a16:creationId xmlns:a16="http://schemas.microsoft.com/office/drawing/2014/main" id="{48228A3F-7416-4C7C-AE0D-4BB5DA602D7B}"/>
+                <a16:creationId xmlns:a16="http://schemas.microsoft.com/office/drawing/2014/main" id="{39F12DB8-A1D6-4546-8819-89821A0B1CCB}"/>
               </a:ext>
             </a:extLst>
           </p:cNvPr>
@@ -27029,7 +27029,7 @@
           <p:cNvPr id="7" name="">
             <a:extLst xmlns:a="http://schemas.openxmlformats.org/drawingml/2006/main">
               <a:ext uri="{FF2B5EF4-FFF2-40B4-BE49-F238E27FC236}">
-                <a16:creationId xmlns:a16="http://schemas.microsoft.com/office/drawing/2014/main" id="{2AE76022-EC74-4BB9-B236-72BF952E9FE0}"/>
+                <a16:creationId xmlns:a16="http://schemas.microsoft.com/office/drawing/2014/main" id="{E5EEC32A-78EE-4BCF-B08A-527CE89C7983}"/>
               </a:ext>
             </a:extLst>
           </p:cNvPr>
@@ -27183,7 +27183,7 @@
     </p:spTree>
     <p:extLst>
       <p:ext uri="{BB962C8B-B14F-4D97-AF65-F5344CB8AC3E}">
-        <p14:creationId xmlns:p14="http://schemas.microsoft.com/office/powerpoint/2010/main" val="1930114895"/>
+        <p14:creationId xmlns:p14="http://schemas.microsoft.com/office/powerpoint/2010/main" val="256685326"/>
       </p:ext>
     </p:extLst>
   </p:cSld>
@@ -27214,7 +27214,7 @@
           <p:cNvPr id="13" name="">
             <a:extLst xmlns:a="http://schemas.openxmlformats.org/drawingml/2006/main">
               <a:ext uri="{FF2B5EF4-FFF2-40B4-BE49-F238E27FC236}">
-                <a16:creationId xmlns:a16="http://schemas.microsoft.com/office/drawing/2014/main" id="{741EF1FE-45CB-49F7-A88F-50B5E7C8C123}"/>
+                <a16:creationId xmlns:a16="http://schemas.microsoft.com/office/drawing/2014/main" id="{8D9B8C1A-2158-46F0-8DD3-AA7692A5A2F4}"/>
               </a:ext>
             </a:extLst>
           </p:cNvPr>
@@ -27370,7 +27370,7 @@
           <p:cNvPr id="2" name="">
             <a:extLst xmlns:a="http://schemas.openxmlformats.org/drawingml/2006/main">
               <a:ext uri="{FF2B5EF4-FFF2-40B4-BE49-F238E27FC236}">
-                <a16:creationId xmlns:a16="http://schemas.microsoft.com/office/drawing/2014/main" id="{9442F6B6-0B1F-4EF1-83B1-6059342580BF}"/>
+                <a16:creationId xmlns:a16="http://schemas.microsoft.com/office/drawing/2014/main" id="{31F178A1-12E8-4D2B-96D3-62D91961C0B3}"/>
               </a:ext>
             </a:extLst>
           </p:cNvPr>
@@ -27526,7 +27526,7 @@
           <p:cNvPr id="3" name="">
             <a:extLst xmlns:a="http://schemas.openxmlformats.org/drawingml/2006/main">
               <a:ext uri="{FF2B5EF4-FFF2-40B4-BE49-F238E27FC236}">
-                <a16:creationId xmlns:a16="http://schemas.microsoft.com/office/drawing/2014/main" id="{A522B8D8-3AAE-436E-B423-40F3C47F5477}"/>
+                <a16:creationId xmlns:a16="http://schemas.microsoft.com/office/drawing/2014/main" id="{B49C8605-3852-400C-8F61-A12FB9C83421}"/>
               </a:ext>
             </a:extLst>
           </p:cNvPr>
@@ -27682,7 +27682,7 @@
           <p:cNvPr id="4" name="">
             <a:extLst xmlns:a="http://schemas.openxmlformats.org/drawingml/2006/main">
               <a:ext uri="{FF2B5EF4-FFF2-40B4-BE49-F238E27FC236}">
-                <a16:creationId xmlns:a16="http://schemas.microsoft.com/office/drawing/2014/main" id="{BEC7CB9A-8F49-4949-B5B7-4B988370ED2A}"/>
+                <a16:creationId xmlns:a16="http://schemas.microsoft.com/office/drawing/2014/main" id="{32C2FC54-0ED0-4807-920C-D2C48143137C}"/>
               </a:ext>
             </a:extLst>
           </p:cNvPr>
@@ -27838,7 +27838,7 @@
           <p:cNvPr id="5" name="">
             <a:extLst xmlns:a="http://schemas.openxmlformats.org/drawingml/2006/main">
               <a:ext uri="{FF2B5EF4-FFF2-40B4-BE49-F238E27FC236}">
-                <a16:creationId xmlns:a16="http://schemas.microsoft.com/office/drawing/2014/main" id="{4B4A9A75-56DA-4281-B69B-062B06736FD3}"/>
+                <a16:creationId xmlns:a16="http://schemas.microsoft.com/office/drawing/2014/main" id="{D9F5CE47-2A67-4AD1-9C57-3BDCA9A6D739}"/>
               </a:ext>
             </a:extLst>
           </p:cNvPr>
@@ -27994,7 +27994,7 @@
           <p:cNvPr id="6" name="">
             <a:extLst xmlns:a="http://schemas.openxmlformats.org/drawingml/2006/main">
               <a:ext uri="{FF2B5EF4-FFF2-40B4-BE49-F238E27FC236}">
-                <a16:creationId xmlns:a16="http://schemas.microsoft.com/office/drawing/2014/main" id="{008A79F6-5756-4424-A9BD-E4EC63214CD7}"/>
+                <a16:creationId xmlns:a16="http://schemas.microsoft.com/office/drawing/2014/main" id="{350D0F81-76A2-4C28-B7C6-65BD4AF18AB5}"/>
               </a:ext>
             </a:extLst>
           </p:cNvPr>
@@ -28150,7 +28150,7 @@
           <p:cNvPr id="7" name="">
             <a:extLst xmlns:a="http://schemas.openxmlformats.org/drawingml/2006/main">
               <a:ext uri="{FF2B5EF4-FFF2-40B4-BE49-F238E27FC236}">
-                <a16:creationId xmlns:a16="http://schemas.microsoft.com/office/drawing/2014/main" id="{40753F26-C8B6-4D51-BAE2-6359721FEE0C}"/>
+                <a16:creationId xmlns:a16="http://schemas.microsoft.com/office/drawing/2014/main" id="{B80AB8FA-753D-4579-B8E1-868441FC4B2E}"/>
               </a:ext>
             </a:extLst>
           </p:cNvPr>
@@ -28180,7 +28180,7 @@
           <p:cNvPr id="8" name="">
             <a:extLst xmlns:a="http://schemas.openxmlformats.org/drawingml/2006/main">
               <a:ext uri="{FF2B5EF4-FFF2-40B4-BE49-F238E27FC236}">
-                <a16:creationId xmlns:a16="http://schemas.microsoft.com/office/drawing/2014/main" id="{B4B1D351-48A2-451C-A1F8-B0F6AEE92BDD}"/>
+                <a16:creationId xmlns:a16="http://schemas.microsoft.com/office/drawing/2014/main" id="{842F661D-1361-44F6-9080-B45070526DDA}"/>
               </a:ext>
             </a:extLst>
           </p:cNvPr>
@@ -28219,7 +28219,7 @@
           <p:cNvPr id="9" name="">
             <a:extLst xmlns:a="http://schemas.openxmlformats.org/drawingml/2006/main">
               <a:ext uri="{FF2B5EF4-FFF2-40B4-BE49-F238E27FC236}">
-                <a16:creationId xmlns:a16="http://schemas.microsoft.com/office/drawing/2014/main" id="{7FAE1B6D-1BCD-4CA1-A5AD-84B3B3A72110}"/>
+                <a16:creationId xmlns:a16="http://schemas.microsoft.com/office/drawing/2014/main" id="{979AB217-536A-4A0F-98AE-5AABDF479DF2}"/>
               </a:ext>
             </a:extLst>
           </p:cNvPr>
@@ -28375,7 +28375,7 @@
           <p:cNvPr id="10" name="">
             <a:extLst xmlns:a="http://schemas.openxmlformats.org/drawingml/2006/main">
               <a:ext uri="{FF2B5EF4-FFF2-40B4-BE49-F238E27FC236}">
-                <a16:creationId xmlns:a16="http://schemas.microsoft.com/office/drawing/2014/main" id="{EB9B138B-0E01-42A8-BFA6-B72A7451950B}"/>
+                <a16:creationId xmlns:a16="http://schemas.microsoft.com/office/drawing/2014/main" id="{78E1655C-2D3E-4152-9F5A-578214B9A382}"/>
               </a:ext>
             </a:extLst>
           </p:cNvPr>
@@ -28531,7 +28531,7 @@
           <p:cNvPr id="11" name="">
             <a:extLst xmlns:a="http://schemas.openxmlformats.org/drawingml/2006/main">
               <a:ext uri="{FF2B5EF4-FFF2-40B4-BE49-F238E27FC236}">
-                <a16:creationId xmlns:a16="http://schemas.microsoft.com/office/drawing/2014/main" id="{E2B02D3D-E32A-412D-9306-37997D29141C}"/>
+                <a16:creationId xmlns:a16="http://schemas.microsoft.com/office/drawing/2014/main" id="{0B92E9FF-564A-4A25-8D94-F716DDC2EF43}"/>
               </a:ext>
             </a:extLst>
           </p:cNvPr>
@@ -28687,7 +28687,7 @@
           <p:cNvPr id="12" name="">
             <a:extLst xmlns:a="http://schemas.openxmlformats.org/drawingml/2006/main">
               <a:ext uri="{FF2B5EF4-FFF2-40B4-BE49-F238E27FC236}">
-                <a16:creationId xmlns:a16="http://schemas.microsoft.com/office/drawing/2014/main" id="{77C8FD5F-B834-4379-A623-0AC6DF9C331F}"/>
+                <a16:creationId xmlns:a16="http://schemas.microsoft.com/office/drawing/2014/main" id="{F34074E4-96A0-4CB3-935F-2762AD40D415}"/>
               </a:ext>
             </a:extLst>
           </p:cNvPr>
@@ -28841,7 +28841,7 @@
     </p:spTree>
     <p:extLst>
       <p:ext uri="{BB962C8B-B14F-4D97-AF65-F5344CB8AC3E}">
-        <p14:creationId xmlns:p14="http://schemas.microsoft.com/office/powerpoint/2010/main" val="154304595"/>
+        <p14:creationId xmlns:p14="http://schemas.microsoft.com/office/powerpoint/2010/main" val="1599118089"/>
       </p:ext>
     </p:extLst>
   </p:cSld>
@@ -28872,7 +28872,7 @@
           <p:cNvPr id="7" name="">
             <a:extLst xmlns:a="http://schemas.openxmlformats.org/drawingml/2006/main">
               <a:ext uri="{FF2B5EF4-FFF2-40B4-BE49-F238E27FC236}">
-                <a16:creationId xmlns:a16="http://schemas.microsoft.com/office/drawing/2014/main" id="{43236EB0-CA91-4F90-8AB0-EF1E04E026BA}"/>
+                <a16:creationId xmlns:a16="http://schemas.microsoft.com/office/drawing/2014/main" id="{18F5B11F-F4A0-41EC-8FAD-AA1F694251A2}"/>
               </a:ext>
             </a:extLst>
           </p:cNvPr>
@@ -29028,7 +29028,7 @@
           <p:cNvPr id="2" name="">
             <a:extLst xmlns:a="http://schemas.openxmlformats.org/drawingml/2006/main">
               <a:ext uri="{FF2B5EF4-FFF2-40B4-BE49-F238E27FC236}">
-                <a16:creationId xmlns:a16="http://schemas.microsoft.com/office/drawing/2014/main" id="{97ABE860-7A11-4507-B1D4-EA8DECE6DD79}"/>
+                <a16:creationId xmlns:a16="http://schemas.microsoft.com/office/drawing/2014/main" id="{EDDFC8B3-9D78-4072-987D-B9453FF5E7D0}"/>
               </a:ext>
             </a:extLst>
           </p:cNvPr>
@@ -29184,7 +29184,7 @@
           <p:cNvPr id="3" name="">
             <a:extLst xmlns:a="http://schemas.openxmlformats.org/drawingml/2006/main">
               <a:ext uri="{FF2B5EF4-FFF2-40B4-BE49-F238E27FC236}">
-                <a16:creationId xmlns:a16="http://schemas.microsoft.com/office/drawing/2014/main" id="{1EBB2363-8517-4CD8-A185-CBA7DED26125}"/>
+                <a16:creationId xmlns:a16="http://schemas.microsoft.com/office/drawing/2014/main" id="{AA98098A-A4E2-4C30-933E-04D5A9F1D52D}"/>
               </a:ext>
             </a:extLst>
           </p:cNvPr>
@@ -29340,7 +29340,7 @@
           <p:cNvPr id="4" name="">
             <a:extLst xmlns:a="http://schemas.openxmlformats.org/drawingml/2006/main">
               <a:ext uri="{FF2B5EF4-FFF2-40B4-BE49-F238E27FC236}">
-                <a16:creationId xmlns:a16="http://schemas.microsoft.com/office/drawing/2014/main" id="{3977F618-C6E6-463A-B86E-F84A69CBA8E8}"/>
+                <a16:creationId xmlns:a16="http://schemas.microsoft.com/office/drawing/2014/main" id="{0304149E-9A88-49E4-B0C4-B68F023C1BAE}"/>
               </a:ext>
             </a:extLst>
           </p:cNvPr>
@@ -29496,7 +29496,7 @@
           <p:cNvPr id="5" name="">
             <a:extLst xmlns:a="http://schemas.openxmlformats.org/drawingml/2006/main">
               <a:ext uri="{FF2B5EF4-FFF2-40B4-BE49-F238E27FC236}">
-                <a16:creationId xmlns:a16="http://schemas.microsoft.com/office/drawing/2014/main" id="{53198EB2-3CF0-495F-AE5B-5EA6BEDDC320}"/>
+                <a16:creationId xmlns:a16="http://schemas.microsoft.com/office/drawing/2014/main" id="{E880D083-9405-4A56-8EAB-4D3CCDAEECC3}"/>
               </a:ext>
             </a:extLst>
           </p:cNvPr>
@@ -29652,7 +29652,7 @@
           <p:cNvPr id="6" name="">
             <a:extLst xmlns:a="http://schemas.openxmlformats.org/drawingml/2006/main">
               <a:ext uri="{FF2B5EF4-FFF2-40B4-BE49-F238E27FC236}">
-                <a16:creationId xmlns:a16="http://schemas.microsoft.com/office/drawing/2014/main" id="{331453DD-F7E8-4774-843F-59FAAF5FF2FF}"/>
+                <a16:creationId xmlns:a16="http://schemas.microsoft.com/office/drawing/2014/main" id="{3E831D5A-F3E3-4F48-94F2-292BD27F23D8}"/>
               </a:ext>
             </a:extLst>
           </p:cNvPr>
@@ -29806,7 +29806,7 @@
     </p:spTree>
     <p:extLst>
       <p:ext uri="{BB962C8B-B14F-4D97-AF65-F5344CB8AC3E}">
-        <p14:creationId xmlns:p14="http://schemas.microsoft.com/office/powerpoint/2010/main" val="2056410880"/>
+        <p14:creationId xmlns:p14="http://schemas.microsoft.com/office/powerpoint/2010/main" val="1566639642"/>
       </p:ext>
     </p:extLst>
   </p:cSld>
@@ -29837,7 +29837,7 @@
           <p:cNvPr id="7" name="">
             <a:extLst xmlns:a="http://schemas.openxmlformats.org/drawingml/2006/main">
               <a:ext uri="{FF2B5EF4-FFF2-40B4-BE49-F238E27FC236}">
-                <a16:creationId xmlns:a16="http://schemas.microsoft.com/office/drawing/2014/main" id="{F8A83C67-3CD4-45B3-9987-3C357365AD3E}"/>
+                <a16:creationId xmlns:a16="http://schemas.microsoft.com/office/drawing/2014/main" id="{47DA1681-A0DC-404F-9666-70EBB7EC0F78}"/>
               </a:ext>
             </a:extLst>
           </p:cNvPr>
@@ -29993,7 +29993,7 @@
           <p:cNvPr id="2" name="">
             <a:extLst xmlns:a="http://schemas.openxmlformats.org/drawingml/2006/main">
               <a:ext uri="{FF2B5EF4-FFF2-40B4-BE49-F238E27FC236}">
-                <a16:creationId xmlns:a16="http://schemas.microsoft.com/office/drawing/2014/main" id="{61AF3BF4-8CE2-45DB-820C-632CA8F93E0C}"/>
+                <a16:creationId xmlns:a16="http://schemas.microsoft.com/office/drawing/2014/main" id="{A10B4CFC-93EF-4205-8FAA-521BA3399E3C}"/>
               </a:ext>
             </a:extLst>
           </p:cNvPr>
@@ -30149,7 +30149,7 @@
           <p:cNvPr id="3" name="">
             <a:extLst xmlns:a="http://schemas.openxmlformats.org/drawingml/2006/main">
               <a:ext uri="{FF2B5EF4-FFF2-40B4-BE49-F238E27FC236}">
-                <a16:creationId xmlns:a16="http://schemas.microsoft.com/office/drawing/2014/main" id="{1B7D04C3-B083-4FA6-B1F8-2E20948E9C9C}"/>
+                <a16:creationId xmlns:a16="http://schemas.microsoft.com/office/drawing/2014/main" id="{A75A72D0-3758-4D7F-9490-10023522F1F2}"/>
               </a:ext>
             </a:extLst>
           </p:cNvPr>
@@ -30305,7 +30305,7 @@
           <p:cNvPr id="4" name="">
             <a:extLst xmlns:a="http://schemas.openxmlformats.org/drawingml/2006/main">
               <a:ext uri="{FF2B5EF4-FFF2-40B4-BE49-F238E27FC236}">
-                <a16:creationId xmlns:a16="http://schemas.microsoft.com/office/drawing/2014/main" id="{FCA28B61-B346-4CF0-B0BD-23440FDA4FFB}"/>
+                <a16:creationId xmlns:a16="http://schemas.microsoft.com/office/drawing/2014/main" id="{9ECBCD5F-D5D9-40FF-B60D-CA3DB50F55FC}"/>
               </a:ext>
             </a:extLst>
           </p:cNvPr>
@@ -30461,7 +30461,7 @@
           <p:cNvPr id="5" name="">
             <a:extLst xmlns:a="http://schemas.openxmlformats.org/drawingml/2006/main">
               <a:ext uri="{FF2B5EF4-FFF2-40B4-BE49-F238E27FC236}">
-                <a16:creationId xmlns:a16="http://schemas.microsoft.com/office/drawing/2014/main" id="{85D338E1-2630-4128-8D47-50543600E23A}"/>
+                <a16:creationId xmlns:a16="http://schemas.microsoft.com/office/drawing/2014/main" id="{A36B7B43-073F-4ABB-A522-FA3F9C07BB8D}"/>
               </a:ext>
             </a:extLst>
           </p:cNvPr>
@@ -30617,7 +30617,7 @@
           <p:cNvPr id="6" name="">
             <a:extLst xmlns:a="http://schemas.openxmlformats.org/drawingml/2006/main">
               <a:ext uri="{FF2B5EF4-FFF2-40B4-BE49-F238E27FC236}">
-                <a16:creationId xmlns:a16="http://schemas.microsoft.com/office/drawing/2014/main" id="{1722E442-5B51-4BF8-82B7-D122F0C796A6}"/>
+                <a16:creationId xmlns:a16="http://schemas.microsoft.com/office/drawing/2014/main" id="{B764561E-C3A0-4BD6-9323-BB2D7B3F53C8}"/>
               </a:ext>
             </a:extLst>
           </p:cNvPr>
@@ -30771,7 +30771,7 @@
     </p:spTree>
     <p:extLst>
       <p:ext uri="{BB962C8B-B14F-4D97-AF65-F5344CB8AC3E}">
-        <p14:creationId xmlns:p14="http://schemas.microsoft.com/office/powerpoint/2010/main" val="782583481"/>
+        <p14:creationId xmlns:p14="http://schemas.microsoft.com/office/powerpoint/2010/main" val="866092386"/>
       </p:ext>
     </p:extLst>
   </p:cSld>
@@ -30802,7 +30802,7 @@
           <p:cNvPr id="15" name="">
             <a:extLst xmlns:a="http://schemas.openxmlformats.org/drawingml/2006/main">
               <a:ext uri="{FF2B5EF4-FFF2-40B4-BE49-F238E27FC236}">
-                <a16:creationId xmlns:a16="http://schemas.microsoft.com/office/drawing/2014/main" id="{572A18A2-D97C-480A-9DE0-B41D4DE31456}"/>
+                <a16:creationId xmlns:a16="http://schemas.microsoft.com/office/drawing/2014/main" id="{D080419C-5769-4EC7-8BE3-D696A7B9BEDF}"/>
               </a:ext>
             </a:extLst>
           </p:cNvPr>
@@ -30958,7 +30958,7 @@
           <p:cNvPr id="2" name="">
             <a:extLst xmlns:a="http://schemas.openxmlformats.org/drawingml/2006/main">
               <a:ext uri="{FF2B5EF4-FFF2-40B4-BE49-F238E27FC236}">
-                <a16:creationId xmlns:a16="http://schemas.microsoft.com/office/drawing/2014/main" id="{0735DC7C-179E-4F7B-9448-9E5BE9847D78}"/>
+                <a16:creationId xmlns:a16="http://schemas.microsoft.com/office/drawing/2014/main" id="{578B728F-0DF1-4932-940A-8AF74FBB951A}"/>
               </a:ext>
             </a:extLst>
           </p:cNvPr>
@@ -31114,7 +31114,7 @@
           <p:cNvPr id="3" name="">
             <a:extLst xmlns:a="http://schemas.openxmlformats.org/drawingml/2006/main">
               <a:ext uri="{FF2B5EF4-FFF2-40B4-BE49-F238E27FC236}">
-                <a16:creationId xmlns:a16="http://schemas.microsoft.com/office/drawing/2014/main" id="{65021072-C51D-48B2-9EC5-E4CF7020429D}"/>
+                <a16:creationId xmlns:a16="http://schemas.microsoft.com/office/drawing/2014/main" id="{3D5CE9F6-2910-40C4-913F-4970790B99D4}"/>
               </a:ext>
             </a:extLst>
           </p:cNvPr>
@@ -31144,7 +31144,7 @@
           <p:cNvPr id="4" name="">
             <a:extLst xmlns:a="http://schemas.openxmlformats.org/drawingml/2006/main">
               <a:ext uri="{FF2B5EF4-FFF2-40B4-BE49-F238E27FC236}">
-                <a16:creationId xmlns:a16="http://schemas.microsoft.com/office/drawing/2014/main" id="{17D1C230-9079-4858-900C-783482BD7B0D}"/>
+                <a16:creationId xmlns:a16="http://schemas.microsoft.com/office/drawing/2014/main" id="{8E7D460A-3C4D-482D-85F7-8357A671B052}"/>
               </a:ext>
             </a:extLst>
           </p:cNvPr>
@@ -31183,7 +31183,7 @@
           <p:cNvPr id="5" name="">
             <a:extLst xmlns:a="http://schemas.openxmlformats.org/drawingml/2006/main">
               <a:ext uri="{FF2B5EF4-FFF2-40B4-BE49-F238E27FC236}">
-                <a16:creationId xmlns:a16="http://schemas.microsoft.com/office/drawing/2014/main" id="{0B514916-5B9A-4B1F-BD5B-4B26527F4380}"/>
+                <a16:creationId xmlns:a16="http://schemas.microsoft.com/office/drawing/2014/main" id="{E7205762-E44D-4952-A7AB-D1DD8889EBFA}"/>
               </a:ext>
             </a:extLst>
           </p:cNvPr>
@@ -31222,7 +31222,7 @@
           <p:cNvPr id="6" name="">
             <a:extLst xmlns:a="http://schemas.openxmlformats.org/drawingml/2006/main">
               <a:ext uri="{FF2B5EF4-FFF2-40B4-BE49-F238E27FC236}">
-                <a16:creationId xmlns:a16="http://schemas.microsoft.com/office/drawing/2014/main" id="{6C546CC9-DF66-4048-AEBC-AE3E8FE54DFF}"/>
+                <a16:creationId xmlns:a16="http://schemas.microsoft.com/office/drawing/2014/main" id="{D4B41A67-5008-4BED-9489-8551ECC9B3A9}"/>
               </a:ext>
             </a:extLst>
           </p:cNvPr>
@@ -31261,7 +31261,7 @@
           <p:cNvPr id="7" name="">
             <a:extLst xmlns:a="http://schemas.openxmlformats.org/drawingml/2006/main">
               <a:ext uri="{FF2B5EF4-FFF2-40B4-BE49-F238E27FC236}">
-                <a16:creationId xmlns:a16="http://schemas.microsoft.com/office/drawing/2014/main" id="{76F0C874-D59F-426A-9183-FB0422A94494}"/>
+                <a16:creationId xmlns:a16="http://schemas.microsoft.com/office/drawing/2014/main" id="{9199807F-C952-4326-A3B3-E90AF6BA449B}"/>
               </a:ext>
             </a:extLst>
           </p:cNvPr>
@@ -31300,7 +31300,7 @@
           <p:cNvPr id="8" name="">
             <a:extLst xmlns:a="http://schemas.openxmlformats.org/drawingml/2006/main">
               <a:ext uri="{FF2B5EF4-FFF2-40B4-BE49-F238E27FC236}">
-                <a16:creationId xmlns:a16="http://schemas.microsoft.com/office/drawing/2014/main" id="{B8F1EA06-C583-4448-91E7-3D3D1F880467}"/>
+                <a16:creationId xmlns:a16="http://schemas.microsoft.com/office/drawing/2014/main" id="{5BF87850-074E-4450-9F1A-3624543A5128}"/>
               </a:ext>
             </a:extLst>
           </p:cNvPr>
@@ -31456,7 +31456,7 @@
           <p:cNvPr id="9" name="">
             <a:extLst xmlns:a="http://schemas.openxmlformats.org/drawingml/2006/main">
               <a:ext uri="{FF2B5EF4-FFF2-40B4-BE49-F238E27FC236}">
-                <a16:creationId xmlns:a16="http://schemas.microsoft.com/office/drawing/2014/main" id="{8EC2D7AD-782E-4ADE-9A57-7ED768A38082}"/>
+                <a16:creationId xmlns:a16="http://schemas.microsoft.com/office/drawing/2014/main" id="{C042CD89-9BAF-4B74-ABBA-70AD71246A61}"/>
               </a:ext>
             </a:extLst>
           </p:cNvPr>
@@ -31612,7 +31612,7 @@
           <p:cNvPr id="10" name="">
             <a:extLst xmlns:a="http://schemas.openxmlformats.org/drawingml/2006/main">
               <a:ext uri="{FF2B5EF4-FFF2-40B4-BE49-F238E27FC236}">
-                <a16:creationId xmlns:a16="http://schemas.microsoft.com/office/drawing/2014/main" id="{BE1BA16E-9A9D-444A-A899-1093431E7BCD}"/>
+                <a16:creationId xmlns:a16="http://schemas.microsoft.com/office/drawing/2014/main" id="{3B4AA107-9719-4A53-93A7-E35DB850F799}"/>
               </a:ext>
             </a:extLst>
           </p:cNvPr>
@@ -31768,7 +31768,7 @@
           <p:cNvPr id="11" name="">
             <a:extLst xmlns:a="http://schemas.openxmlformats.org/drawingml/2006/main">
               <a:ext uri="{FF2B5EF4-FFF2-40B4-BE49-F238E27FC236}">
-                <a16:creationId xmlns:a16="http://schemas.microsoft.com/office/drawing/2014/main" id="{D3677E1B-974E-4B2E-A6D9-2B95A9C08451}"/>
+                <a16:creationId xmlns:a16="http://schemas.microsoft.com/office/drawing/2014/main" id="{F5DE9345-4B14-43C6-AF4F-5E0B0FD833DC}"/>
               </a:ext>
             </a:extLst>
           </p:cNvPr>
@@ -31924,7 +31924,7 @@
           <p:cNvPr id="12" name="">
             <a:extLst xmlns:a="http://schemas.openxmlformats.org/drawingml/2006/main">
               <a:ext uri="{FF2B5EF4-FFF2-40B4-BE49-F238E27FC236}">
-                <a16:creationId xmlns:a16="http://schemas.microsoft.com/office/drawing/2014/main" id="{5DCC8770-004A-4D37-B663-9A3877074989}"/>
+                <a16:creationId xmlns:a16="http://schemas.microsoft.com/office/drawing/2014/main" id="{6267A2A4-4175-447D-838F-A8DCC231F4B5}"/>
               </a:ext>
             </a:extLst>
           </p:cNvPr>
@@ -32080,7 +32080,7 @@
           <p:cNvPr id="13" name="">
             <a:extLst xmlns:a="http://schemas.openxmlformats.org/drawingml/2006/main">
               <a:ext uri="{FF2B5EF4-FFF2-40B4-BE49-F238E27FC236}">
-                <a16:creationId xmlns:a16="http://schemas.microsoft.com/office/drawing/2014/main" id="{04EB2F12-7565-442D-914C-B497F3202B8F}"/>
+                <a16:creationId xmlns:a16="http://schemas.microsoft.com/office/drawing/2014/main" id="{2A386ED9-95C9-4151-B284-7CB7AFF54ACB}"/>
               </a:ext>
             </a:extLst>
           </p:cNvPr>
@@ -32236,7 +32236,7 @@
           <p:cNvPr id="14" name="">
             <a:extLst xmlns:a="http://schemas.openxmlformats.org/drawingml/2006/main">
               <a:ext uri="{FF2B5EF4-FFF2-40B4-BE49-F238E27FC236}">
-                <a16:creationId xmlns:a16="http://schemas.microsoft.com/office/drawing/2014/main" id="{42134C4E-C6F4-466A-A441-BB6D0791BB6E}"/>
+                <a16:creationId xmlns:a16="http://schemas.microsoft.com/office/drawing/2014/main" id="{C7DE95E9-9181-4201-B34E-DBB0F0D918ED}"/>
               </a:ext>
             </a:extLst>
           </p:cNvPr>
@@ -32390,7 +32390,7 @@
     </p:spTree>
     <p:extLst>
       <p:ext uri="{BB962C8B-B14F-4D97-AF65-F5344CB8AC3E}">
-        <p14:creationId xmlns:p14="http://schemas.microsoft.com/office/powerpoint/2010/main" val="1791719443"/>
+        <p14:creationId xmlns:p14="http://schemas.microsoft.com/office/powerpoint/2010/main" val="1948582595"/>
       </p:ext>
     </p:extLst>
   </p:cSld>
@@ -32421,7 +32421,7 @@
           <p:cNvPr id="6" name="">
             <a:extLst xmlns:a="http://schemas.openxmlformats.org/drawingml/2006/main">
               <a:ext uri="{FF2B5EF4-FFF2-40B4-BE49-F238E27FC236}">
-                <a16:creationId xmlns:a16="http://schemas.microsoft.com/office/drawing/2014/main" id="{9DA36078-DFA2-4D80-B3B0-217BD289A106}"/>
+                <a16:creationId xmlns:a16="http://schemas.microsoft.com/office/drawing/2014/main" id="{BD9BCE8F-4CB4-4175-87C9-01A60368760E}"/>
               </a:ext>
             </a:extLst>
           </p:cNvPr>
@@ -32577,7 +32577,7 @@
           <p:cNvPr id="2" name="">
             <a:extLst xmlns:a="http://schemas.openxmlformats.org/drawingml/2006/main">
               <a:ext uri="{FF2B5EF4-FFF2-40B4-BE49-F238E27FC236}">
-                <a16:creationId xmlns:a16="http://schemas.microsoft.com/office/drawing/2014/main" id="{1A006D5B-065C-48B5-A10E-E1B741C0038A}"/>
+                <a16:creationId xmlns:a16="http://schemas.microsoft.com/office/drawing/2014/main" id="{710159B1-129A-453F-8525-B002E1D78639}"/>
               </a:ext>
             </a:extLst>
           </p:cNvPr>
@@ -32733,7 +32733,7 @@
           <p:cNvPr id="3" name="">
             <a:extLst xmlns:a="http://schemas.openxmlformats.org/drawingml/2006/main">
               <a:ext uri="{FF2B5EF4-FFF2-40B4-BE49-F238E27FC236}">
-                <a16:creationId xmlns:a16="http://schemas.microsoft.com/office/drawing/2014/main" id="{05C5AC3B-85A9-4CEB-9872-18AA579AE3C4}"/>
+                <a16:creationId xmlns:a16="http://schemas.microsoft.com/office/drawing/2014/main" id="{CF373C39-C2FE-4BDB-BADF-01FC45056064}"/>
               </a:ext>
             </a:extLst>
           </p:cNvPr>
@@ -32889,7 +32889,7 @@
           <p:cNvPr id="4" name="">
             <a:extLst xmlns:a="http://schemas.openxmlformats.org/drawingml/2006/main">
               <a:ext uri="{FF2B5EF4-FFF2-40B4-BE49-F238E27FC236}">
-                <a16:creationId xmlns:a16="http://schemas.microsoft.com/office/drawing/2014/main" id="{3E44582A-0992-499F-9BBE-D6594B395A47}"/>
+                <a16:creationId xmlns:a16="http://schemas.microsoft.com/office/drawing/2014/main" id="{EA82226E-A8EF-4572-8184-79CC1A9EEF15}"/>
               </a:ext>
             </a:extLst>
           </p:cNvPr>
@@ -33045,7 +33045,7 @@
           <p:cNvPr id="5" name="">
             <a:extLst xmlns:a="http://schemas.openxmlformats.org/drawingml/2006/main">
               <a:ext uri="{FF2B5EF4-FFF2-40B4-BE49-F238E27FC236}">
-                <a16:creationId xmlns:a16="http://schemas.microsoft.com/office/drawing/2014/main" id="{BD2B05D9-3F3E-4ADF-8512-A04177170FB1}"/>
+                <a16:creationId xmlns:a16="http://schemas.microsoft.com/office/drawing/2014/main" id="{49FCCF3D-5F06-4102-AEE8-5EA98EB5859F}"/>
               </a:ext>
             </a:extLst>
           </p:cNvPr>
@@ -33199,7 +33199,7 @@
     </p:spTree>
     <p:extLst>
       <p:ext uri="{BB962C8B-B14F-4D97-AF65-F5344CB8AC3E}">
-        <p14:creationId xmlns:p14="http://schemas.microsoft.com/office/powerpoint/2010/main" val="369011843"/>
+        <p14:creationId xmlns:p14="http://schemas.microsoft.com/office/powerpoint/2010/main" val="1130913626"/>
       </p:ext>
     </p:extLst>
   </p:cSld>
@@ -33230,7 +33230,7 @@
           <p:cNvPr id="6" name="">
             <a:extLst xmlns:a="http://schemas.openxmlformats.org/drawingml/2006/main">
               <a:ext uri="{FF2B5EF4-FFF2-40B4-BE49-F238E27FC236}">
-                <a16:creationId xmlns:a16="http://schemas.microsoft.com/office/drawing/2014/main" id="{C3DB7649-DCB7-411B-85DD-5CF6C42D6EC3}"/>
+                <a16:creationId xmlns:a16="http://schemas.microsoft.com/office/drawing/2014/main" id="{F46B7924-D93F-4EEC-B8EE-7038BCACE9AC}"/>
               </a:ext>
             </a:extLst>
           </p:cNvPr>
@@ -33386,7 +33386,7 @@
           <p:cNvPr id="2" name="">
             <a:extLst xmlns:a="http://schemas.openxmlformats.org/drawingml/2006/main">
               <a:ext uri="{FF2B5EF4-FFF2-40B4-BE49-F238E27FC236}">
-                <a16:creationId xmlns:a16="http://schemas.microsoft.com/office/drawing/2014/main" id="{784EADD2-800A-4535-9FF1-0F51BB6B32ED}"/>
+                <a16:creationId xmlns:a16="http://schemas.microsoft.com/office/drawing/2014/main" id="{90BEC6B8-5B2E-4533-A839-399E1E9BF887}"/>
               </a:ext>
             </a:extLst>
           </p:cNvPr>
@@ -33542,7 +33542,7 @@
           <p:cNvPr id="3" name="">
             <a:extLst xmlns:a="http://schemas.openxmlformats.org/drawingml/2006/main">
               <a:ext uri="{FF2B5EF4-FFF2-40B4-BE49-F238E27FC236}">
-                <a16:creationId xmlns:a16="http://schemas.microsoft.com/office/drawing/2014/main" id="{0058E1AF-0B14-4D21-AE5A-06820C3BC0AC}"/>
+                <a16:creationId xmlns:a16="http://schemas.microsoft.com/office/drawing/2014/main" id="{A5FC15C9-421D-4114-88BE-BEAC2F8A1ECD}"/>
               </a:ext>
             </a:extLst>
           </p:cNvPr>
@@ -33698,7 +33698,7 @@
           <p:cNvPr id="4" name="">
             <a:extLst xmlns:a="http://schemas.openxmlformats.org/drawingml/2006/main">
               <a:ext uri="{FF2B5EF4-FFF2-40B4-BE49-F238E27FC236}">
-                <a16:creationId xmlns:a16="http://schemas.microsoft.com/office/drawing/2014/main" id="{921CF962-65C3-480D-A06C-8BB38F79012C}"/>
+                <a16:creationId xmlns:a16="http://schemas.microsoft.com/office/drawing/2014/main" id="{B7184C45-D146-4B8A-A56E-03D11F1E9A43}"/>
               </a:ext>
             </a:extLst>
           </p:cNvPr>
@@ -33854,7 +33854,7 @@
           <p:cNvPr id="5" name="">
             <a:extLst xmlns:a="http://schemas.openxmlformats.org/drawingml/2006/main">
               <a:ext uri="{FF2B5EF4-FFF2-40B4-BE49-F238E27FC236}">
-                <a16:creationId xmlns:a16="http://schemas.microsoft.com/office/drawing/2014/main" id="{2533338B-5A94-4F69-BC6A-B2E8E2AF2D23}"/>
+                <a16:creationId xmlns:a16="http://schemas.microsoft.com/office/drawing/2014/main" id="{1FDBE49D-8915-4A78-9B9A-2277E9370EBE}"/>
               </a:ext>
             </a:extLst>
           </p:cNvPr>
@@ -34008,7 +34008,7 @@
     </p:spTree>
     <p:extLst>
       <p:ext uri="{BB962C8B-B14F-4D97-AF65-F5344CB8AC3E}">
-        <p14:creationId xmlns:p14="http://schemas.microsoft.com/office/powerpoint/2010/main" val="525031751"/>
+        <p14:creationId xmlns:p14="http://schemas.microsoft.com/office/powerpoint/2010/main" val="1362014019"/>
       </p:ext>
     </p:extLst>
   </p:cSld>
@@ -34039,7 +34039,7 @@
           <p:cNvPr id="17" name="">
             <a:extLst xmlns:a="http://schemas.openxmlformats.org/drawingml/2006/main">
               <a:ext uri="{FF2B5EF4-FFF2-40B4-BE49-F238E27FC236}">
-                <a16:creationId xmlns:a16="http://schemas.microsoft.com/office/drawing/2014/main" id="{20EB0E42-2846-456B-8F2D-86BD8FECD762}"/>
+                <a16:creationId xmlns:a16="http://schemas.microsoft.com/office/drawing/2014/main" id="{3B79152E-E882-4FE8-BA2D-2F2FB1EBF48C}"/>
               </a:ext>
             </a:extLst>
           </p:cNvPr>
@@ -34195,7 +34195,7 @@
           <p:cNvPr id="2" name="">
             <a:extLst xmlns:a="http://schemas.openxmlformats.org/drawingml/2006/main">
               <a:ext uri="{FF2B5EF4-FFF2-40B4-BE49-F238E27FC236}">
-                <a16:creationId xmlns:a16="http://schemas.microsoft.com/office/drawing/2014/main" id="{45EF42AF-099E-4B9E-82D7-E1869CA8AFCE}"/>
+                <a16:creationId xmlns:a16="http://schemas.microsoft.com/office/drawing/2014/main" id="{30333710-BC92-4C8A-8604-5203919F58BF}"/>
               </a:ext>
             </a:extLst>
           </p:cNvPr>
@@ -34351,7 +34351,7 @@
           <p:cNvPr id="3" name="">
             <a:extLst xmlns:a="http://schemas.openxmlformats.org/drawingml/2006/main">
               <a:ext uri="{FF2B5EF4-FFF2-40B4-BE49-F238E27FC236}">
-                <a16:creationId xmlns:a16="http://schemas.microsoft.com/office/drawing/2014/main" id="{ECD3B915-3F37-4645-BA8E-3C64D9D0F15E}"/>
+                <a16:creationId xmlns:a16="http://schemas.microsoft.com/office/drawing/2014/main" id="{3B1006FB-2E32-487D-967B-B9EDCC9CF167}"/>
               </a:ext>
             </a:extLst>
           </p:cNvPr>
@@ -34507,7 +34507,7 @@
           <p:cNvPr id="4" name="">
             <a:extLst xmlns:a="http://schemas.openxmlformats.org/drawingml/2006/main">
               <a:ext uri="{FF2B5EF4-FFF2-40B4-BE49-F238E27FC236}">
-                <a16:creationId xmlns:a16="http://schemas.microsoft.com/office/drawing/2014/main" id="{7B8F1B78-2347-4089-A12F-3EC53BA30B7B}"/>
+                <a16:creationId xmlns:a16="http://schemas.microsoft.com/office/drawing/2014/main" id="{41D08727-2CF5-48BA-B892-34D36200A1A8}"/>
               </a:ext>
             </a:extLst>
           </p:cNvPr>
@@ -34663,7 +34663,7 @@
           <p:cNvPr id="5" name="">
             <a:extLst xmlns:a="http://schemas.openxmlformats.org/drawingml/2006/main">
               <a:ext uri="{FF2B5EF4-FFF2-40B4-BE49-F238E27FC236}">
-                <a16:creationId xmlns:a16="http://schemas.microsoft.com/office/drawing/2014/main" id="{ED93F738-2881-4BEC-B04A-9C2B48D459EF}"/>
+                <a16:creationId xmlns:a16="http://schemas.microsoft.com/office/drawing/2014/main" id="{A318CE3D-62A4-47BE-A8CC-A1339A795261}"/>
               </a:ext>
             </a:extLst>
           </p:cNvPr>
@@ -34693,7 +34693,7 @@
           <p:cNvPr id="6" name="">
             <a:extLst xmlns:a="http://schemas.openxmlformats.org/drawingml/2006/main">
               <a:ext uri="{FF2B5EF4-FFF2-40B4-BE49-F238E27FC236}">
-                <a16:creationId xmlns:a16="http://schemas.microsoft.com/office/drawing/2014/main" id="{059DC19C-F018-4D55-9705-E035BB3F7D04}"/>
+                <a16:creationId xmlns:a16="http://schemas.microsoft.com/office/drawing/2014/main" id="{A1684F36-1D6F-4FE6-BBDF-756A0FB8CCF6}"/>
               </a:ext>
             </a:extLst>
           </p:cNvPr>
@@ -34732,7 +34732,7 @@
           <p:cNvPr id="7" name="">
             <a:extLst xmlns:a="http://schemas.openxmlformats.org/drawingml/2006/main">
               <a:ext uri="{FF2B5EF4-FFF2-40B4-BE49-F238E27FC236}">
-                <a16:creationId xmlns:a16="http://schemas.microsoft.com/office/drawing/2014/main" id="{79C7CD71-9A09-4364-8CB8-B832DC66838F}"/>
+                <a16:creationId xmlns:a16="http://schemas.microsoft.com/office/drawing/2014/main" id="{51DE6AFF-B839-4ADF-ACF1-DDEAE9553BB3}"/>
               </a:ext>
             </a:extLst>
           </p:cNvPr>
@@ -34771,7 +34771,7 @@
           <p:cNvPr id="8" name="">
             <a:extLst xmlns:a="http://schemas.openxmlformats.org/drawingml/2006/main">
               <a:ext uri="{FF2B5EF4-FFF2-40B4-BE49-F238E27FC236}">
-                <a16:creationId xmlns:a16="http://schemas.microsoft.com/office/drawing/2014/main" id="{B76E34A9-4F80-4E28-8065-92389DC6EDDA}"/>
+                <a16:creationId xmlns:a16="http://schemas.microsoft.com/office/drawing/2014/main" id="{C417411B-D9F0-4138-AF1B-B59F8EF509B2}"/>
               </a:ext>
             </a:extLst>
           </p:cNvPr>
@@ -34810,7 +34810,7 @@
           <p:cNvPr id="9" name="">
             <a:extLst xmlns:a="http://schemas.openxmlformats.org/drawingml/2006/main">
               <a:ext uri="{FF2B5EF4-FFF2-40B4-BE49-F238E27FC236}">
-                <a16:creationId xmlns:a16="http://schemas.microsoft.com/office/drawing/2014/main" id="{9C07ACAE-EBE7-41DB-B409-5F551C35370A}"/>
+                <a16:creationId xmlns:a16="http://schemas.microsoft.com/office/drawing/2014/main" id="{C4645167-B377-4E99-A48A-B8E8B0F9C4ED}"/>
               </a:ext>
             </a:extLst>
           </p:cNvPr>
@@ -34849,7 +34849,7 @@
           <p:cNvPr id="10" name="">
             <a:extLst xmlns:a="http://schemas.openxmlformats.org/drawingml/2006/main">
               <a:ext uri="{FF2B5EF4-FFF2-40B4-BE49-F238E27FC236}">
-                <a16:creationId xmlns:a16="http://schemas.microsoft.com/office/drawing/2014/main" id="{89F9B3F3-BFE9-4555-BB77-C27CDBEBCEF4}"/>
+                <a16:creationId xmlns:a16="http://schemas.microsoft.com/office/drawing/2014/main" id="{9A1FA934-F2C4-476F-9AA8-E509001CCA9F}"/>
               </a:ext>
             </a:extLst>
           </p:cNvPr>
@@ -35005,7 +35005,7 @@
           <p:cNvPr id="11" name="">
             <a:extLst xmlns:a="http://schemas.openxmlformats.org/drawingml/2006/main">
               <a:ext uri="{FF2B5EF4-FFF2-40B4-BE49-F238E27FC236}">
-                <a16:creationId xmlns:a16="http://schemas.microsoft.com/office/drawing/2014/main" id="{028DF9EF-1CEF-4964-9AB8-41D6818241E6}"/>
+                <a16:creationId xmlns:a16="http://schemas.microsoft.com/office/drawing/2014/main" id="{B8EE1795-683D-48BA-9C07-71F1173D9833}"/>
               </a:ext>
             </a:extLst>
           </p:cNvPr>
@@ -35161,7 +35161,7 @@
           <p:cNvPr id="12" name="">
             <a:extLst xmlns:a="http://schemas.openxmlformats.org/drawingml/2006/main">
               <a:ext uri="{FF2B5EF4-FFF2-40B4-BE49-F238E27FC236}">
-                <a16:creationId xmlns:a16="http://schemas.microsoft.com/office/drawing/2014/main" id="{592F3D15-3C0F-471E-9852-E75DBF634517}"/>
+                <a16:creationId xmlns:a16="http://schemas.microsoft.com/office/drawing/2014/main" id="{7F5D8F44-270D-4833-8213-014AB3072F7D}"/>
               </a:ext>
             </a:extLst>
           </p:cNvPr>
@@ -35317,7 +35317,7 @@
           <p:cNvPr id="13" name="">
             <a:extLst xmlns:a="http://schemas.openxmlformats.org/drawingml/2006/main">
               <a:ext uri="{FF2B5EF4-FFF2-40B4-BE49-F238E27FC236}">
-                <a16:creationId xmlns:a16="http://schemas.microsoft.com/office/drawing/2014/main" id="{D3E8EAAE-7878-4581-8C88-A37E734A1A8A}"/>
+                <a16:creationId xmlns:a16="http://schemas.microsoft.com/office/drawing/2014/main" id="{0B10191F-7912-4856-963A-BD29CF1AAB30}"/>
               </a:ext>
             </a:extLst>
           </p:cNvPr>
@@ -35473,7 +35473,7 @@
           <p:cNvPr id="14" name="">
             <a:extLst xmlns:a="http://schemas.openxmlformats.org/drawingml/2006/main">
               <a:ext uri="{FF2B5EF4-FFF2-40B4-BE49-F238E27FC236}">
-                <a16:creationId xmlns:a16="http://schemas.microsoft.com/office/drawing/2014/main" id="{9096331F-82F4-4838-851E-E9494AE0BCE3}"/>
+                <a16:creationId xmlns:a16="http://schemas.microsoft.com/office/drawing/2014/main" id="{CFF64EB1-18CB-4905-B1C2-B36901DA34BE}"/>
               </a:ext>
             </a:extLst>
           </p:cNvPr>
@@ -35629,7 +35629,7 @@
           <p:cNvPr id="15" name="">
             <a:extLst xmlns:a="http://schemas.openxmlformats.org/drawingml/2006/main">
               <a:ext uri="{FF2B5EF4-FFF2-40B4-BE49-F238E27FC236}">
-                <a16:creationId xmlns:a16="http://schemas.microsoft.com/office/drawing/2014/main" id="{A5927E96-D131-4451-812C-AD83187C6479}"/>
+                <a16:creationId xmlns:a16="http://schemas.microsoft.com/office/drawing/2014/main" id="{F43CD682-EC94-452E-B373-45F8983060B3}"/>
               </a:ext>
             </a:extLst>
           </p:cNvPr>
@@ -35785,7 +35785,7 @@
           <p:cNvPr id="16" name="">
             <a:extLst xmlns:a="http://schemas.openxmlformats.org/drawingml/2006/main">
               <a:ext uri="{FF2B5EF4-FFF2-40B4-BE49-F238E27FC236}">
-                <a16:creationId xmlns:a16="http://schemas.microsoft.com/office/drawing/2014/main" id="{904EEC0A-28DE-4547-A116-93ED04227501}"/>
+                <a16:creationId xmlns:a16="http://schemas.microsoft.com/office/drawing/2014/main" id="{4E8A26F6-ED6A-44E7-A286-522002CCE7E8}"/>
               </a:ext>
             </a:extLst>
           </p:cNvPr>
@@ -35939,7 +35939,7 @@
     </p:spTree>
     <p:extLst>
       <p:ext uri="{BB962C8B-B14F-4D97-AF65-F5344CB8AC3E}">
-        <p14:creationId xmlns:p14="http://schemas.microsoft.com/office/powerpoint/2010/main" val="1260552562"/>
+        <p14:creationId xmlns:p14="http://schemas.microsoft.com/office/powerpoint/2010/main" val="482619448"/>
       </p:ext>
     </p:extLst>
   </p:cSld>
@@ -35970,7 +35970,7 @@
           <p:cNvPr id="18" name="">
             <a:extLst xmlns:a="http://schemas.openxmlformats.org/drawingml/2006/main">
               <a:ext uri="{FF2B5EF4-FFF2-40B4-BE49-F238E27FC236}">
-                <a16:creationId xmlns:a16="http://schemas.microsoft.com/office/drawing/2014/main" id="{B1113FDA-ADDC-40FF-A3B1-8F1FE8DC83DD}"/>
+                <a16:creationId xmlns:a16="http://schemas.microsoft.com/office/drawing/2014/main" id="{8E81EA9E-18BB-4FE7-927A-C79F59D68615}"/>
               </a:ext>
             </a:extLst>
           </p:cNvPr>
@@ -36126,7 +36126,7 @@
           <p:cNvPr id="2" name="">
             <a:extLst xmlns:a="http://schemas.openxmlformats.org/drawingml/2006/main">
               <a:ext uri="{FF2B5EF4-FFF2-40B4-BE49-F238E27FC236}">
-                <a16:creationId xmlns:a16="http://schemas.microsoft.com/office/drawing/2014/main" id="{C4D28C89-ED37-4557-B7EB-0DDC9D4221E3}"/>
+                <a16:creationId xmlns:a16="http://schemas.microsoft.com/office/drawing/2014/main" id="{FA609ADE-22CE-4D92-A9CA-1D568580729E}"/>
               </a:ext>
             </a:extLst>
           </p:cNvPr>
@@ -36282,7 +36282,7 @@
           <p:cNvPr id="3" name="">
             <a:extLst xmlns:a="http://schemas.openxmlformats.org/drawingml/2006/main">
               <a:ext uri="{FF2B5EF4-FFF2-40B4-BE49-F238E27FC236}">
-                <a16:creationId xmlns:a16="http://schemas.microsoft.com/office/drawing/2014/main" id="{18941221-5DA0-4DD4-AACC-311467655EF5}"/>
+                <a16:creationId xmlns:a16="http://schemas.microsoft.com/office/drawing/2014/main" id="{58E0842B-51DE-41DC-ADA1-63CD879ADD7A}"/>
               </a:ext>
             </a:extLst>
           </p:cNvPr>
@@ -36438,7 +36438,7 @@
           <p:cNvPr id="4" name="">
             <a:extLst xmlns:a="http://schemas.openxmlformats.org/drawingml/2006/main">
               <a:ext uri="{FF2B5EF4-FFF2-40B4-BE49-F238E27FC236}">
-                <a16:creationId xmlns:a16="http://schemas.microsoft.com/office/drawing/2014/main" id="{97E27FB7-FFEF-4E23-A850-5B018593D2B2}"/>
+                <a16:creationId xmlns:a16="http://schemas.microsoft.com/office/drawing/2014/main" id="{12126A47-A1B9-4BFE-861E-9C79C9BBD971}"/>
               </a:ext>
             </a:extLst>
           </p:cNvPr>
@@ -36594,7 +36594,7 @@
           <p:cNvPr id="5" name="">
             <a:extLst xmlns:a="http://schemas.openxmlformats.org/drawingml/2006/main">
               <a:ext uri="{FF2B5EF4-FFF2-40B4-BE49-F238E27FC236}">
-                <a16:creationId xmlns:a16="http://schemas.microsoft.com/office/drawing/2014/main" id="{9AA75EA6-C402-4FAC-9B2D-0675C52E935A}"/>
+                <a16:creationId xmlns:a16="http://schemas.microsoft.com/office/drawing/2014/main" id="{A445B8CB-2657-4A96-B24D-48EAC4F3F05B}"/>
               </a:ext>
             </a:extLst>
           </p:cNvPr>
@@ -36750,7 +36750,7 @@
           <p:cNvPr id="6" name="">
             <a:extLst xmlns:a="http://schemas.openxmlformats.org/drawingml/2006/main">
               <a:ext uri="{FF2B5EF4-FFF2-40B4-BE49-F238E27FC236}">
-                <a16:creationId xmlns:a16="http://schemas.microsoft.com/office/drawing/2014/main" id="{1872C1BD-75E9-4AD1-937C-D8D088401815}"/>
+                <a16:creationId xmlns:a16="http://schemas.microsoft.com/office/drawing/2014/main" id="{B4932CE2-A0E8-403B-85AC-628CF05930C3}"/>
               </a:ext>
             </a:extLst>
           </p:cNvPr>
@@ -36780,7 +36780,7 @@
           <p:cNvPr id="7" name="">
             <a:extLst xmlns:a="http://schemas.openxmlformats.org/drawingml/2006/main">
               <a:ext uri="{FF2B5EF4-FFF2-40B4-BE49-F238E27FC236}">
-                <a16:creationId xmlns:a16="http://schemas.microsoft.com/office/drawing/2014/main" id="{993A3251-3D03-4350-B595-63F1A92739EC}"/>
+                <a16:creationId xmlns:a16="http://schemas.microsoft.com/office/drawing/2014/main" id="{658D8E99-58FE-4AEE-91B4-28CE74F956EC}"/>
               </a:ext>
             </a:extLst>
           </p:cNvPr>
@@ -36819,7 +36819,7 @@
           <p:cNvPr id="8" name="">
             <a:extLst xmlns:a="http://schemas.openxmlformats.org/drawingml/2006/main">
               <a:ext uri="{FF2B5EF4-FFF2-40B4-BE49-F238E27FC236}">
-                <a16:creationId xmlns:a16="http://schemas.microsoft.com/office/drawing/2014/main" id="{A68611CC-6B0F-4219-90E3-D93F91A47606}"/>
+                <a16:creationId xmlns:a16="http://schemas.microsoft.com/office/drawing/2014/main" id="{EAD14726-BF66-4AA2-8F05-EFD13AFD21AA}"/>
               </a:ext>
             </a:extLst>
           </p:cNvPr>
@@ -36858,7 +36858,7 @@
           <p:cNvPr id="9" name="">
             <a:extLst xmlns:a="http://schemas.openxmlformats.org/drawingml/2006/main">
               <a:ext uri="{FF2B5EF4-FFF2-40B4-BE49-F238E27FC236}">
-                <a16:creationId xmlns:a16="http://schemas.microsoft.com/office/drawing/2014/main" id="{190C01B6-FA42-4028-AAA1-6863BD3FE309}"/>
+                <a16:creationId xmlns:a16="http://schemas.microsoft.com/office/drawing/2014/main" id="{05362F72-8970-4B17-8C64-2E4828329160}"/>
               </a:ext>
             </a:extLst>
           </p:cNvPr>
@@ -36897,7 +36897,7 @@
           <p:cNvPr id="10" name="">
             <a:extLst xmlns:a="http://schemas.openxmlformats.org/drawingml/2006/main">
               <a:ext uri="{FF2B5EF4-FFF2-40B4-BE49-F238E27FC236}">
-                <a16:creationId xmlns:a16="http://schemas.microsoft.com/office/drawing/2014/main" id="{22190E3B-8D7A-489C-BB46-47384109DB2D}"/>
+                <a16:creationId xmlns:a16="http://schemas.microsoft.com/office/drawing/2014/main" id="{32FA19E0-5B7D-4C0A-8CB0-B9ABCEFB6CE5}"/>
               </a:ext>
             </a:extLst>
           </p:cNvPr>
@@ -36936,7 +36936,7 @@
           <p:cNvPr id="11" name="">
             <a:extLst xmlns:a="http://schemas.openxmlformats.org/drawingml/2006/main">
               <a:ext uri="{FF2B5EF4-FFF2-40B4-BE49-F238E27FC236}">
-                <a16:creationId xmlns:a16="http://schemas.microsoft.com/office/drawing/2014/main" id="{7BDC2702-B62A-46BC-9395-76C587106E03}"/>
+                <a16:creationId xmlns:a16="http://schemas.microsoft.com/office/drawing/2014/main" id="{C19F7901-D65C-4ED1-A98A-0C7B325F04C9}"/>
               </a:ext>
             </a:extLst>
           </p:cNvPr>
@@ -37092,7 +37092,7 @@
           <p:cNvPr id="12" name="">
             <a:extLst xmlns:a="http://schemas.openxmlformats.org/drawingml/2006/main">
               <a:ext uri="{FF2B5EF4-FFF2-40B4-BE49-F238E27FC236}">
-                <a16:creationId xmlns:a16="http://schemas.microsoft.com/office/drawing/2014/main" id="{6622C513-877C-4A5A-BC16-A75DC42230F0}"/>
+                <a16:creationId xmlns:a16="http://schemas.microsoft.com/office/drawing/2014/main" id="{C55B85E0-040D-497E-95D3-403E2B78724B}"/>
               </a:ext>
             </a:extLst>
           </p:cNvPr>
@@ -37248,7 +37248,7 @@
           <p:cNvPr id="13" name="">
             <a:extLst xmlns:a="http://schemas.openxmlformats.org/drawingml/2006/main">
               <a:ext uri="{FF2B5EF4-FFF2-40B4-BE49-F238E27FC236}">
-                <a16:creationId xmlns:a16="http://schemas.microsoft.com/office/drawing/2014/main" id="{03E0C0E2-0FCC-42E0-87F9-447C3BC2D9B6}"/>
+                <a16:creationId xmlns:a16="http://schemas.microsoft.com/office/drawing/2014/main" id="{A51185AC-C62B-4F0A-B3D9-7E4C6D4EA3F4}"/>
               </a:ext>
             </a:extLst>
           </p:cNvPr>
@@ -37404,7 +37404,7 @@
           <p:cNvPr id="14" name="">
             <a:extLst xmlns:a="http://schemas.openxmlformats.org/drawingml/2006/main">
               <a:ext uri="{FF2B5EF4-FFF2-40B4-BE49-F238E27FC236}">
-                <a16:creationId xmlns:a16="http://schemas.microsoft.com/office/drawing/2014/main" id="{9256B3AE-CAB2-49C3-AE01-3FB21CEB1C22}"/>
+                <a16:creationId xmlns:a16="http://schemas.microsoft.com/office/drawing/2014/main" id="{5CABF333-E040-4BFA-86F0-1CF0DBE263BE}"/>
               </a:ext>
             </a:extLst>
           </p:cNvPr>
@@ -37560,7 +37560,7 @@
           <p:cNvPr id="15" name="">
             <a:extLst xmlns:a="http://schemas.openxmlformats.org/drawingml/2006/main">
               <a:ext uri="{FF2B5EF4-FFF2-40B4-BE49-F238E27FC236}">
-                <a16:creationId xmlns:a16="http://schemas.microsoft.com/office/drawing/2014/main" id="{BC8E1742-BB97-45F4-8AAE-C0920B6A17B0}"/>
+                <a16:creationId xmlns:a16="http://schemas.microsoft.com/office/drawing/2014/main" id="{981859F1-F9D0-483F-B9E0-236C8922D8D0}"/>
               </a:ext>
             </a:extLst>
           </p:cNvPr>
@@ -37716,7 +37716,7 @@
           <p:cNvPr id="16" name="">
             <a:extLst xmlns:a="http://schemas.openxmlformats.org/drawingml/2006/main">
               <a:ext uri="{FF2B5EF4-FFF2-40B4-BE49-F238E27FC236}">
-                <a16:creationId xmlns:a16="http://schemas.microsoft.com/office/drawing/2014/main" id="{A583C37E-D9DF-491C-87B4-B4310D053AD3}"/>
+                <a16:creationId xmlns:a16="http://schemas.microsoft.com/office/drawing/2014/main" id="{8F3775AF-08A1-4B50-8576-A00A7E5805EA}"/>
               </a:ext>
             </a:extLst>
           </p:cNvPr>
@@ -37872,7 +37872,7 @@
           <p:cNvPr id="17" name="">
             <a:extLst xmlns:a="http://schemas.openxmlformats.org/drawingml/2006/main">
               <a:ext uri="{FF2B5EF4-FFF2-40B4-BE49-F238E27FC236}">
-                <a16:creationId xmlns:a16="http://schemas.microsoft.com/office/drawing/2014/main" id="{92755655-5B8E-4633-9396-ABDDEC20F09F}"/>
+                <a16:creationId xmlns:a16="http://schemas.microsoft.com/office/drawing/2014/main" id="{D846B191-309D-4C47-B375-C52036A15A72}"/>
               </a:ext>
             </a:extLst>
           </p:cNvPr>
@@ -38026,7 +38026,7 @@
     </p:spTree>
     <p:extLst>
       <p:ext uri="{BB962C8B-B14F-4D97-AF65-F5344CB8AC3E}">
-        <p14:creationId xmlns:p14="http://schemas.microsoft.com/office/powerpoint/2010/main" val="2039785136"/>
+        <p14:creationId xmlns:p14="http://schemas.microsoft.com/office/powerpoint/2010/main" val="1894288175"/>
       </p:ext>
     </p:extLst>
   </p:cSld>
@@ -38057,7 +38057,7 @@
           <p:cNvPr id="13" name="">
             <a:extLst xmlns:a="http://schemas.openxmlformats.org/drawingml/2006/main">
               <a:ext uri="{FF2B5EF4-FFF2-40B4-BE49-F238E27FC236}">
-                <a16:creationId xmlns:a16="http://schemas.microsoft.com/office/drawing/2014/main" id="{06EB1B1D-8513-4181-B38A-04C5287CCC82}"/>
+                <a16:creationId xmlns:a16="http://schemas.microsoft.com/office/drawing/2014/main" id="{EA88766A-C01B-42C4-A755-DF20B1A9BE93}"/>
               </a:ext>
             </a:extLst>
           </p:cNvPr>
@@ -38213,7 +38213,7 @@
           <p:cNvPr id="2" name="">
             <a:extLst xmlns:a="http://schemas.openxmlformats.org/drawingml/2006/main">
               <a:ext uri="{FF2B5EF4-FFF2-40B4-BE49-F238E27FC236}">
-                <a16:creationId xmlns:a16="http://schemas.microsoft.com/office/drawing/2014/main" id="{0F175A73-B560-42B9-B169-31CCBEEE2BB3}"/>
+                <a16:creationId xmlns:a16="http://schemas.microsoft.com/office/drawing/2014/main" id="{2AA88EFB-6DD2-4A63-80C9-86022C9A1D0A}"/>
               </a:ext>
             </a:extLst>
           </p:cNvPr>
@@ -38369,7 +38369,7 @@
           <p:cNvPr id="3" name="">
             <a:extLst xmlns:a="http://schemas.openxmlformats.org/drawingml/2006/main">
               <a:ext uri="{FF2B5EF4-FFF2-40B4-BE49-F238E27FC236}">
-                <a16:creationId xmlns:a16="http://schemas.microsoft.com/office/drawing/2014/main" id="{835F7CC7-C12B-42B5-9A48-106A8E3C011F}"/>
+                <a16:creationId xmlns:a16="http://schemas.microsoft.com/office/drawing/2014/main" id="{87E11EA4-D61F-4DFF-8C44-58C9DE47D951}"/>
               </a:ext>
             </a:extLst>
           </p:cNvPr>
@@ -38525,7 +38525,7 @@
           <p:cNvPr id="4" name="">
             <a:extLst xmlns:a="http://schemas.openxmlformats.org/drawingml/2006/main">
               <a:ext uri="{FF2B5EF4-FFF2-40B4-BE49-F238E27FC236}">
-                <a16:creationId xmlns:a16="http://schemas.microsoft.com/office/drawing/2014/main" id="{C2B0FC50-32A8-4DE3-9BC1-1D51AF51CCD5}"/>
+                <a16:creationId xmlns:a16="http://schemas.microsoft.com/office/drawing/2014/main" id="{2FAB27EF-4705-4741-B11B-5AFC1D30EB91}"/>
               </a:ext>
             </a:extLst>
           </p:cNvPr>
@@ -38555,7 +38555,7 @@
           <p:cNvPr id="5" name="">
             <a:extLst xmlns:a="http://schemas.openxmlformats.org/drawingml/2006/main">
               <a:ext uri="{FF2B5EF4-FFF2-40B4-BE49-F238E27FC236}">
-                <a16:creationId xmlns:a16="http://schemas.microsoft.com/office/drawing/2014/main" id="{DDEDD2FF-5EBF-46F0-8115-A5CAEE96C190}"/>
+                <a16:creationId xmlns:a16="http://schemas.microsoft.com/office/drawing/2014/main" id="{7C92938D-8032-4DD4-9B42-47DB67396C49}"/>
               </a:ext>
             </a:extLst>
           </p:cNvPr>
@@ -38600,7 +38600,7 @@
           <p:cNvPr id="6" name="">
             <a:extLst xmlns:a="http://schemas.openxmlformats.org/drawingml/2006/main">
               <a:ext uri="{FF2B5EF4-FFF2-40B4-BE49-F238E27FC236}">
-                <a16:creationId xmlns:a16="http://schemas.microsoft.com/office/drawing/2014/main" id="{2A642160-D08E-4427-A95F-0ED88A8CFD9B}"/>
+                <a16:creationId xmlns:a16="http://schemas.microsoft.com/office/drawing/2014/main" id="{831EB2B8-AB45-45E4-A201-92CAAC027177}"/>
               </a:ext>
             </a:extLst>
           </p:cNvPr>
@@ -38756,7 +38756,7 @@
           <p:cNvPr id="7" name="">
             <a:extLst xmlns:a="http://schemas.openxmlformats.org/drawingml/2006/main">
               <a:ext uri="{FF2B5EF4-FFF2-40B4-BE49-F238E27FC236}">
-                <a16:creationId xmlns:a16="http://schemas.microsoft.com/office/drawing/2014/main" id="{979E083F-9E3C-4FC5-B251-D356D67D33DD}"/>
+                <a16:creationId xmlns:a16="http://schemas.microsoft.com/office/drawing/2014/main" id="{D6B368CF-6F87-4546-8F5A-0C7C22F46118}"/>
               </a:ext>
             </a:extLst>
           </p:cNvPr>
@@ -38912,7 +38912,7 @@
           <p:cNvPr id="8" name="">
             <a:extLst xmlns:a="http://schemas.openxmlformats.org/drawingml/2006/main">
               <a:ext uri="{FF2B5EF4-FFF2-40B4-BE49-F238E27FC236}">
-                <a16:creationId xmlns:a16="http://schemas.microsoft.com/office/drawing/2014/main" id="{4CB265B1-F67C-440B-89BF-FDF67C192438}"/>
+                <a16:creationId xmlns:a16="http://schemas.microsoft.com/office/drawing/2014/main" id="{82EBC531-F0AD-491F-B1CF-05D05F49FA94}"/>
               </a:ext>
             </a:extLst>
           </p:cNvPr>
@@ -39068,7 +39068,7 @@
           <p:cNvPr id="9" name="">
             <a:extLst xmlns:a="http://schemas.openxmlformats.org/drawingml/2006/main">
               <a:ext uri="{FF2B5EF4-FFF2-40B4-BE49-F238E27FC236}">
-                <a16:creationId xmlns:a16="http://schemas.microsoft.com/office/drawing/2014/main" id="{1DE553C2-7A73-4FE5-96BA-E9633B4E0E41}"/>
+                <a16:creationId xmlns:a16="http://schemas.microsoft.com/office/drawing/2014/main" id="{D8326F06-D092-43B3-8593-BE92BC636CD9}"/>
               </a:ext>
             </a:extLst>
           </p:cNvPr>
@@ -39224,7 +39224,7 @@
           <p:cNvPr id="10" name="">
             <a:extLst xmlns:a="http://schemas.openxmlformats.org/drawingml/2006/main">
               <a:ext uri="{FF2B5EF4-FFF2-40B4-BE49-F238E27FC236}">
-                <a16:creationId xmlns:a16="http://schemas.microsoft.com/office/drawing/2014/main" id="{35D25793-44A7-406C-9764-B4A200CF3A0E}"/>
+                <a16:creationId xmlns:a16="http://schemas.microsoft.com/office/drawing/2014/main" id="{AE08DE4F-AF0A-4DA3-9BC3-1FADCDFA8094}"/>
               </a:ext>
             </a:extLst>
           </p:cNvPr>
@@ -39380,7 +39380,7 @@
           <p:cNvPr id="11" name="">
             <a:extLst xmlns:a="http://schemas.openxmlformats.org/drawingml/2006/main">
               <a:ext uri="{FF2B5EF4-FFF2-40B4-BE49-F238E27FC236}">
-                <a16:creationId xmlns:a16="http://schemas.microsoft.com/office/drawing/2014/main" id="{07ACEE92-B4BE-4FEF-8D2D-5F2B581B867A}"/>
+                <a16:creationId xmlns:a16="http://schemas.microsoft.com/office/drawing/2014/main" id="{8373AE1B-28D6-48D3-8EC5-DCCB2E0C150D}"/>
               </a:ext>
             </a:extLst>
           </p:cNvPr>
@@ -39536,7 +39536,7 @@
           <p:cNvPr id="12" name="">
             <a:extLst xmlns:a="http://schemas.openxmlformats.org/drawingml/2006/main">
               <a:ext uri="{FF2B5EF4-FFF2-40B4-BE49-F238E27FC236}">
-                <a16:creationId xmlns:a16="http://schemas.microsoft.com/office/drawing/2014/main" id="{78161B7F-F2C6-43FF-8AAA-4E22D0BB22CF}"/>
+                <a16:creationId xmlns:a16="http://schemas.microsoft.com/office/drawing/2014/main" id="{42AFC0BD-2A37-40DC-A42D-EA84F5F8FC0B}"/>
               </a:ext>
             </a:extLst>
           </p:cNvPr>
@@ -39690,7 +39690,7 @@
     </p:spTree>
     <p:extLst>
       <p:ext uri="{BB962C8B-B14F-4D97-AF65-F5344CB8AC3E}">
-        <p14:creationId xmlns:p14="http://schemas.microsoft.com/office/powerpoint/2010/main" val="547236132"/>
+        <p14:creationId xmlns:p14="http://schemas.microsoft.com/office/powerpoint/2010/main" val="1328322629"/>
       </p:ext>
     </p:extLst>
   </p:cSld>
@@ -39721,7 +39721,7 @@
           <p:cNvPr id="6" name="">
             <a:extLst xmlns:a="http://schemas.openxmlformats.org/drawingml/2006/main">
               <a:ext uri="{FF2B5EF4-FFF2-40B4-BE49-F238E27FC236}">
-                <a16:creationId xmlns:a16="http://schemas.microsoft.com/office/drawing/2014/main" id="{9C179D99-29F2-4765-BB2B-958E4E690F46}"/>
+                <a16:creationId xmlns:a16="http://schemas.microsoft.com/office/drawing/2014/main" id="{D358E579-CC2B-4C78-B8D4-37AFDC5B8F93}"/>
               </a:ext>
             </a:extLst>
           </p:cNvPr>
@@ -39877,7 +39877,7 @@
           <p:cNvPr id="2" name="">
             <a:extLst xmlns:a="http://schemas.openxmlformats.org/drawingml/2006/main">
               <a:ext uri="{FF2B5EF4-FFF2-40B4-BE49-F238E27FC236}">
-                <a16:creationId xmlns:a16="http://schemas.microsoft.com/office/drawing/2014/main" id="{E01B63BA-C4E1-48F0-A480-3CBFF4B8C7AC}"/>
+                <a16:creationId xmlns:a16="http://schemas.microsoft.com/office/drawing/2014/main" id="{AF1B269C-A990-4793-AE36-5118B6B34851}"/>
               </a:ext>
             </a:extLst>
           </p:cNvPr>
@@ -40033,7 +40033,7 @@
           <p:cNvPr id="3" name="">
             <a:extLst xmlns:a="http://schemas.openxmlformats.org/drawingml/2006/main">
               <a:ext uri="{FF2B5EF4-FFF2-40B4-BE49-F238E27FC236}">
-                <a16:creationId xmlns:a16="http://schemas.microsoft.com/office/drawing/2014/main" id="{AC0F1115-87B2-4F8B-AC80-4CAFE3B77FC3}"/>
+                <a16:creationId xmlns:a16="http://schemas.microsoft.com/office/drawing/2014/main" id="{DE981E9B-85AB-4223-BEEF-B9124D4E5042}"/>
               </a:ext>
             </a:extLst>
           </p:cNvPr>
@@ -40189,7 +40189,7 @@
           <p:cNvPr id="4" name="">
             <a:extLst xmlns:a="http://schemas.openxmlformats.org/drawingml/2006/main">
               <a:ext uri="{FF2B5EF4-FFF2-40B4-BE49-F238E27FC236}">
-                <a16:creationId xmlns:a16="http://schemas.microsoft.com/office/drawing/2014/main" id="{D26A919F-E9A6-4710-A883-E0E8C7997FA0}"/>
+                <a16:creationId xmlns:a16="http://schemas.microsoft.com/office/drawing/2014/main" id="{D36377F3-3DFC-41A7-BB95-CAA556F871BD}"/>
               </a:ext>
             </a:extLst>
           </p:cNvPr>
@@ -40345,7 +40345,7 @@
           <p:cNvPr id="5" name="">
             <a:extLst xmlns:a="http://schemas.openxmlformats.org/drawingml/2006/main">
               <a:ext uri="{FF2B5EF4-FFF2-40B4-BE49-F238E27FC236}">
-                <a16:creationId xmlns:a16="http://schemas.microsoft.com/office/drawing/2014/main" id="{686390DA-F62A-485A-89C0-BF9590069BE5}"/>
+                <a16:creationId xmlns:a16="http://schemas.microsoft.com/office/drawing/2014/main" id="{AC369A8C-587A-45AF-B2B9-8A90A2623B54}"/>
               </a:ext>
             </a:extLst>
           </p:cNvPr>
@@ -40499,7 +40499,7 @@
     </p:spTree>
     <p:extLst>
       <p:ext uri="{BB962C8B-B14F-4D97-AF65-F5344CB8AC3E}">
-        <p14:creationId xmlns:p14="http://schemas.microsoft.com/office/powerpoint/2010/main" val="904927449"/>
+        <p14:creationId xmlns:p14="http://schemas.microsoft.com/office/powerpoint/2010/main" val="2084923014"/>
       </p:ext>
     </p:extLst>
   </p:cSld>
@@ -40530,7 +40530,7 @@
           <p:cNvPr id="6" name="">
             <a:extLst xmlns:a="http://schemas.openxmlformats.org/drawingml/2006/main">
               <a:ext uri="{FF2B5EF4-FFF2-40B4-BE49-F238E27FC236}">
-                <a16:creationId xmlns:a16="http://schemas.microsoft.com/office/drawing/2014/main" id="{4DA1DF5C-0CF4-4502-B7BD-12F0B5F7D06C}"/>
+                <a16:creationId xmlns:a16="http://schemas.microsoft.com/office/drawing/2014/main" id="{BA91066E-E45E-4EBE-AA21-10DAEC4A2A69}"/>
               </a:ext>
             </a:extLst>
           </p:cNvPr>
@@ -40686,7 +40686,7 @@
           <p:cNvPr id="2" name="">
             <a:extLst xmlns:a="http://schemas.openxmlformats.org/drawingml/2006/main">
               <a:ext uri="{FF2B5EF4-FFF2-40B4-BE49-F238E27FC236}">
-                <a16:creationId xmlns:a16="http://schemas.microsoft.com/office/drawing/2014/main" id="{6ECF0552-C92E-4845-AB8A-C262F83A6691}"/>
+                <a16:creationId xmlns:a16="http://schemas.microsoft.com/office/drawing/2014/main" id="{09DA442A-796B-4778-A371-DAE1AD2814E3}"/>
               </a:ext>
             </a:extLst>
           </p:cNvPr>
@@ -40842,7 +40842,7 @@
           <p:cNvPr id="3" name="">
             <a:extLst xmlns:a="http://schemas.openxmlformats.org/drawingml/2006/main">
               <a:ext uri="{FF2B5EF4-FFF2-40B4-BE49-F238E27FC236}">
-                <a16:creationId xmlns:a16="http://schemas.microsoft.com/office/drawing/2014/main" id="{5B2B17CD-E925-4242-BCB5-E28A49A72774}"/>
+                <a16:creationId xmlns:a16="http://schemas.microsoft.com/office/drawing/2014/main" id="{769A4514-40A0-4154-B394-874CFA369425}"/>
               </a:ext>
             </a:extLst>
           </p:cNvPr>
@@ -40998,7 +40998,7 @@
           <p:cNvPr id="4" name="">
             <a:extLst xmlns:a="http://schemas.openxmlformats.org/drawingml/2006/main">
               <a:ext uri="{FF2B5EF4-FFF2-40B4-BE49-F238E27FC236}">
-                <a16:creationId xmlns:a16="http://schemas.microsoft.com/office/drawing/2014/main" id="{BF0B9030-22AD-48E2-9AA8-96E7631B1CC9}"/>
+                <a16:creationId xmlns:a16="http://schemas.microsoft.com/office/drawing/2014/main" id="{1C38AE6F-FFC2-4D9A-9A16-40A7DD4F07B0}"/>
               </a:ext>
             </a:extLst>
           </p:cNvPr>
@@ -41154,7 +41154,7 @@
           <p:cNvPr id="5" name="">
             <a:extLst xmlns:a="http://schemas.openxmlformats.org/drawingml/2006/main">
               <a:ext uri="{FF2B5EF4-FFF2-40B4-BE49-F238E27FC236}">
-                <a16:creationId xmlns:a16="http://schemas.microsoft.com/office/drawing/2014/main" id="{879048A7-47E3-4F8A-9604-02592D68B347}"/>
+                <a16:creationId xmlns:a16="http://schemas.microsoft.com/office/drawing/2014/main" id="{AEA23DC7-3D72-4514-9D4F-98E69A6ADEF8}"/>
               </a:ext>
             </a:extLst>
           </p:cNvPr>
@@ -41308,7 +41308,7 @@
     </p:spTree>
     <p:extLst>
       <p:ext uri="{BB962C8B-B14F-4D97-AF65-F5344CB8AC3E}">
-        <p14:creationId xmlns:p14="http://schemas.microsoft.com/office/powerpoint/2010/main" val="1925875150"/>
+        <p14:creationId xmlns:p14="http://schemas.microsoft.com/office/powerpoint/2010/main" val="275983942"/>
       </p:ext>
     </p:extLst>
   </p:cSld>
@@ -41339,7 +41339,7 @@
           <p:cNvPr id="6" name="">
             <a:extLst xmlns:a="http://schemas.openxmlformats.org/drawingml/2006/main">
               <a:ext uri="{FF2B5EF4-FFF2-40B4-BE49-F238E27FC236}">
-                <a16:creationId xmlns:a16="http://schemas.microsoft.com/office/drawing/2014/main" id="{7E83C7E1-591F-4655-BCAF-DDB110B412DD}"/>
+                <a16:creationId xmlns:a16="http://schemas.microsoft.com/office/drawing/2014/main" id="{0E143030-BC1E-4705-989C-BD8B0499BE9E}"/>
               </a:ext>
             </a:extLst>
           </p:cNvPr>
@@ -41495,7 +41495,7 @@
           <p:cNvPr id="2" name="">
             <a:extLst xmlns:a="http://schemas.openxmlformats.org/drawingml/2006/main">
               <a:ext uri="{FF2B5EF4-FFF2-40B4-BE49-F238E27FC236}">
-                <a16:creationId xmlns:a16="http://schemas.microsoft.com/office/drawing/2014/main" id="{A89F8382-05AE-4AFD-9A12-673AA751BABA}"/>
+                <a16:creationId xmlns:a16="http://schemas.microsoft.com/office/drawing/2014/main" id="{37D5EBFC-4571-48D9-B24C-75C88E42DEF9}"/>
               </a:ext>
             </a:extLst>
           </p:cNvPr>
@@ -41651,7 +41651,7 @@
           <p:cNvPr id="3" name="">
             <a:extLst xmlns:a="http://schemas.openxmlformats.org/drawingml/2006/main">
               <a:ext uri="{FF2B5EF4-FFF2-40B4-BE49-F238E27FC236}">
-                <a16:creationId xmlns:a16="http://schemas.microsoft.com/office/drawing/2014/main" id="{B8F6F7F0-722F-4A8C-88DE-BD3BEA017635}"/>
+                <a16:creationId xmlns:a16="http://schemas.microsoft.com/office/drawing/2014/main" id="{A43C49BD-2ED3-4C96-B7C6-103C6D8A7499}"/>
               </a:ext>
             </a:extLst>
           </p:cNvPr>
@@ -41807,7 +41807,7 @@
           <p:cNvPr id="4" name="">
             <a:extLst xmlns:a="http://schemas.openxmlformats.org/drawingml/2006/main">
               <a:ext uri="{FF2B5EF4-FFF2-40B4-BE49-F238E27FC236}">
-                <a16:creationId xmlns:a16="http://schemas.microsoft.com/office/drawing/2014/main" id="{94CD6EDF-D6AB-4C18-9B11-66C448B6F38A}"/>
+                <a16:creationId xmlns:a16="http://schemas.microsoft.com/office/drawing/2014/main" id="{4E59FB0D-B9C1-4166-9191-185C30894086}"/>
               </a:ext>
             </a:extLst>
           </p:cNvPr>
@@ -41963,7 +41963,7 @@
           <p:cNvPr id="5" name="">
             <a:extLst xmlns:a="http://schemas.openxmlformats.org/drawingml/2006/main">
               <a:ext uri="{FF2B5EF4-FFF2-40B4-BE49-F238E27FC236}">
-                <a16:creationId xmlns:a16="http://schemas.microsoft.com/office/drawing/2014/main" id="{7881B72B-C70D-41D0-905A-4B77D9262C58}"/>
+                <a16:creationId xmlns:a16="http://schemas.microsoft.com/office/drawing/2014/main" id="{11B8EB3E-A0C8-4B1B-A8A4-4BFEB062C526}"/>
               </a:ext>
             </a:extLst>
           </p:cNvPr>
@@ -42117,7 +42117,7 @@
     </p:spTree>
     <p:extLst>
       <p:ext uri="{BB962C8B-B14F-4D97-AF65-F5344CB8AC3E}">
-        <p14:creationId xmlns:p14="http://schemas.microsoft.com/office/powerpoint/2010/main" val="503901874"/>
+        <p14:creationId xmlns:p14="http://schemas.microsoft.com/office/powerpoint/2010/main" val="868716479"/>
       </p:ext>
     </p:extLst>
   </p:cSld>

</xml_diff>